<commit_message>
docs: synchronize documentation for software testing deliverables and simulation metrics
- Add PPTX presentation decks and generator scripts to root, docs/, and scripts/ directory indexes.

- Update root README simulation metrics with verified 90-day backtest and inventory simulation values.

- Document 51 automated offline tests (Flutter + FastAPI) and Gemini 3 Flash model integration.

- Ignore MS Office temporary lock files (~$*) in .gitignore.
</commit_message>
<xml_diff>
--- a/docs/software_testing_10slides.pptx
+++ b/docs/software_testing_10slides.pptx
@@ -4,9 +4,6 @@
   <p:sldMasterIdLst>
     <p:sldMasterId id="2147483648" r:id="rId1"/>
   </p:sldMasterIdLst>
-  <p:notesMasterIdLst>
-    <p:notesMasterId r:id="rId12"/>
-  </p:notesMasterIdLst>
   <p:sldIdLst>
     <p:sldId id="256" r:id="rId2"/>
     <p:sldId id="257" r:id="rId3"/>
@@ -19,6 +16,9 @@
     <p:sldId id="264" r:id="rId10"/>
     <p:sldId id="265" r:id="rId11"/>
   </p:sldIdLst>
+  <p:notesMasterIdLst>
+    <p:notesMasterId r:id="rId12"/>
+  </p:notesMasterIdLst>
   <p:sldSz cx="12192000" cy="6858000"/>
   <p:notesSz cx="6858000" cy="12192000"/>
   <p:defaultTextStyle>
@@ -113,20 +113,13 @@
       </a:defRPr>
     </a:lvl9pPr>
   </p:defaultTextStyle>
-  <p:extLst>
-    <p:ext uri="{EFAFB233-063F-42B5-8137-9DF3F51BA10A}">
-      <p15:sldGuideLst xmlns:p15="http://schemas.microsoft.com/office/powerpoint/2012/main"/>
-    </p:ext>
-  </p:extLst>
 </p:presentation>
 </file>
 
 <file path=ppt/charts/chart1.xml><?xml version="1.0" encoding="utf-8"?>
-<c:chartSpace xmlns:c="http://schemas.openxmlformats.org/drawingml/2006/chart" xmlns:a="http://schemas.openxmlformats.org/drawingml/2006/main" xmlns:r="http://schemas.openxmlformats.org/officeDocument/2006/relationships" xmlns:c16r2="http://schemas.microsoft.com/office/drawing/2015/06/chart">
+<c:chartSpace xmlns:c="http://schemas.openxmlformats.org/drawingml/2006/chart" xmlns:a="http://schemas.openxmlformats.org/drawingml/2006/main" xmlns:r="http://schemas.openxmlformats.org/officeDocument/2006/relationships">
   <c:date1904 val="0"/>
-  <c:lang val="en-US"/>
   <c:roundedCorners val="1"/>
-  <c:style val="2"/>
   <c:chart>
     <c:autoTitleDeleted val="1"/>
     <c:plotArea>
@@ -158,26 +151,18 @@
           <c:invertIfNegative val="0"/>
           <c:dLbls>
             <c:numFmt formatCode="#,##0" sourceLinked="0"/>
-            <c:spPr>
-              <a:noFill/>
-              <a:ln>
-                <a:noFill/>
-              </a:ln>
-              <a:effectLst/>
-            </c:spPr>
             <c:txPr>
               <a:bodyPr/>
               <a:lstStyle/>
               <a:p>
                 <a:pPr>
-                  <a:defRPr sz="1300" b="0" i="0" u="none" strike="noStrike">
+                  <a:defRPr b="0" i="0" strike="noStrike" sz="1300" u="none">
                     <a:solidFill>
                       <a:srgbClr val="000000"/>
                     </a:solidFill>
                     <a:latin typeface="Arial"/>
                   </a:defRPr>
                 </a:pPr>
-                <a:endParaRPr lang="en-US"/>
               </a:p>
             </c:txPr>
             <c:showLegendKey val="0"/>
@@ -187,37 +172,34 @@
             <c:showPercent val="0"/>
             <c:showBubbleSize val="0"/>
             <c:showLeaderLines val="0"/>
-            <c:extLst>
-              <c:ext xmlns:c15="http://schemas.microsoft.com/office/drawing/2012/chart" uri="{CE6537A1-D6FC-4f65-9D91-7224C49458BB}">
-                <c15:showLeaderLines val="0"/>
-              </c:ext>
-            </c:extLst>
           </c:dLbls>
           <c:cat>
-            <c:strRef>
+            <c:multiLvlStrRef>
               <c:f>Sheet1!$A$2:$A$7</c:f>
-              <c:strCache>
+              <c:multiLvlStrCache>
                 <c:ptCount val="6"/>
-                <c:pt idx="0">
-                  <c:v>Prophet</c:v>
-                </c:pt>
-                <c:pt idx="1">
-                  <c:v>Hybrid</c:v>
-                </c:pt>
-                <c:pt idx="2">
-                  <c:v>GBDT</c:v>
-                </c:pt>
-                <c:pt idx="3">
-                  <c:v>MA 7d</c:v>
-                </c:pt>
-                <c:pt idx="4">
-                  <c:v>SNaive</c:v>
-                </c:pt>
-                <c:pt idx="5">
-                  <c:v>Wkday4W</c:v>
-                </c:pt>
-              </c:strCache>
-            </c:strRef>
+                <c:lvl>
+                  <c:pt idx="0">
+                    <c:v>Prophet</c:v>
+                  </c:pt>
+                  <c:pt idx="1">
+                    <c:v>Hybrid</c:v>
+                  </c:pt>
+                  <c:pt idx="2">
+                    <c:v>GBDT</c:v>
+                  </c:pt>
+                  <c:pt idx="3">
+                    <c:v>MA 7d</c:v>
+                  </c:pt>
+                  <c:pt idx="4">
+                    <c:v>SNaive</c:v>
+                  </c:pt>
+                  <c:pt idx="5">
+                    <c:v>Wkday4W</c:v>
+                  </c:pt>
+                </c:lvl>
+              </c:multiLvlStrCache>
+            </c:multiLvlStrRef>
           </c:cat>
           <c:val>
             <c:numRef>
@@ -246,23 +228,36 @@
               </c:numCache>
             </c:numRef>
           </c:val>
-          <c:extLst>
-            <c:ext xmlns:c16="http://schemas.microsoft.com/office/drawing/2014/chart" uri="{C3380CC4-5D6E-409C-BE32-E72D297353CC}">
-              <c16:uniqueId val="{00000000-38D8-412A-BFDC-F2A275E88045}"/>
-            </c:ext>
-          </c:extLst>
         </c:ser>
         <c:dLbls>
+          <c:numFmt formatCode="#,##0" sourceLinked="0"/>
+          <c:txPr>
+            <a:bodyPr/>
+            <a:lstStyle/>
+            <a:p>
+              <a:pPr>
+                <a:defRPr b="0" i="0" strike="noStrike" sz="1300" u="none">
+                  <a:solidFill>
+                    <a:srgbClr val="000000"/>
+                  </a:solidFill>
+                  <a:latin typeface="Arial"/>
+                </a:defRPr>
+              </a:pPr>
+            </a:p>
+          </c:txPr>
           <c:showLegendKey val="0"/>
           <c:showVal val="1"/>
           <c:showCatName val="0"/>
           <c:showSerName val="0"/>
           <c:showPercent val="0"/>
           <c:showBubbleSize val="0"/>
+          <c:showLeaderLines val="0"/>
         </c:dLbls>
         <c:gapWidth val="150"/>
+        <c:overlap val="0"/>
         <c:axId val="2094734554"/>
         <c:axId val="2094734552"/>
+        <c:axId val="2094734556"/>
       </c:barChart>
       <c:catAx>
         <c:axId val="2094734554"/>
@@ -303,7 +298,6 @@
         <c:crosses val="autoZero"/>
         <c:auto val="1"/>
         <c:lblAlgn val="ctr"/>
-        <c:lblOffset val="100"/>
         <c:noMultiLvlLbl val="1"/>
       </c:catAx>
       <c:valAx>
@@ -368,7 +362,6 @@
     </c:plotArea>
     <c:plotVisOnly val="1"/>
     <c:dispBlanksAs val="span"/>
-    <c:showDLblsOverMax val="1"/>
   </c:chart>
   <c:spPr>
     <a:noFill/>
@@ -405,10 +398,234 @@
           <a:chExt cx="0" cy="0"/>
         </a:xfrm>
       </p:grpSpPr>
+      <p:sp>
+        <p:nvSpPr>
+          <p:cNvPr id="2" name="Header Placeholder 1"/>
+          <p:cNvSpPr>
+            <a:spLocks noGrp="1"/>
+          </p:cNvSpPr>
+          <p:nvPr>
+            <p:ph type="hdr" sz="quarter"/>
+          </p:nvPr>
+        </p:nvSpPr>
+        <p:spPr>
+          <a:xfrm>
+            <a:off x="0" y="0"/>
+            <a:ext cx="2971800" cy="458788"/>
+          </a:xfrm>
+          <a:prstGeom prst="rect">
+            <a:avLst/>
+          </a:prstGeom>
+        </p:spPr>
+        <p:txBody>
+          <a:bodyPr vert="horz" lIns="91440" tIns="45720" rIns="91440" bIns="45720" rtlCol="0"/>
+          <a:lstStyle>
+            <a:lvl1pPr algn="l">
+              <a:defRPr sz="1200"/>
+            </a:lvl1pPr>
+          </a:lstStyle>
+          <a:p>
+            <a:endParaRPr lang="en-US"/>
+          </a:p>
+        </p:txBody>
+      </p:sp>
+      <p:sp>
+        <p:nvSpPr>
+          <p:cNvPr id="3" name="Date Placeholder 2"/>
+          <p:cNvSpPr>
+            <a:spLocks noGrp="1"/>
+          </p:cNvSpPr>
+          <p:nvPr>
+            <p:ph type="dt" idx="1"/>
+          </p:nvPr>
+        </p:nvSpPr>
+        <p:spPr>
+          <a:xfrm>
+            <a:off x="3884613" y="0"/>
+            <a:ext cx="2971800" cy="458788"/>
+          </a:xfrm>
+          <a:prstGeom prst="rect">
+            <a:avLst/>
+          </a:prstGeom>
+        </p:spPr>
+        <p:txBody>
+          <a:bodyPr vert="horz" lIns="91440" tIns="45720" rIns="91440" bIns="45720" rtlCol="0"/>
+          <a:lstStyle>
+            <a:lvl1pPr algn="r">
+              <a:defRPr sz="1200"/>
+            </a:lvl1pPr>
+          </a:lstStyle>
+          <a:p>
+            <a:fld id="{5282F153-3F37-0F45-9E97-73ACFA13230C}" type="datetimeFigureOut">
+              <a:rPr lang="en-US"/>
+              <a:t>7/23/19</a:t>
+            </a:fld>
+            <a:endParaRPr lang="en-US"/>
+          </a:p>
+        </p:txBody>
+      </p:sp>
+      <p:sp>
+        <p:nvSpPr>
+          <p:cNvPr id="4" name="Slide Image Placeholder 3"/>
+          <p:cNvSpPr>
+            <a:spLocks noGrp="1" noRot="1" noChangeAspect="1"/>
+          </p:cNvSpPr>
+          <p:nvPr>
+            <p:ph type="sldImg" idx="2"/>
+          </p:nvPr>
+        </p:nvSpPr>
+        <p:spPr>
+          <a:xfrm>
+            <a:off x="685800" y="1143000"/>
+            <a:ext cx="5486400" cy="3086100"/>
+          </a:xfrm>
+          <a:prstGeom prst="rect">
+            <a:avLst/>
+          </a:prstGeom>
+          <a:noFill/>
+          <a:ln w="12700">
+            <a:solidFill>
+              <a:prstClr val="black"/>
+            </a:solidFill>
+          </a:ln>
+        </p:spPr>
+        <p:txBody>
+          <a:bodyPr vert="horz" lIns="91440" tIns="45720" rIns="91440" bIns="45720" rtlCol="0" anchor="ctr"/>
+          <a:lstStyle/>
+          <a:p>
+            <a:endParaRPr lang="en-US"/>
+          </a:p>
+        </p:txBody>
+      </p:sp>
+      <p:sp>
+        <p:nvSpPr>
+          <p:cNvPr id="5" name="Notes Placeholder 4"/>
+          <p:cNvSpPr>
+            <a:spLocks noGrp="1"/>
+          </p:cNvSpPr>
+          <p:nvPr>
+            <p:ph type="body" sz="quarter" idx="3"/>
+          </p:nvPr>
+        </p:nvSpPr>
+        <p:spPr>
+          <a:xfrm>
+            <a:off x="685800" y="4400550"/>
+            <a:ext cx="5486400" cy="3600450"/>
+          </a:xfrm>
+          <a:prstGeom prst="rect">
+            <a:avLst/>
+          </a:prstGeom>
+        </p:spPr>
+        <p:txBody>
+          <a:bodyPr vert="horz" lIns="91440" tIns="45720" rIns="91440" bIns="45720" rtlCol="0"/>
+          <a:lstStyle/>
+          <a:p>
+            <a:pPr lvl="0"/>
+            <a:r>
+              <a:rPr lang="en-US"/>
+              <a:t>Click to edit Master text styles</a:t>
+            </a:r>
+          </a:p>
+          <a:p>
+            <a:pPr lvl="1"/>
+            <a:r>
+              <a:rPr lang="en-US"/>
+              <a:t>Second level</a:t>
+            </a:r>
+          </a:p>
+          <a:p>
+            <a:pPr lvl="2"/>
+            <a:r>
+              <a:rPr lang="en-US"/>
+              <a:t>Third level</a:t>
+            </a:r>
+          </a:p>
+          <a:p>
+            <a:pPr lvl="3"/>
+            <a:r>
+              <a:rPr lang="en-US"/>
+              <a:t>Fourth level</a:t>
+            </a:r>
+          </a:p>
+          <a:p>
+            <a:pPr lvl="4"/>
+            <a:r>
+              <a:rPr lang="en-US"/>
+              <a:t>Fifth level</a:t>
+            </a:r>
+          </a:p>
+        </p:txBody>
+      </p:sp>
+      <p:sp>
+        <p:nvSpPr>
+          <p:cNvPr id="6" name="Footer Placeholder 5"/>
+          <p:cNvSpPr>
+            <a:spLocks noGrp="1"/>
+          </p:cNvSpPr>
+          <p:nvPr>
+            <p:ph type="ftr" sz="quarter" idx="4"/>
+          </p:nvPr>
+        </p:nvSpPr>
+        <p:spPr>
+          <a:xfrm>
+            <a:off x="0" y="8685213"/>
+            <a:ext cx="2971800" cy="458787"/>
+          </a:xfrm>
+          <a:prstGeom prst="rect">
+            <a:avLst/>
+          </a:prstGeom>
+        </p:spPr>
+        <p:txBody>
+          <a:bodyPr vert="horz" lIns="91440" tIns="45720" rIns="91440" bIns="45720" rtlCol="0" anchor="b"/>
+          <a:lstStyle>
+            <a:lvl1pPr algn="l">
+              <a:defRPr sz="1200"/>
+            </a:lvl1pPr>
+          </a:lstStyle>
+          <a:p>
+            <a:endParaRPr lang="en-US"/>
+          </a:p>
+        </p:txBody>
+      </p:sp>
+      <p:sp>
+        <p:nvSpPr>
+          <p:cNvPr id="7" name="Slide Number Placeholder 6"/>
+          <p:cNvSpPr>
+            <a:spLocks noGrp="1"/>
+          </p:cNvSpPr>
+          <p:nvPr>
+            <p:ph type="sldNum" sz="quarter" idx="5"/>
+          </p:nvPr>
+        </p:nvSpPr>
+        <p:spPr>
+          <a:xfrm>
+            <a:off x="3884613" y="8685213"/>
+            <a:ext cx="2971800" cy="458787"/>
+          </a:xfrm>
+          <a:prstGeom prst="rect">
+            <a:avLst/>
+          </a:prstGeom>
+        </p:spPr>
+        <p:txBody>
+          <a:bodyPr vert="horz" lIns="91440" tIns="45720" rIns="91440" bIns="45720" rtlCol="0" anchor="b"/>
+          <a:lstStyle>
+            <a:lvl1pPr algn="r">
+              <a:defRPr sz="1200"/>
+            </a:lvl1pPr>
+          </a:lstStyle>
+          <a:p>
+            <a:fld id="{CE5E9CC1-C706-0F49-92D6-E571CC5EEA8F}" type="slidenum">
+              <a:rPr lang="en-US"/>
+              <a:t>‹#›</a:t>
+            </a:fld>
+            <a:endParaRPr lang="en-US"/>
+          </a:p>
+        </p:txBody>
+      </p:sp>
     </p:spTree>
     <p:extLst>
       <p:ext uri="{BB962C8B-B14F-4D97-AF65-F5344CB8AC3E}">
-        <p14:creationId xmlns:p14="http://schemas.microsoft.com/office/powerpoint/2010/main" val="908992074"/>
+        <p14:creationId xmlns:p14="http://schemas.microsoft.com/office/powerpoint/2010/main" val="1024086991"/>
       </p:ext>
     </p:extLst>
   </p:cSld>
@@ -556,6 +773,7 @@
               <a:rPr lang="en-US" dirty="0"/>
               <a:t>Good morning. Today I am presenting the software testing and quality engineering defense for RestockIQ. RestockIQ is a multi-tier platform that combines machine learning demand forecasting with active waste prevention for retail food businesses. This presentation covers the testing actually conducted on this project, spanning 51 automated tests and physical device smoke verification.</a:t>
             </a:r>
+            <a:endParaRPr lang="en-US" dirty="0"/>
           </a:p>
         </p:txBody>
       </p:sp>
@@ -643,6 +861,7 @@
               <a:rPr lang="en-US" dirty="0"/>
               <a:t>To conclude on Slide 10, we summarize our achievements and remaining roadmap. We designed and executed comprehensive black-box, white-box, integration, and security test suites, fulfilling course outcomes CO1 and CO2, while CO3 on test-driven development remains partial. We acknowledge unperformed techniques including mutation and distributed load testing, and prioritize calendar alignment and commercial bundling in future work. Thank you.</a:t>
             </a:r>
+            <a:endParaRPr lang="en-US" dirty="0"/>
           </a:p>
         </p:txBody>
       </p:sp>
@@ -730,6 +949,7 @@
               <a:rPr lang="en-US" dirty="0"/>
               <a:t>RestockIQ is built across four distinct architectural tiers: the Flutter mobile client, the FastAPI backend microservice, MongoDB Atlas cloud storage, and our ML forecasting engine with Google Gemini 3 Flash. We engineered 51 automated tests covering these components. The entire local test harness runs in approximately 44 seconds without needing external internet access.</a:t>
             </a:r>
+            <a:endParaRPr lang="en-US" dirty="0"/>
           </a:p>
         </p:txBody>
       </p:sp>
@@ -817,6 +1037,7 @@
               <a:rPr lang="en-US" dirty="0"/>
               <a:t>On this slide, we examine our black-box testing techniques. On the left, boundary value analysis probes the AI assistant query endpoint at lengths 0, 1, 500, and 501 characters, confirming the API rejects empty or oversized inputs. On the right, a decision table tests the waste action engine at exact code boundaries: 0.70 triggers no discount, while 0.69 immediately activates a 20 percent price discount.</a:t>
             </a:r>
+            <a:endParaRPr lang="en-US" dirty="0"/>
           </a:p>
         </p:txBody>
       </p:sp>
@@ -904,6 +1125,7 @@
               <a:rPr lang="en-US" dirty="0"/>
               <a:t>Slide 4 illustrates state transition testing on the dynamic waste alert system. An item transitions from unfired state S0 into active warning states S1 or S2 when evening sales pace slows. Applying a discount executes transition T3 into state S3, mutating the database item price by 20 percent. Transition T5 or T6 into state S5 permanently suppresses the alert from cluttering the manager's dashboard.</a:t>
             </a:r>
+            <a:endParaRPr lang="en-US" dirty="0"/>
           </a:p>
         </p:txBody>
       </p:sp>
@@ -991,6 +1213,7 @@
               <a:rPr lang="en-US" dirty="0"/>
               <a:t>On Slide 5, we present white-box basis path testing for the client IP extraction function. By mapping the control flow graph, we identify 10 nodes, 13 edges, and 4 decision points, yielding a cyclomatic complexity of exactly 5. We constructed 5 unit tests covering every independent path. Running coverage.py strictly on application source files confirms 100 percent branch coverage on core security functions.</a:t>
             </a:r>
+            <a:endParaRPr lang="en-US" dirty="0"/>
           </a:p>
         </p:txBody>
       </p:sp>
@@ -1078,6 +1301,7 @@
               <a:rPr lang="en-US" dirty="0"/>
               <a:t>Slide 6 contrasts our classical Detroit-style tests with mockist London-style tests. Classical tests verify real in-memory state mutations in our inventory providers, while mockist tests simulate 4-second API timeouts to ensure mobile screens fail over gracefully. In CI, our backend offline tests pass in 23 seconds and Render keepalive pings every 10 minutes, while the Flutter CI fix is staged locally.</a:t>
             </a:r>
+            <a:endParaRPr lang="en-US" dirty="0"/>
           </a:p>
         </p:txBody>
       </p:sp>
@@ -1165,6 +1389,7 @@
               <a:rPr lang="en-US" dirty="0"/>
               <a:t>Slide 7 demonstrates defect lifecycle management. At the top, we illustrate the progression from human error to code defect to runtime failure using DEF-009: a developer assumed the emulator loopback IP was universally reachable, creating a defect that caused a real 76-second freeze on physical hardware. Below, our defect table shows 11 historical defects tracked: 9 are resolved and regression tested, while 2 remain open.</a:t>
             </a:r>
+            <a:endParaRPr lang="en-US" dirty="0"/>
           </a:p>
         </p:txBody>
       </p:sp>
@@ -1252,6 +1477,7 @@
               <a:rPr lang="en-US" dirty="0"/>
               <a:t>On Slide 8, we review security and end-to-end testing. On the left, our 9-step E2E flow validates the entire lifecycle from authentication to restock and POS logging against MongoDB Atlas. On the right, owner-ID filtering ensures tenant data cannot cross store boundaries, tested with 100 percent isolation on a mock database. Our custom rate limiter protects against spoofed headers, with the limitation that live Render hop counts remain unverified.</a:t>
             </a:r>
+            <a:endParaRPr lang="en-US" dirty="0"/>
           </a:p>
         </p:txBody>
       </p:sp>
@@ -1339,6 +1565,7 @@
               <a:rPr lang="en-US" dirty="0"/>
               <a:t>Slide 9 reports empirical results from testing our AI models. In our 6-fold backtest, Prophet alone achieved 21.7 percent WAPE, outperforming the hybrid model at 23.4 percent; we report this negative finding transparently without claiming untested causes. We proved zero temporal leakage across all folds, verified that Gemini outputs zero hallucinated numbers, and confirmed via simulation that safety stock buffers dictate waste percentages.</a:t>
             </a:r>
+            <a:endParaRPr lang="en-US" dirty="0"/>
           </a:p>
         </p:txBody>
       </p:sp>
@@ -1411,11 +1638,6 @@
 <file path=ppt/slideMasters/slideMaster1.xml><?xml version="1.0" encoding="utf-8"?>
 <p:sldMaster xmlns:a="http://schemas.openxmlformats.org/drawingml/2006/main" xmlns:r="http://schemas.openxmlformats.org/officeDocument/2006/relationships" xmlns:p="http://schemas.openxmlformats.org/presentationml/2006/main">
   <p:cSld>
-    <p:bg>
-      <p:bgRef idx="1001">
-        <a:schemeClr val="bg1"/>
-      </p:bgRef>
-    </p:bg>
     <p:spTree>
       <p:nvGrpSpPr>
         <p:cNvPr id="1" name=""/>
@@ -1698,7 +1920,6 @@
         <a:solidFill>
           <a:srgbClr val="FCF9F4"/>
         </a:solidFill>
-        <a:effectLst/>
       </p:bgPr>
     </p:bg>
     <p:spTree>
@@ -1727,7 +1948,9 @@
             <a:ext cx="2560320" cy="411480"/>
           </a:xfrm>
           <a:prstGeom prst="rect">
-            <a:avLst/>
+            <a:avLst>
+              <a:gd name="adj" fmla="val 17778"/>
+            </a:avLst>
           </a:prstGeom>
           <a:solidFill>
             <a:srgbClr val="EFEAE1"/>
@@ -1761,7 +1984,7 @@
           <a:bodyPr wrap="square" rtlCol="0" anchor="ctr"/>
           <a:lstStyle/>
           <a:p>
-            <a:pPr marL="0" indent="0" algn="ctr">
+            <a:pPr algn="ctr" indent="0" marL="0">
               <a:buNone/>
             </a:pPr>
             <a:r>
@@ -1800,7 +2023,7 @@
           <a:bodyPr wrap="square" rtlCol="0" anchor="ctr"/>
           <a:lstStyle/>
           <a:p>
-            <a:pPr marL="0" indent="0">
+            <a:pPr indent="0" marL="0">
               <a:buNone/>
             </a:pPr>
             <a:r>
@@ -1862,7 +2085,7 @@
           <a:bodyPr wrap="square" rtlCol="0" anchor="ctr"/>
           <a:lstStyle/>
           <a:p>
-            <a:pPr marL="0" indent="0">
+            <a:pPr indent="0" marL="0">
               <a:buNone/>
             </a:pPr>
             <a:r>
@@ -1892,7 +2115,9 @@
             <a:ext cx="6217920" cy="2011680"/>
           </a:xfrm>
           <a:prstGeom prst="rect">
-            <a:avLst/>
+            <a:avLst>
+              <a:gd name="adj" fmla="val 5455"/>
+            </a:avLst>
           </a:prstGeom>
           <a:solidFill>
             <a:srgbClr val="FFFFFF"/>
@@ -1926,7 +2151,7 @@
           <a:bodyPr wrap="square" rtlCol="0" anchor="ctr"/>
           <a:lstStyle/>
           <a:p>
-            <a:pPr marL="0" indent="0">
+            <a:pPr indent="0" marL="0">
               <a:buNone/>
             </a:pPr>
             <a:r>
@@ -1940,6 +2165,9 @@
               </a:rPr>
               <a:t>Author: </a:t>
             </a:r>
+            <a:pPr indent="0" marL="0">
+              <a:buNone/>
+            </a:pPr>
             <a:r>
               <a:rPr lang="en-US" sz="1800" dirty="0">
                 <a:solidFill>
@@ -1952,6 +2180,9 @@
               <a:t>Yatin Patil (Lucifer)
 </a:t>
             </a:r>
+            <a:pPr indent="0" marL="0">
+              <a:buNone/>
+            </a:pPr>
             <a:r>
               <a:rPr lang="en-US" sz="1800" b="1" dirty="0">
                 <a:solidFill>
@@ -1963,6 +2194,9 @@
               </a:rPr>
               <a:t>Program: </a:t>
             </a:r>
+            <a:pPr indent="0" marL="0">
+              <a:buNone/>
+            </a:pPr>
             <a:r>
               <a:rPr lang="en-US" sz="1800" dirty="0">
                 <a:solidFill>
@@ -1975,6 +2209,9 @@
               <a:t>B.Tech Information Technology
 </a:t>
             </a:r>
+            <a:pPr indent="0" marL="0">
+              <a:buNone/>
+            </a:pPr>
             <a:r>
               <a:rPr lang="en-US" sz="1800" b="1" dirty="0">
                 <a:solidFill>
@@ -1986,6 +2223,9 @@
               </a:rPr>
               <a:t>College: </a:t>
             </a:r>
+            <a:pPr indent="0" marL="0">
+              <a:buNone/>
+            </a:pPr>
             <a:r>
               <a:rPr lang="en-US" sz="1800" dirty="0">
                 <a:solidFill>
@@ -1998,6 +2238,9 @@
               <a:t>MPSTME, NMIMS University
 </a:t>
             </a:r>
+            <a:pPr indent="0" marL="0">
+              <a:buNone/>
+            </a:pPr>
             <a:r>
               <a:rPr lang="en-US" sz="1800" b="1" dirty="0">
                 <a:solidFill>
@@ -2009,6 +2252,9 @@
               </a:rPr>
               <a:t>Repository: </a:t>
             </a:r>
+            <a:pPr indent="0" marL="0">
+              <a:buNone/>
+            </a:pPr>
             <a:r>
               <a:rPr lang="en-US" sz="1700" dirty="0">
                 <a:solidFill>
@@ -2036,7 +2282,9 @@
             <a:ext cx="3749040" cy="2011680"/>
           </a:xfrm>
           <a:prstGeom prst="rect">
-            <a:avLst/>
+            <a:avLst>
+              <a:gd name="adj" fmla="val 5455"/>
+            </a:avLst>
           </a:prstGeom>
           <a:solidFill>
             <a:srgbClr val="EFEAE1"/>
@@ -2070,7 +2318,7 @@
           <a:bodyPr wrap="square" rtlCol="0" anchor="ctr"/>
           <a:lstStyle/>
           <a:p>
-            <a:pPr marL="0" indent="0">
+            <a:pPr indent="0" marL="0">
               <a:buNone/>
             </a:pPr>
             <a:r>
@@ -2109,7 +2357,7 @@
           <a:bodyPr wrap="square" rtlCol="0" anchor="ctr"/>
           <a:lstStyle/>
           <a:p>
-            <a:pPr marL="0" indent="0" algn="ctr">
+            <a:pPr algn="ctr" indent="0" marL="0">
               <a:buNone/>
             </a:pPr>
             <a:r>
@@ -2148,7 +2396,7 @@
           <a:bodyPr wrap="square" rtlCol="0" anchor="ctr"/>
           <a:lstStyle/>
           <a:p>
-            <a:pPr marL="0" indent="0" algn="ctr">
+            <a:pPr algn="ctr" indent="0" marL="0">
               <a:buNone/>
             </a:pPr>
             <a:r>
@@ -2165,7 +2413,7 @@
             <a:endParaRPr lang="en-US" sz="1600" dirty="0"/>
           </a:p>
           <a:p>
-            <a:pPr marL="0" indent="0" algn="ctr">
+            <a:pPr algn="ctr" indent="0" marL="0">
               <a:buNone/>
             </a:pPr>
             <a:r>
@@ -2199,7 +2447,6 @@
         <a:solidFill>
           <a:srgbClr val="FCF9F4"/>
         </a:solidFill>
-        <a:effectLst/>
       </p:bgPr>
     </p:bg>
     <p:spTree>
@@ -2237,7 +2484,7 @@
           <a:bodyPr wrap="square" rtlCol="0" anchor="ctr"/>
           <a:lstStyle/>
           <a:p>
-            <a:pPr marL="0" indent="0" algn="r">
+            <a:pPr algn="r" indent="0" marL="0">
               <a:buNone/>
             </a:pPr>
             <a:r>
@@ -2276,7 +2523,7 @@
           <a:bodyPr wrap="square" rtlCol="0" anchor="ctr"/>
           <a:lstStyle/>
           <a:p>
-            <a:pPr marL="0" indent="0">
+            <a:pPr indent="0" marL="0">
               <a:buNone/>
             </a:pPr>
             <a:r>
@@ -2329,7 +2576,9 @@
             <a:ext cx="3410712" cy="3703320"/>
           </a:xfrm>
           <a:prstGeom prst="rect">
-            <a:avLst/>
+            <a:avLst>
+              <a:gd name="adj" fmla="val 3217"/>
+            </a:avLst>
           </a:prstGeom>
           <a:solidFill>
             <a:srgbClr val="FFFFFF"/>
@@ -2354,7 +2603,9 @@
             <a:ext cx="3136392" cy="365760"/>
           </a:xfrm>
           <a:prstGeom prst="rect">
-            <a:avLst/>
+            <a:avLst>
+              <a:gd name="adj" fmla="val 15000"/>
+            </a:avLst>
           </a:prstGeom>
           <a:solidFill>
             <a:srgbClr val="EFEAE1"/>
@@ -2388,7 +2639,7 @@
           <a:bodyPr wrap="square" rtlCol="0" anchor="ctr"/>
           <a:lstStyle/>
           <a:p>
-            <a:pPr marL="0" indent="0" algn="ctr">
+            <a:pPr algn="ctr" indent="0" marL="0">
               <a:buNone/>
             </a:pPr>
             <a:r>
@@ -2536,7 +2787,9 @@
             <a:ext cx="3410712" cy="3703320"/>
           </a:xfrm>
           <a:prstGeom prst="rect">
-            <a:avLst/>
+            <a:avLst>
+              <a:gd name="adj" fmla="val 3217"/>
+            </a:avLst>
           </a:prstGeom>
           <a:solidFill>
             <a:srgbClr val="FFFFFF"/>
@@ -2561,7 +2814,9 @@
             <a:ext cx="3136392" cy="365760"/>
           </a:xfrm>
           <a:prstGeom prst="rect">
-            <a:avLst/>
+            <a:avLst>
+              <a:gd name="adj" fmla="val 15000"/>
+            </a:avLst>
           </a:prstGeom>
           <a:solidFill>
             <a:srgbClr val="EFEAE1"/>
@@ -2595,7 +2850,7 @@
           <a:bodyPr wrap="square" rtlCol="0" anchor="ctr"/>
           <a:lstStyle/>
           <a:p>
-            <a:pPr marL="0" indent="0" algn="ctr">
+            <a:pPr algn="ctr" indent="0" marL="0">
               <a:buNone/>
             </a:pPr>
             <a:r>
@@ -2743,7 +2998,9 @@
             <a:ext cx="3410712" cy="3703320"/>
           </a:xfrm>
           <a:prstGeom prst="rect">
-            <a:avLst/>
+            <a:avLst>
+              <a:gd name="adj" fmla="val 3217"/>
+            </a:avLst>
           </a:prstGeom>
           <a:solidFill>
             <a:srgbClr val="FFFFFF"/>
@@ -2768,7 +3025,9 @@
             <a:ext cx="3136392" cy="365760"/>
           </a:xfrm>
           <a:prstGeom prst="rect">
-            <a:avLst/>
+            <a:avLst>
+              <a:gd name="adj" fmla="val 15000"/>
+            </a:avLst>
           </a:prstGeom>
           <a:solidFill>
             <a:srgbClr val="EFEAE1"/>
@@ -2780,13 +3039,6 @@
             <a:prstDash val="solid"/>
           </a:ln>
         </p:spPr>
-        <p:txBody>
-          <a:bodyPr/>
-          <a:lstStyle/>
-          <a:p>
-            <a:endParaRPr lang="en-IN" dirty="0"/>
-          </a:p>
-        </p:txBody>
       </p:sp>
       <p:sp>
         <p:nvSpPr>
@@ -2809,7 +3061,7 @@
           <a:bodyPr wrap="square" rtlCol="0" anchor="ctr"/>
           <a:lstStyle/>
           <a:p>
-            <a:pPr marL="0" indent="0" algn="ctr">
+            <a:pPr algn="ctr" indent="0" marL="0">
               <a:buNone/>
             </a:pPr>
             <a:r>
@@ -3055,7 +3307,6 @@
         <a:solidFill>
           <a:srgbClr val="FCF9F4"/>
         </a:solidFill>
-        <a:effectLst/>
       </p:bgPr>
     </p:bg>
     <p:spTree>
@@ -3093,7 +3344,7 @@
           <a:bodyPr wrap="square" rtlCol="0" anchor="ctr"/>
           <a:lstStyle/>
           <a:p>
-            <a:pPr marL="0" indent="0" algn="r">
+            <a:pPr algn="r" indent="0" marL="0">
               <a:buNone/>
             </a:pPr>
             <a:r>
@@ -3132,7 +3383,7 @@
           <a:bodyPr wrap="square" rtlCol="0" anchor="ctr"/>
           <a:lstStyle/>
           <a:p>
-            <a:pPr marL="0" indent="0">
+            <a:pPr indent="0" marL="0">
               <a:buNone/>
             </a:pPr>
             <a:r>
@@ -3185,7 +3436,9 @@
             <a:ext cx="2496312" cy="2423160"/>
           </a:xfrm>
           <a:prstGeom prst="rect">
-            <a:avLst/>
+            <a:avLst>
+              <a:gd name="adj" fmla="val 4528"/>
+            </a:avLst>
           </a:prstGeom>
           <a:solidFill>
             <a:srgbClr val="FFFFFF"/>
@@ -3219,7 +3472,7 @@
           <a:bodyPr wrap="square" rtlCol="0" anchor="ctr"/>
           <a:lstStyle/>
           <a:p>
-            <a:pPr marL="0" indent="0" algn="ctr">
+            <a:pPr algn="ctr" indent="0" marL="0">
               <a:buNone/>
             </a:pPr>
             <a:r>
@@ -3258,7 +3511,7 @@
           <a:bodyPr wrap="square" rtlCol="0" anchor="ctr"/>
           <a:lstStyle/>
           <a:p>
-            <a:pPr marL="0" indent="0" algn="ctr">
+            <a:pPr algn="ctr" indent="0" marL="0">
               <a:buNone/>
             </a:pPr>
             <a:r>
@@ -3297,7 +3550,7 @@
           <a:bodyPr wrap="square" rtlCol="0" anchor="ctr"/>
           <a:lstStyle/>
           <a:p>
-            <a:pPr marL="0" indent="0" algn="ctr">
+            <a:pPr algn="ctr" indent="0" marL="0">
               <a:buNone/>
             </a:pPr>
             <a:r>
@@ -3336,7 +3589,7 @@
           <a:bodyPr wrap="square" rtlCol="0" anchor="ctr"/>
           <a:lstStyle/>
           <a:p>
-            <a:pPr marL="0" indent="0" algn="ctr">
+            <a:pPr algn="ctr" indent="0" marL="0">
               <a:buNone/>
             </a:pPr>
             <a:r>
@@ -3353,7 +3606,7 @@
             <a:endParaRPr lang="en-US" sz="1400" dirty="0"/>
           </a:p>
           <a:p>
-            <a:pPr marL="0" indent="0" algn="ctr">
+            <a:pPr algn="ctr" indent="0" marL="0">
               <a:buNone/>
             </a:pPr>
             <a:r>
@@ -3383,7 +3636,9 @@
             <a:ext cx="2496312" cy="2423160"/>
           </a:xfrm>
           <a:prstGeom prst="rect">
-            <a:avLst/>
+            <a:avLst>
+              <a:gd name="adj" fmla="val 4528"/>
+            </a:avLst>
           </a:prstGeom>
           <a:solidFill>
             <a:srgbClr val="FFFFFF"/>
@@ -3417,7 +3672,7 @@
           <a:bodyPr wrap="square" rtlCol="0" anchor="ctr"/>
           <a:lstStyle/>
           <a:p>
-            <a:pPr marL="0" indent="0" algn="ctr">
+            <a:pPr algn="ctr" indent="0" marL="0">
               <a:buNone/>
             </a:pPr>
             <a:r>
@@ -3456,7 +3711,7 @@
           <a:bodyPr wrap="square" rtlCol="0" anchor="ctr"/>
           <a:lstStyle/>
           <a:p>
-            <a:pPr marL="0" indent="0" algn="ctr">
+            <a:pPr algn="ctr" indent="0" marL="0">
               <a:buNone/>
             </a:pPr>
             <a:r>
@@ -3495,7 +3750,7 @@
           <a:bodyPr wrap="square" rtlCol="0" anchor="ctr"/>
           <a:lstStyle/>
           <a:p>
-            <a:pPr marL="0" indent="0" algn="ctr">
+            <a:pPr algn="ctr" indent="0" marL="0">
               <a:buNone/>
             </a:pPr>
             <a:r>
@@ -3534,7 +3789,7 @@
           <a:bodyPr wrap="square" rtlCol="0" anchor="ctr"/>
           <a:lstStyle/>
           <a:p>
-            <a:pPr marL="0" indent="0" algn="ctr">
+            <a:pPr algn="ctr" indent="0" marL="0">
               <a:buNone/>
             </a:pPr>
             <a:r>
@@ -3551,7 +3806,7 @@
             <a:endParaRPr lang="en-US" sz="1400" dirty="0"/>
           </a:p>
           <a:p>
-            <a:pPr marL="0" indent="0" algn="ctr">
+            <a:pPr algn="ctr" indent="0" marL="0">
               <a:buNone/>
             </a:pPr>
             <a:r>
@@ -3581,7 +3836,9 @@
             <a:ext cx="2496312" cy="2423160"/>
           </a:xfrm>
           <a:prstGeom prst="rect">
-            <a:avLst/>
+            <a:avLst>
+              <a:gd name="adj" fmla="val 4528"/>
+            </a:avLst>
           </a:prstGeom>
           <a:solidFill>
             <a:srgbClr val="FFFFFF"/>
@@ -3615,7 +3872,7 @@
           <a:bodyPr wrap="square" rtlCol="0" anchor="ctr"/>
           <a:lstStyle/>
           <a:p>
-            <a:pPr marL="0" indent="0" algn="ctr">
+            <a:pPr algn="ctr" indent="0" marL="0">
               <a:buNone/>
             </a:pPr>
             <a:r>
@@ -3654,7 +3911,7 @@
           <a:bodyPr wrap="square" rtlCol="0" anchor="ctr"/>
           <a:lstStyle/>
           <a:p>
-            <a:pPr marL="0" indent="0" algn="ctr">
+            <a:pPr algn="ctr" indent="0" marL="0">
               <a:buNone/>
             </a:pPr>
             <a:r>
@@ -3693,7 +3950,7 @@
           <a:bodyPr wrap="square" rtlCol="0" anchor="ctr"/>
           <a:lstStyle/>
           <a:p>
-            <a:pPr marL="0" indent="0" algn="ctr">
+            <a:pPr algn="ctr" indent="0" marL="0">
               <a:buNone/>
             </a:pPr>
             <a:r>
@@ -3732,7 +3989,7 @@
           <a:bodyPr wrap="square" rtlCol="0" anchor="ctr"/>
           <a:lstStyle/>
           <a:p>
-            <a:pPr marL="0" indent="0" algn="ctr">
+            <a:pPr algn="ctr" indent="0" marL="0">
               <a:buNone/>
             </a:pPr>
             <a:r>
@@ -3749,7 +4006,7 @@
             <a:endParaRPr lang="en-US" sz="1400" dirty="0"/>
           </a:p>
           <a:p>
-            <a:pPr marL="0" indent="0" algn="ctr">
+            <a:pPr algn="ctr" indent="0" marL="0">
               <a:buNone/>
             </a:pPr>
             <a:r>
@@ -3779,7 +4036,9 @@
             <a:ext cx="2496312" cy="2423160"/>
           </a:xfrm>
           <a:prstGeom prst="rect">
-            <a:avLst/>
+            <a:avLst>
+              <a:gd name="adj" fmla="val 4528"/>
+            </a:avLst>
           </a:prstGeom>
           <a:solidFill>
             <a:srgbClr val="FFFFFF"/>
@@ -3813,7 +4072,7 @@
           <a:bodyPr wrap="square" rtlCol="0" anchor="ctr"/>
           <a:lstStyle/>
           <a:p>
-            <a:pPr marL="0" indent="0" algn="ctr">
+            <a:pPr algn="ctr" indent="0" marL="0">
               <a:buNone/>
             </a:pPr>
             <a:r>
@@ -3852,7 +4111,7 @@
           <a:bodyPr wrap="square" rtlCol="0" anchor="ctr"/>
           <a:lstStyle/>
           <a:p>
-            <a:pPr marL="0" indent="0" algn="ctr">
+            <a:pPr algn="ctr" indent="0" marL="0">
               <a:buNone/>
             </a:pPr>
             <a:r>
@@ -3891,7 +4150,7 @@
           <a:bodyPr wrap="square" rtlCol="0" anchor="ctr"/>
           <a:lstStyle/>
           <a:p>
-            <a:pPr marL="0" indent="0" algn="ctr">
+            <a:pPr algn="ctr" indent="0" marL="0">
               <a:buNone/>
             </a:pPr>
             <a:r>
@@ -3930,7 +4189,7 @@
           <a:bodyPr wrap="square" rtlCol="0" anchor="ctr"/>
           <a:lstStyle/>
           <a:p>
-            <a:pPr marL="0" indent="0" algn="ctr">
+            <a:pPr algn="ctr" indent="0" marL="0">
               <a:buNone/>
             </a:pPr>
             <a:r>
@@ -3947,7 +4206,7 @@
             <a:endParaRPr lang="en-US" sz="1400" dirty="0"/>
           </a:p>
           <a:p>
-            <a:pPr marL="0" indent="0" algn="ctr">
+            <a:pPr algn="ctr" indent="0" marL="0">
               <a:buNone/>
             </a:pPr>
             <a:r>
@@ -3977,7 +4236,9 @@
             <a:ext cx="10728655" cy="1143000"/>
           </a:xfrm>
           <a:prstGeom prst="rect">
-            <a:avLst/>
+            <a:avLst>
+              <a:gd name="adj" fmla="val 9600"/>
+            </a:avLst>
           </a:prstGeom>
           <a:solidFill>
             <a:srgbClr val="1B4332"/>
@@ -4011,7 +4272,7 @@
           <a:bodyPr wrap="square" rtlCol="0" anchor="ctr"/>
           <a:lstStyle/>
           <a:p>
-            <a:pPr marL="0" indent="0">
+            <a:pPr indent="0" marL="0">
               <a:buNone/>
             </a:pPr>
             <a:r>
@@ -4050,7 +4311,7 @@
           <a:bodyPr wrap="square" rtlCol="0" anchor="ctr"/>
           <a:lstStyle/>
           <a:p>
-            <a:pPr marL="0" indent="0">
+            <a:pPr indent="0" marL="0">
               <a:buNone/>
             </a:pPr>
             <a:r>
@@ -4089,7 +4350,7 @@
           <a:bodyPr wrap="square" rtlCol="0" anchor="ctr"/>
           <a:lstStyle/>
           <a:p>
-            <a:pPr marL="0" indent="0" algn="ctr">
+            <a:pPr algn="ctr" indent="0" marL="0">
               <a:buNone/>
             </a:pPr>
             <a:r>
@@ -4128,7 +4389,7 @@
           <a:bodyPr wrap="square" rtlCol="0" anchor="ctr"/>
           <a:lstStyle/>
           <a:p>
-            <a:pPr marL="0" indent="0" algn="ctr">
+            <a:pPr algn="ctr" indent="0" marL="0">
               <a:buNone/>
             </a:pPr>
             <a:r>
@@ -4256,7 +4517,6 @@
         <a:solidFill>
           <a:srgbClr val="FCF9F4"/>
         </a:solidFill>
-        <a:effectLst/>
       </p:bgPr>
     </p:bg>
     <p:spTree>
@@ -4294,7 +4554,7 @@
           <a:bodyPr wrap="square" rtlCol="0" anchor="ctr"/>
           <a:lstStyle/>
           <a:p>
-            <a:pPr marL="0" indent="0" algn="r">
+            <a:pPr algn="r" indent="0" marL="0">
               <a:buNone/>
             </a:pPr>
             <a:r>
@@ -4333,7 +4593,7 @@
           <a:bodyPr wrap="square" rtlCol="0" anchor="ctr"/>
           <a:lstStyle/>
           <a:p>
-            <a:pPr marL="0" indent="0">
+            <a:pPr indent="0" marL="0">
               <a:buNone/>
             </a:pPr>
             <a:r>
@@ -4386,7 +4646,9 @@
             <a:ext cx="5166360" cy="3703320"/>
           </a:xfrm>
           <a:prstGeom prst="rect">
-            <a:avLst/>
+            <a:avLst>
+              <a:gd name="adj" fmla="val 2963"/>
+            </a:avLst>
           </a:prstGeom>
           <a:solidFill>
             <a:srgbClr val="FFFFFF"/>
@@ -4420,7 +4682,7 @@
           <a:bodyPr wrap="square" rtlCol="0" anchor="ctr"/>
           <a:lstStyle/>
           <a:p>
-            <a:pPr marL="0" indent="0">
+            <a:pPr indent="0" marL="0">
               <a:buNone/>
             </a:pPr>
             <a:r>
@@ -4440,7 +4702,7 @@
       </p:sp>
       <p:graphicFrame>
         <p:nvGraphicFramePr>
-          <p:cNvPr id="10" name="Table 0"/>
+          <p:cNvPr id="4" name="Table 0"/>
           <p:cNvGraphicFramePr>
             <a:graphicFrameLocks noGrp="1"/>
           </p:cNvGraphicFramePr>
@@ -4454,34 +4716,16 @@
         </p:nvGraphicFramePr>
         <p:xfrm>
           <a:off x="914400" y="1965960"/>
-          <a:ext cx="4800600" cy="2895600"/>
+          <a:ext cx="4800600" cy="2834640"/>
         </p:xfrm>
         <a:graphic>
           <a:graphicData uri="http://schemas.openxmlformats.org/drawingml/2006/table">
             <a:tbl>
               <a:tblPr/>
               <a:tblGrid>
-                <a:gridCol w="1005840">
-                  <a:extLst>
-                    <a:ext uri="{9D8B030D-6E8A-4147-A177-3AD203B41FA5}">
-                      <a16:colId xmlns:a16="http://schemas.microsoft.com/office/drawing/2014/main" val="20000"/>
-                    </a:ext>
-                  </a:extLst>
-                </a:gridCol>
-                <a:gridCol w="1965960">
-                  <a:extLst>
-                    <a:ext uri="{9D8B030D-6E8A-4147-A177-3AD203B41FA5}">
-                      <a16:colId xmlns:a16="http://schemas.microsoft.com/office/drawing/2014/main" val="20001"/>
-                    </a:ext>
-                  </a:extLst>
-                </a:gridCol>
-                <a:gridCol w="1828800">
-                  <a:extLst>
-                    <a:ext uri="{9D8B030D-6E8A-4147-A177-3AD203B41FA5}">
-                      <a16:colId xmlns:a16="http://schemas.microsoft.com/office/drawing/2014/main" val="20002"/>
-                    </a:ext>
-                  </a:extLst>
-                </a:gridCol>
+                <a:gridCol w="1005840"/>
+                <a:gridCol w="1965960"/>
+                <a:gridCol w="1828800"/>
               </a:tblGrid>
               <a:tr h="502920">
                 <a:tc>
@@ -4489,7 +4733,7 @@
                     <a:bodyPr/>
                     <a:lstStyle/>
                     <a:p>
-                      <a:pPr marL="0" indent="0" algn="ctr">
+                      <a:pPr algn="ctr" indent="0" marL="0">
                         <a:buNone/>
                       </a:pPr>
                       <a:r>
@@ -4510,7 +4754,7 @@
                       </a:endParaRPr>
                     </a:p>
                   </a:txBody>
-                  <a:tcPr>
+                  <a:tcPr marL="91440" marR="91440" marT="45720" marB="45720">
                     <a:lnL w="6350" cap="flat" cmpd="sng" algn="ctr">
                       <a:solidFill>
                         <a:srgbClr val="E5E0D8"/>
@@ -4557,7 +4801,7 @@
                     <a:bodyPr/>
                     <a:lstStyle/>
                     <a:p>
-                      <a:pPr marL="0" indent="0">
+                      <a:pPr indent="0" marL="0">
                         <a:buNone/>
                       </a:pPr>
                       <a:r>
@@ -4578,7 +4822,7 @@
                       </a:endParaRPr>
                     </a:p>
                   </a:txBody>
-                  <a:tcPr>
+                  <a:tcPr marL="91440" marR="91440" marT="45720" marB="45720">
                     <a:lnL w="6350" cap="flat" cmpd="sng" algn="ctr">
                       <a:solidFill>
                         <a:srgbClr val="E5E0D8"/>
@@ -4625,7 +4869,7 @@
                     <a:bodyPr/>
                     <a:lstStyle/>
                     <a:p>
-                      <a:pPr marL="0" indent="0">
+                      <a:pPr indent="0" marL="0">
                         <a:buNone/>
                       </a:pPr>
                       <a:r>
@@ -4646,7 +4890,7 @@
                       </a:endParaRPr>
                     </a:p>
                   </a:txBody>
-                  <a:tcPr>
+                  <a:tcPr marL="91440" marR="91440" marT="45720" marB="45720">
                     <a:lnL w="6350" cap="flat" cmpd="sng" algn="ctr">
                       <a:solidFill>
                         <a:srgbClr val="E5E0D8"/>
@@ -4688,11 +4932,6 @@
                     </a:solidFill>
                   </a:tcPr>
                 </a:tc>
-                <a:extLst>
-                  <a:ext uri="{0D108BD9-81ED-4DB2-BD59-A6C34878D82A}">
-                    <a16:rowId xmlns:a16="http://schemas.microsoft.com/office/drawing/2014/main" val="10000"/>
-                  </a:ext>
-                </a:extLst>
               </a:tr>
               <a:tr h="548640">
                 <a:tc>
@@ -4700,7 +4939,7 @@
                     <a:bodyPr/>
                     <a:lstStyle/>
                     <a:p>
-                      <a:pPr marL="0" indent="0">
+                      <a:pPr indent="0" marL="0">
                         <a:buNone/>
                       </a:pPr>
                       <a:r>
@@ -4721,7 +4960,7 @@
                       </a:endParaRPr>
                     </a:p>
                   </a:txBody>
-                  <a:tcPr>
+                  <a:tcPr marL="91440" marR="91440" marT="45720" marB="45720">
                     <a:lnL w="6350" cap="flat" cmpd="sng" algn="ctr">
                       <a:solidFill>
                         <a:srgbClr val="E5E0D8"/>
@@ -4768,7 +5007,7 @@
                     <a:bodyPr/>
                     <a:lstStyle/>
                     <a:p>
-                      <a:pPr marL="0" indent="0">
+                      <a:pPr indent="0" marL="0">
                         <a:buNone/>
                       </a:pPr>
                       <a:r>
@@ -4789,7 +5028,7 @@
                       </a:endParaRPr>
                     </a:p>
                   </a:txBody>
-                  <a:tcPr>
+                  <a:tcPr marL="91440" marR="91440" marT="45720" marB="45720">
                     <a:lnL w="6350" cap="flat" cmpd="sng" algn="ctr">
                       <a:solidFill>
                         <a:srgbClr val="E5E0D8"/>
@@ -4836,7 +5075,7 @@
                     <a:bodyPr/>
                     <a:lstStyle/>
                     <a:p>
-                      <a:pPr marL="0" indent="0">
+                      <a:pPr indent="0" marL="0">
                         <a:buNone/>
                       </a:pPr>
                       <a:r>
@@ -4857,7 +5096,7 @@
                       </a:endParaRPr>
                     </a:p>
                   </a:txBody>
-                  <a:tcPr>
+                  <a:tcPr marL="91440" marR="91440" marT="45720" marB="45720">
                     <a:lnL w="6350" cap="flat" cmpd="sng" algn="ctr">
                       <a:solidFill>
                         <a:srgbClr val="E5E0D8"/>
@@ -4899,11 +5138,6 @@
                     </a:solidFill>
                   </a:tcPr>
                 </a:tc>
-                <a:extLst>
-                  <a:ext uri="{0D108BD9-81ED-4DB2-BD59-A6C34878D82A}">
-                    <a16:rowId xmlns:a16="http://schemas.microsoft.com/office/drawing/2014/main" val="10001"/>
-                  </a:ext>
-                </a:extLst>
               </a:tr>
               <a:tr h="548640">
                 <a:tc>
@@ -4911,7 +5145,7 @@
                     <a:bodyPr/>
                     <a:lstStyle/>
                     <a:p>
-                      <a:pPr marL="0" indent="0">
+                      <a:pPr indent="0" marL="0">
                         <a:buNone/>
                       </a:pPr>
                       <a:r>
@@ -4932,7 +5166,7 @@
                       </a:endParaRPr>
                     </a:p>
                   </a:txBody>
-                  <a:tcPr>
+                  <a:tcPr marL="91440" marR="91440" marT="45720" marB="45720">
                     <a:lnL w="6350" cap="flat" cmpd="sng" algn="ctr">
                       <a:solidFill>
                         <a:srgbClr val="E5E0D8"/>
@@ -4979,7 +5213,7 @@
                     <a:bodyPr/>
                     <a:lstStyle/>
                     <a:p>
-                      <a:pPr marL="0" indent="0">
+                      <a:pPr indent="0" marL="0">
                         <a:buNone/>
                       </a:pPr>
                       <a:r>
@@ -5000,7 +5234,7 @@
                       </a:endParaRPr>
                     </a:p>
                   </a:txBody>
-                  <a:tcPr>
+                  <a:tcPr marL="91440" marR="91440" marT="45720" marB="45720">
                     <a:lnL w="6350" cap="flat" cmpd="sng" algn="ctr">
                       <a:solidFill>
                         <a:srgbClr val="E5E0D8"/>
@@ -5047,7 +5281,7 @@
                     <a:bodyPr/>
                     <a:lstStyle/>
                     <a:p>
-                      <a:pPr marL="0" indent="0">
+                      <a:pPr indent="0" marL="0">
                         <a:buNone/>
                       </a:pPr>
                       <a:r>
@@ -5068,7 +5302,7 @@
                       </a:endParaRPr>
                     </a:p>
                   </a:txBody>
-                  <a:tcPr>
+                  <a:tcPr marL="91440" marR="91440" marT="45720" marB="45720">
                     <a:lnL w="6350" cap="flat" cmpd="sng" algn="ctr">
                       <a:solidFill>
                         <a:srgbClr val="E5E0D8"/>
@@ -5110,11 +5344,6 @@
                     </a:solidFill>
                   </a:tcPr>
                 </a:tc>
-                <a:extLst>
-                  <a:ext uri="{0D108BD9-81ED-4DB2-BD59-A6C34878D82A}">
-                    <a16:rowId xmlns:a16="http://schemas.microsoft.com/office/drawing/2014/main" val="10002"/>
-                  </a:ext>
-                </a:extLst>
               </a:tr>
               <a:tr h="548640">
                 <a:tc>
@@ -5122,7 +5351,7 @@
                     <a:bodyPr/>
                     <a:lstStyle/>
                     <a:p>
-                      <a:pPr marL="0" indent="0">
+                      <a:pPr indent="0" marL="0">
                         <a:buNone/>
                       </a:pPr>
                       <a:r>
@@ -5143,7 +5372,7 @@
                       </a:endParaRPr>
                     </a:p>
                   </a:txBody>
-                  <a:tcPr>
+                  <a:tcPr marL="91440" marR="91440" marT="45720" marB="45720">
                     <a:lnL w="6350" cap="flat" cmpd="sng" algn="ctr">
                       <a:solidFill>
                         <a:srgbClr val="E5E0D8"/>
@@ -5190,7 +5419,7 @@
                     <a:bodyPr/>
                     <a:lstStyle/>
                     <a:p>
-                      <a:pPr marL="0" indent="0">
+                      <a:pPr indent="0" marL="0">
                         <a:buNone/>
                       </a:pPr>
                       <a:r>
@@ -5211,7 +5440,7 @@
                       </a:endParaRPr>
                     </a:p>
                   </a:txBody>
-                  <a:tcPr>
+                  <a:tcPr marL="91440" marR="91440" marT="45720" marB="45720">
                     <a:lnL w="6350" cap="flat" cmpd="sng" algn="ctr">
                       <a:solidFill>
                         <a:srgbClr val="E5E0D8"/>
@@ -5258,7 +5487,7 @@
                     <a:bodyPr/>
                     <a:lstStyle/>
                     <a:p>
-                      <a:pPr marL="0" indent="0">
+                      <a:pPr indent="0" marL="0">
                         <a:buNone/>
                       </a:pPr>
                       <a:r>
@@ -5279,7 +5508,7 @@
                       </a:endParaRPr>
                     </a:p>
                   </a:txBody>
-                  <a:tcPr>
+                  <a:tcPr marL="91440" marR="91440" marT="45720" marB="45720">
                     <a:lnL w="6350" cap="flat" cmpd="sng" algn="ctr">
                       <a:solidFill>
                         <a:srgbClr val="E5E0D8"/>
@@ -5321,11 +5550,6 @@
                     </a:solidFill>
                   </a:tcPr>
                 </a:tc>
-                <a:extLst>
-                  <a:ext uri="{0D108BD9-81ED-4DB2-BD59-A6C34878D82A}">
-                    <a16:rowId xmlns:a16="http://schemas.microsoft.com/office/drawing/2014/main" val="10003"/>
-                  </a:ext>
-                </a:extLst>
               </a:tr>
               <a:tr h="548640">
                 <a:tc>
@@ -5333,7 +5557,7 @@
                     <a:bodyPr/>
                     <a:lstStyle/>
                     <a:p>
-                      <a:pPr marL="0" indent="0">
+                      <a:pPr indent="0" marL="0">
                         <a:buNone/>
                       </a:pPr>
                       <a:r>
@@ -5354,7 +5578,7 @@
                       </a:endParaRPr>
                     </a:p>
                   </a:txBody>
-                  <a:tcPr>
+                  <a:tcPr marL="91440" marR="91440" marT="45720" marB="45720">
                     <a:lnL w="6350" cap="flat" cmpd="sng" algn="ctr">
                       <a:solidFill>
                         <a:srgbClr val="E5E0D8"/>
@@ -5401,7 +5625,7 @@
                     <a:bodyPr/>
                     <a:lstStyle/>
                     <a:p>
-                      <a:pPr marL="0" indent="0">
+                      <a:pPr indent="0" marL="0">
                         <a:buNone/>
                       </a:pPr>
                       <a:r>
@@ -5422,7 +5646,7 @@
                       </a:endParaRPr>
                     </a:p>
                   </a:txBody>
-                  <a:tcPr>
+                  <a:tcPr marL="91440" marR="91440" marT="45720" marB="45720">
                     <a:lnL w="6350" cap="flat" cmpd="sng" algn="ctr">
                       <a:solidFill>
                         <a:srgbClr val="E5E0D8"/>
@@ -5469,7 +5693,7 @@
                     <a:bodyPr/>
                     <a:lstStyle/>
                     <a:p>
-                      <a:pPr marL="0" indent="0">
+                      <a:pPr indent="0" marL="0">
                         <a:buNone/>
                       </a:pPr>
                       <a:r>
@@ -5490,7 +5714,7 @@
                       </a:endParaRPr>
                     </a:p>
                   </a:txBody>
-                  <a:tcPr>
+                  <a:tcPr marL="91440" marR="91440" marT="45720" marB="45720">
                     <a:lnL w="6350" cap="flat" cmpd="sng" algn="ctr">
                       <a:solidFill>
                         <a:srgbClr val="E5E0D8"/>
@@ -5532,11 +5756,6 @@
                     </a:solidFill>
                   </a:tcPr>
                 </a:tc>
-                <a:extLst>
-                  <a:ext uri="{0D108BD9-81ED-4DB2-BD59-A6C34878D82A}">
-                    <a16:rowId xmlns:a16="http://schemas.microsoft.com/office/drawing/2014/main" val="10004"/>
-                  </a:ext>
-                </a:extLst>
               </a:tr>
             </a:tbl>
           </a:graphicData>
@@ -5554,7 +5773,9 @@
             <a:ext cx="5193792" cy="3703320"/>
           </a:xfrm>
           <a:prstGeom prst="rect">
-            <a:avLst/>
+            <a:avLst>
+              <a:gd name="adj" fmla="val 2963"/>
+            </a:avLst>
           </a:prstGeom>
           <a:solidFill>
             <a:srgbClr val="FFFFFF"/>
@@ -5588,7 +5809,7 @@
           <a:bodyPr wrap="square" rtlCol="0" anchor="ctr"/>
           <a:lstStyle/>
           <a:p>
-            <a:pPr marL="0" indent="0">
+            <a:pPr indent="0" marL="0">
               <a:buNone/>
             </a:pPr>
             <a:r>
@@ -5622,34 +5843,16 @@
         </p:nvGraphicFramePr>
         <p:xfrm>
           <a:off x="6446520" y="1965960"/>
-          <a:ext cx="4828032" cy="2743200"/>
+          <a:ext cx="4828032" cy="2834640"/>
         </p:xfrm>
         <a:graphic>
           <a:graphicData uri="http://schemas.openxmlformats.org/drawingml/2006/table">
             <a:tbl>
               <a:tblPr/>
               <a:tblGrid>
-                <a:gridCol w="1051560">
-                  <a:extLst>
-                    <a:ext uri="{9D8B030D-6E8A-4147-A177-3AD203B41FA5}">
-                      <a16:colId xmlns:a16="http://schemas.microsoft.com/office/drawing/2014/main" val="20000"/>
-                    </a:ext>
-                  </a:extLst>
-                </a:gridCol>
-                <a:gridCol w="1417320">
-                  <a:extLst>
-                    <a:ext uri="{9D8B030D-6E8A-4147-A177-3AD203B41FA5}">
-                      <a16:colId xmlns:a16="http://schemas.microsoft.com/office/drawing/2014/main" val="20001"/>
-                    </a:ext>
-                  </a:extLst>
-                </a:gridCol>
-                <a:gridCol w="2359152">
-                  <a:extLst>
-                    <a:ext uri="{9D8B030D-6E8A-4147-A177-3AD203B41FA5}">
-                      <a16:colId xmlns:a16="http://schemas.microsoft.com/office/drawing/2014/main" val="20002"/>
-                    </a:ext>
-                  </a:extLst>
-                </a:gridCol>
+                <a:gridCol w="1051560"/>
+                <a:gridCol w="1417320"/>
+                <a:gridCol w="2359152"/>
               </a:tblGrid>
               <a:tr h="502920">
                 <a:tc>
@@ -5657,7 +5860,7 @@
                     <a:bodyPr/>
                     <a:lstStyle/>
                     <a:p>
-                      <a:pPr marL="0" indent="0" algn="ctr">
+                      <a:pPr algn="ctr" indent="0" marL="0">
                         <a:buNone/>
                       </a:pPr>
                       <a:r>
@@ -5678,7 +5881,7 @@
                       </a:endParaRPr>
                     </a:p>
                   </a:txBody>
-                  <a:tcPr>
+                  <a:tcPr marL="91440" marR="91440" marT="45720" marB="45720">
                     <a:lnL w="6350" cap="flat" cmpd="sng" algn="ctr">
                       <a:solidFill>
                         <a:srgbClr val="E5E0D8"/>
@@ -5725,7 +5928,7 @@
                     <a:bodyPr/>
                     <a:lstStyle/>
                     <a:p>
-                      <a:pPr marL="0" indent="0" algn="ctr">
+                      <a:pPr algn="ctr" indent="0" marL="0">
                         <a:buNone/>
                       </a:pPr>
                       <a:r>
@@ -5746,7 +5949,7 @@
                       </a:endParaRPr>
                     </a:p>
                   </a:txBody>
-                  <a:tcPr>
+                  <a:tcPr marL="91440" marR="91440" marT="45720" marB="45720">
                     <a:lnL w="6350" cap="flat" cmpd="sng" algn="ctr">
                       <a:solidFill>
                         <a:srgbClr val="E5E0D8"/>
@@ -5793,7 +5996,7 @@
                     <a:bodyPr/>
                     <a:lstStyle/>
                     <a:p>
-                      <a:pPr marL="0" indent="0">
+                      <a:pPr indent="0" marL="0">
                         <a:buNone/>
                       </a:pPr>
                       <a:r>
@@ -5814,7 +6017,7 @@
                       </a:endParaRPr>
                     </a:p>
                   </a:txBody>
-                  <a:tcPr>
+                  <a:tcPr marL="91440" marR="91440" marT="45720" marB="45720">
                     <a:lnL w="6350" cap="flat" cmpd="sng" algn="ctr">
                       <a:solidFill>
                         <a:srgbClr val="E5E0D8"/>
@@ -5856,11 +6059,6 @@
                     </a:solidFill>
                   </a:tcPr>
                 </a:tc>
-                <a:extLst>
-                  <a:ext uri="{0D108BD9-81ED-4DB2-BD59-A6C34878D82A}">
-                    <a16:rowId xmlns:a16="http://schemas.microsoft.com/office/drawing/2014/main" val="10000"/>
-                  </a:ext>
-                </a:extLst>
               </a:tr>
               <a:tr h="548640">
                 <a:tc>
@@ -5868,7 +6066,7 @@
                     <a:bodyPr/>
                     <a:lstStyle/>
                     <a:p>
-                      <a:pPr marL="0" indent="0">
+                      <a:pPr indent="0" marL="0">
                         <a:buNone/>
                       </a:pPr>
                       <a:r>
@@ -5889,7 +6087,7 @@
                       </a:endParaRPr>
                     </a:p>
                   </a:txBody>
-                  <a:tcPr>
+                  <a:tcPr marL="91440" marR="91440" marT="45720" marB="45720">
                     <a:lnL w="6350" cap="flat" cmpd="sng" algn="ctr">
                       <a:solidFill>
                         <a:srgbClr val="E5E0D8"/>
@@ -5936,7 +6134,7 @@
                     <a:bodyPr/>
                     <a:lstStyle/>
                     <a:p>
-                      <a:pPr marL="0" indent="0">
+                      <a:pPr indent="0" marL="0">
                         <a:buNone/>
                       </a:pPr>
                       <a:r>
@@ -5957,7 +6155,7 @@
                       </a:endParaRPr>
                     </a:p>
                   </a:txBody>
-                  <a:tcPr>
+                  <a:tcPr marL="91440" marR="91440" marT="45720" marB="45720">
                     <a:lnL w="6350" cap="flat" cmpd="sng" algn="ctr">
                       <a:solidFill>
                         <a:srgbClr val="E5E0D8"/>
@@ -6004,7 +6202,7 @@
                     <a:bodyPr/>
                     <a:lstStyle/>
                     <a:p>
-                      <a:pPr marL="0" indent="0">
+                      <a:pPr indent="0" marL="0">
                         <a:buNone/>
                       </a:pPr>
                       <a:r>
@@ -6025,7 +6223,7 @@
                       </a:endParaRPr>
                     </a:p>
                   </a:txBody>
-                  <a:tcPr>
+                  <a:tcPr marL="91440" marR="91440" marT="45720" marB="45720">
                     <a:lnL w="6350" cap="flat" cmpd="sng" algn="ctr">
                       <a:solidFill>
                         <a:srgbClr val="E5E0D8"/>
@@ -6067,11 +6265,6 @@
                     </a:solidFill>
                   </a:tcPr>
                 </a:tc>
-                <a:extLst>
-                  <a:ext uri="{0D108BD9-81ED-4DB2-BD59-A6C34878D82A}">
-                    <a16:rowId xmlns:a16="http://schemas.microsoft.com/office/drawing/2014/main" val="10001"/>
-                  </a:ext>
-                </a:extLst>
               </a:tr>
               <a:tr h="548640">
                 <a:tc>
@@ -6079,7 +6272,7 @@
                     <a:bodyPr/>
                     <a:lstStyle/>
                     <a:p>
-                      <a:pPr marL="0" indent="0">
+                      <a:pPr indent="0" marL="0">
                         <a:buNone/>
                       </a:pPr>
                       <a:r>
@@ -6100,7 +6293,7 @@
                       </a:endParaRPr>
                     </a:p>
                   </a:txBody>
-                  <a:tcPr>
+                  <a:tcPr marL="91440" marR="91440" marT="45720" marB="45720">
                     <a:lnL w="6350" cap="flat" cmpd="sng" algn="ctr">
                       <a:solidFill>
                         <a:srgbClr val="E5E0D8"/>
@@ -6147,7 +6340,7 @@
                     <a:bodyPr/>
                     <a:lstStyle/>
                     <a:p>
-                      <a:pPr marL="0" indent="0">
+                      <a:pPr indent="0" marL="0">
                         <a:buNone/>
                       </a:pPr>
                       <a:r>
@@ -6168,7 +6361,7 @@
                       </a:endParaRPr>
                     </a:p>
                   </a:txBody>
-                  <a:tcPr>
+                  <a:tcPr marL="91440" marR="91440" marT="45720" marB="45720">
                     <a:lnL w="6350" cap="flat" cmpd="sng" algn="ctr">
                       <a:solidFill>
                         <a:srgbClr val="E5E0D8"/>
@@ -6215,7 +6408,7 @@
                     <a:bodyPr/>
                     <a:lstStyle/>
                     <a:p>
-                      <a:pPr marL="0" indent="0">
+                      <a:pPr indent="0" marL="0">
                         <a:buNone/>
                       </a:pPr>
                       <a:r>
@@ -6236,7 +6429,7 @@
                       </a:endParaRPr>
                     </a:p>
                   </a:txBody>
-                  <a:tcPr>
+                  <a:tcPr marL="91440" marR="91440" marT="45720" marB="45720">
                     <a:lnL w="6350" cap="flat" cmpd="sng" algn="ctr">
                       <a:solidFill>
                         <a:srgbClr val="E5E0D8"/>
@@ -6278,11 +6471,6 @@
                     </a:solidFill>
                   </a:tcPr>
                 </a:tc>
-                <a:extLst>
-                  <a:ext uri="{0D108BD9-81ED-4DB2-BD59-A6C34878D82A}">
-                    <a16:rowId xmlns:a16="http://schemas.microsoft.com/office/drawing/2014/main" val="10002"/>
-                  </a:ext>
-                </a:extLst>
               </a:tr>
               <a:tr h="548640">
                 <a:tc>
@@ -6290,7 +6478,7 @@
                     <a:bodyPr/>
                     <a:lstStyle/>
                     <a:p>
-                      <a:pPr marL="0" indent="0">
+                      <a:pPr indent="0" marL="0">
                         <a:buNone/>
                       </a:pPr>
                       <a:r>
@@ -6311,7 +6499,7 @@
                       </a:endParaRPr>
                     </a:p>
                   </a:txBody>
-                  <a:tcPr>
+                  <a:tcPr marL="91440" marR="91440" marT="45720" marB="45720">
                     <a:lnL w="6350" cap="flat" cmpd="sng" algn="ctr">
                       <a:solidFill>
                         <a:srgbClr val="E5E0D8"/>
@@ -6358,7 +6546,7 @@
                     <a:bodyPr/>
                     <a:lstStyle/>
                     <a:p>
-                      <a:pPr marL="0" indent="0">
+                      <a:pPr indent="0" marL="0">
                         <a:buNone/>
                       </a:pPr>
                       <a:r>
@@ -6379,7 +6567,7 @@
                       </a:endParaRPr>
                     </a:p>
                   </a:txBody>
-                  <a:tcPr>
+                  <a:tcPr marL="91440" marR="91440" marT="45720" marB="45720">
                     <a:lnL w="6350" cap="flat" cmpd="sng" algn="ctr">
                       <a:solidFill>
                         <a:srgbClr val="E5E0D8"/>
@@ -6426,7 +6614,7 @@
                     <a:bodyPr/>
                     <a:lstStyle/>
                     <a:p>
-                      <a:pPr marL="0" indent="0">
+                      <a:pPr indent="0" marL="0">
                         <a:buNone/>
                       </a:pPr>
                       <a:r>
@@ -6447,7 +6635,7 @@
                       </a:endParaRPr>
                     </a:p>
                   </a:txBody>
-                  <a:tcPr>
+                  <a:tcPr marL="91440" marR="91440" marT="45720" marB="45720">
                     <a:lnL w="6350" cap="flat" cmpd="sng" algn="ctr">
                       <a:solidFill>
                         <a:srgbClr val="E5E0D8"/>
@@ -6489,11 +6677,6 @@
                     </a:solidFill>
                   </a:tcPr>
                 </a:tc>
-                <a:extLst>
-                  <a:ext uri="{0D108BD9-81ED-4DB2-BD59-A6C34878D82A}">
-                    <a16:rowId xmlns:a16="http://schemas.microsoft.com/office/drawing/2014/main" val="10003"/>
-                  </a:ext>
-                </a:extLst>
               </a:tr>
               <a:tr h="548640">
                 <a:tc>
@@ -6501,7 +6684,7 @@
                     <a:bodyPr/>
                     <a:lstStyle/>
                     <a:p>
-                      <a:pPr marL="0" indent="0">
+                      <a:pPr indent="0" marL="0">
                         <a:buNone/>
                       </a:pPr>
                       <a:r>
@@ -6522,7 +6705,7 @@
                       </a:endParaRPr>
                     </a:p>
                   </a:txBody>
-                  <a:tcPr>
+                  <a:tcPr marL="91440" marR="91440" marT="45720" marB="45720">
                     <a:lnL w="6350" cap="flat" cmpd="sng" algn="ctr">
                       <a:solidFill>
                         <a:srgbClr val="E5E0D8"/>
@@ -6569,7 +6752,7 @@
                     <a:bodyPr/>
                     <a:lstStyle/>
                     <a:p>
-                      <a:pPr marL="0" indent="0">
+                      <a:pPr indent="0" marL="0">
                         <a:buNone/>
                       </a:pPr>
                       <a:r>
@@ -6590,7 +6773,7 @@
                       </a:endParaRPr>
                     </a:p>
                   </a:txBody>
-                  <a:tcPr>
+                  <a:tcPr marL="91440" marR="91440" marT="45720" marB="45720">
                     <a:lnL w="6350" cap="flat" cmpd="sng" algn="ctr">
                       <a:solidFill>
                         <a:srgbClr val="E5E0D8"/>
@@ -6637,7 +6820,7 @@
                     <a:bodyPr/>
                     <a:lstStyle/>
                     <a:p>
-                      <a:pPr marL="0" indent="0">
+                      <a:pPr indent="0" marL="0">
                         <a:buNone/>
                       </a:pPr>
                       <a:r>
@@ -6658,7 +6841,7 @@
                       </a:endParaRPr>
                     </a:p>
                   </a:txBody>
-                  <a:tcPr>
+                  <a:tcPr marL="91440" marR="91440" marT="45720" marB="45720">
                     <a:lnL w="6350" cap="flat" cmpd="sng" algn="ctr">
                       <a:solidFill>
                         <a:srgbClr val="E5E0D8"/>
@@ -6700,11 +6883,6 @@
                     </a:solidFill>
                   </a:tcPr>
                 </a:tc>
-                <a:extLst>
-                  <a:ext uri="{0D108BD9-81ED-4DB2-BD59-A6C34878D82A}">
-                    <a16:rowId xmlns:a16="http://schemas.microsoft.com/office/drawing/2014/main" val="10004"/>
-                  </a:ext>
-                </a:extLst>
               </a:tr>
             </a:tbl>
           </a:graphicData>
@@ -6820,7 +6998,6 @@
         <a:solidFill>
           <a:srgbClr val="FCF9F4"/>
         </a:solidFill>
-        <a:effectLst/>
       </p:bgPr>
     </p:bg>
     <p:spTree>
@@ -6858,7 +7035,7 @@
           <a:bodyPr wrap="square" rtlCol="0" anchor="ctr"/>
           <a:lstStyle/>
           <a:p>
-            <a:pPr marL="0" indent="0" algn="r">
+            <a:pPr algn="r" indent="0" marL="0">
               <a:buNone/>
             </a:pPr>
             <a:r>
@@ -6897,7 +7074,7 @@
           <a:bodyPr wrap="square" rtlCol="0" anchor="ctr"/>
           <a:lstStyle/>
           <a:p>
-            <a:pPr marL="0" indent="0">
+            <a:pPr indent="0" marL="0">
               <a:buNone/>
             </a:pPr>
             <a:r>
@@ -6950,7 +7127,9 @@
             <a:ext cx="10728655" cy="3703320"/>
           </a:xfrm>
           <a:prstGeom prst="rect">
-            <a:avLst/>
+            <a:avLst>
+              <a:gd name="adj" fmla="val 2963"/>
+            </a:avLst>
           </a:prstGeom>
           <a:solidFill>
             <a:srgbClr val="FFFFFF"/>
@@ -6975,7 +7154,9 @@
             <a:ext cx="1783080" cy="1371600"/>
           </a:xfrm>
           <a:prstGeom prst="rect">
-            <a:avLst/>
+            <a:avLst>
+              <a:gd name="adj" fmla="val 6667"/>
+            </a:avLst>
           </a:prstGeom>
           <a:solidFill>
             <a:srgbClr val="EFEAE1"/>
@@ -7009,7 +7190,7 @@
           <a:bodyPr wrap="square" rtlCol="0" anchor="ctr"/>
           <a:lstStyle/>
           <a:p>
-            <a:pPr marL="0" indent="0" algn="ctr">
+            <a:pPr algn="ctr" indent="0" marL="0">
               <a:buNone/>
             </a:pPr>
             <a:r>
@@ -7026,7 +7207,7 @@
             <a:endParaRPr lang="en-US" sz="1450" dirty="0"/>
           </a:p>
           <a:p>
-            <a:pPr marL="0" indent="0" algn="ctr">
+            <a:pPr algn="ctr" indent="0" marL="0">
               <a:buNone/>
             </a:pPr>
             <a:r>
@@ -7043,7 +7224,7 @@
             <a:endParaRPr lang="en-US" sz="1450" dirty="0"/>
           </a:p>
           <a:p>
-            <a:pPr marL="0" indent="0" algn="ctr">
+            <a:pPr algn="ctr" indent="0" marL="0">
               <a:buNone/>
             </a:pPr>
             <a:r>
@@ -7073,7 +7254,9 @@
             <a:ext cx="2103120" cy="1234440"/>
           </a:xfrm>
           <a:prstGeom prst="rect">
-            <a:avLst/>
+            <a:avLst>
+              <a:gd name="adj" fmla="val 7407"/>
+            </a:avLst>
           </a:prstGeom>
           <a:solidFill>
             <a:srgbClr val="FFFFFF"/>
@@ -7107,7 +7290,7 @@
           <a:bodyPr wrap="square" rtlCol="0" anchor="ctr"/>
           <a:lstStyle/>
           <a:p>
-            <a:pPr marL="0" indent="0" algn="ctr">
+            <a:pPr algn="ctr" indent="0" marL="0">
               <a:buNone/>
             </a:pPr>
             <a:r>
@@ -7124,7 +7307,7 @@
             <a:endParaRPr lang="en-US" sz="1350" dirty="0"/>
           </a:p>
           <a:p>
-            <a:pPr marL="0" indent="0" algn="ctr">
+            <a:pPr algn="ctr" indent="0" marL="0">
               <a:buNone/>
             </a:pPr>
             <a:r>
@@ -7154,7 +7337,9 @@
             <a:ext cx="2103120" cy="1234440"/>
           </a:xfrm>
           <a:prstGeom prst="rect">
-            <a:avLst/>
+            <a:avLst>
+              <a:gd name="adj" fmla="val 7407"/>
+            </a:avLst>
           </a:prstGeom>
           <a:solidFill>
             <a:srgbClr val="B91C1C"/>
@@ -7183,7 +7368,7 @@
           <a:bodyPr wrap="square" rtlCol="0" anchor="ctr"/>
           <a:lstStyle/>
           <a:p>
-            <a:pPr marL="0" indent="0" algn="ctr">
+            <a:pPr algn="ctr" indent="0" marL="0">
               <a:buNone/>
             </a:pPr>
             <a:r>
@@ -7200,7 +7385,7 @@
             <a:endParaRPr lang="en-US" sz="1350" dirty="0"/>
           </a:p>
           <a:p>
-            <a:pPr marL="0" indent="0" algn="ctr">
+            <a:pPr algn="ctr" indent="0" marL="0">
               <a:buNone/>
             </a:pPr>
             <a:r>
@@ -7230,7 +7415,9 @@
             <a:ext cx="2011680" cy="1234440"/>
           </a:xfrm>
           <a:prstGeom prst="rect">
-            <a:avLst/>
+            <a:avLst>
+              <a:gd name="adj" fmla="val 7407"/>
+            </a:avLst>
           </a:prstGeom>
           <a:solidFill>
             <a:srgbClr val="FFFFFF"/>
@@ -7264,7 +7451,7 @@
           <a:bodyPr wrap="square" rtlCol="0" anchor="ctr"/>
           <a:lstStyle/>
           <a:p>
-            <a:pPr marL="0" indent="0" algn="ctr">
+            <a:pPr algn="ctr" indent="0" marL="0">
               <a:buNone/>
             </a:pPr>
             <a:r>
@@ -7281,7 +7468,7 @@
             <a:endParaRPr lang="en-US" sz="1350" dirty="0"/>
           </a:p>
           <a:p>
-            <a:pPr marL="0" indent="0" algn="ctr">
+            <a:pPr algn="ctr" indent="0" marL="0">
               <a:buNone/>
             </a:pPr>
             <a:r>
@@ -7311,7 +7498,9 @@
             <a:ext cx="2011680" cy="1234440"/>
           </a:xfrm>
           <a:prstGeom prst="rect">
-            <a:avLst/>
+            <a:avLst>
+              <a:gd name="adj" fmla="val 7407"/>
+            </a:avLst>
           </a:prstGeom>
           <a:solidFill>
             <a:srgbClr val="FFFFFF"/>
@@ -7345,7 +7534,7 @@
           <a:bodyPr wrap="square" rtlCol="0" anchor="ctr"/>
           <a:lstStyle/>
           <a:p>
-            <a:pPr marL="0" indent="0" algn="ctr">
+            <a:pPr algn="ctr" indent="0" marL="0">
               <a:buNone/>
             </a:pPr>
             <a:r>
@@ -7362,7 +7551,7 @@
             <a:endParaRPr lang="en-US" sz="1300" dirty="0"/>
           </a:p>
           <a:p>
-            <a:pPr marL="0" indent="0" algn="ctr">
+            <a:pPr algn="ctr" indent="0" marL="0">
               <a:buNone/>
             </a:pPr>
             <a:r>
@@ -7392,7 +7581,9 @@
             <a:ext cx="1325880" cy="1371600"/>
           </a:xfrm>
           <a:prstGeom prst="rect">
-            <a:avLst/>
+            <a:avLst>
+              <a:gd name="adj" fmla="val 6897"/>
+            </a:avLst>
           </a:prstGeom>
           <a:solidFill>
             <a:srgbClr val="EFEAE1"/>
@@ -7426,7 +7617,7 @@
           <a:bodyPr wrap="square" rtlCol="0" anchor="ctr"/>
           <a:lstStyle/>
           <a:p>
-            <a:pPr marL="0" indent="0" algn="ctr">
+            <a:pPr algn="ctr" indent="0" marL="0">
               <a:buNone/>
             </a:pPr>
             <a:r>
@@ -7443,13 +7634,13 @@
             <a:endParaRPr lang="en-US" sz="1200" dirty="0"/>
           </a:p>
           <a:p>
-            <a:pPr marL="0" indent="0" algn="ctr">
+            <a:pPr algn="ctr" indent="0" marL="0">
               <a:buNone/>
             </a:pPr>
             <a:endParaRPr lang="en-US" sz="1200" dirty="0"/>
           </a:p>
           <a:p>
-            <a:pPr marL="0" indent="0" algn="ctr">
+            <a:pPr algn="ctr" indent="0" marL="0">
               <a:buNone/>
             </a:pPr>
             <a:r>
@@ -7466,7 +7657,7 @@
             <a:endParaRPr lang="en-US" sz="1200" dirty="0"/>
           </a:p>
           <a:p>
-            <a:pPr marL="0" indent="0" algn="ctr">
+            <a:pPr algn="ctr" indent="0" marL="0">
               <a:buNone/>
             </a:pPr>
             <a:r>
@@ -7505,7 +7696,7 @@
           <a:bodyPr wrap="square" rtlCol="0" anchor="ctr"/>
           <a:lstStyle/>
           <a:p>
-            <a:pPr marL="0" indent="0">
+            <a:pPr indent="0" marL="0">
               <a:buNone/>
             </a:pPr>
             <a:r>
@@ -7544,7 +7735,7 @@
           <a:bodyPr wrap="square" rtlCol="0" anchor="ctr"/>
           <a:lstStyle/>
           <a:p>
-            <a:pPr marL="0" indent="0">
+            <a:pPr indent="0" marL="0">
               <a:buNone/>
             </a:pPr>
             <a:r>
@@ -7583,7 +7774,7 @@
           <a:bodyPr wrap="square" rtlCol="0" anchor="ctr"/>
           <a:lstStyle/>
           <a:p>
-            <a:pPr marL="0" indent="0">
+            <a:pPr indent="0" marL="0">
               <a:buNone/>
             </a:pPr>
             <a:r>
@@ -7622,7 +7813,7 @@
           <a:bodyPr wrap="square" rtlCol="0" anchor="ctr"/>
           <a:lstStyle/>
           <a:p>
-            <a:pPr marL="0" indent="0">
+            <a:pPr indent="0" marL="0">
               <a:buNone/>
             </a:pPr>
             <a:r>
@@ -7661,7 +7852,7 @@
           <a:bodyPr wrap="square" rtlCol="0" anchor="ctr"/>
           <a:lstStyle/>
           <a:p>
-            <a:pPr marL="0" indent="0">
+            <a:pPr indent="0" marL="0">
               <a:buNone/>
             </a:pPr>
             <a:r>
@@ -7789,7 +7980,6 @@
         <a:solidFill>
           <a:srgbClr val="FCF9F4"/>
         </a:solidFill>
-        <a:effectLst/>
       </p:bgPr>
     </p:bg>
     <p:spTree>
@@ -7827,7 +8017,7 @@
           <a:bodyPr wrap="square" rtlCol="0" anchor="ctr"/>
           <a:lstStyle/>
           <a:p>
-            <a:pPr marL="0" indent="0" algn="r">
+            <a:pPr algn="r" indent="0" marL="0">
               <a:buNone/>
             </a:pPr>
             <a:r>
@@ -7866,7 +8056,7 @@
           <a:bodyPr wrap="square" rtlCol="0" anchor="ctr"/>
           <a:lstStyle/>
           <a:p>
-            <a:pPr marL="0" indent="0">
+            <a:pPr indent="0" marL="0">
               <a:buNone/>
             </a:pPr>
             <a:r>
@@ -7919,7 +8109,9 @@
             <a:ext cx="5486400" cy="3703320"/>
           </a:xfrm>
           <a:prstGeom prst="rect">
-            <a:avLst/>
+            <a:avLst>
+              <a:gd name="adj" fmla="val 2963"/>
+            </a:avLst>
           </a:prstGeom>
           <a:solidFill>
             <a:srgbClr val="FFFFFF"/>
@@ -7953,7 +8145,7 @@
           <a:bodyPr wrap="square" rtlCol="0" anchor="ctr"/>
           <a:lstStyle/>
           <a:p>
-            <a:pPr marL="0" indent="0">
+            <a:pPr indent="0" marL="0">
               <a:buNone/>
             </a:pPr>
             <a:r>
@@ -7983,7 +8175,9 @@
             <a:ext cx="5120640" cy="347472"/>
           </a:xfrm>
           <a:prstGeom prst="rect">
-            <a:avLst/>
+            <a:avLst>
+              <a:gd name="adj" fmla="val 15789"/>
+            </a:avLst>
           </a:prstGeom>
           <a:solidFill>
             <a:srgbClr val="FFFFFF"/>
@@ -8017,7 +8211,7 @@
           <a:bodyPr wrap="square" rtlCol="0" anchor="ctr"/>
           <a:lstStyle/>
           <a:p>
-            <a:pPr marL="0" indent="0">
+            <a:pPr indent="0" marL="0">
               <a:buNone/>
             </a:pPr>
             <a:r>
@@ -8047,7 +8241,9 @@
             <a:ext cx="5120640" cy="347472"/>
           </a:xfrm>
           <a:prstGeom prst="rect">
-            <a:avLst/>
+            <a:avLst>
+              <a:gd name="adj" fmla="val 15789"/>
+            </a:avLst>
           </a:prstGeom>
           <a:solidFill>
             <a:srgbClr val="EFEAE1"/>
@@ -8081,7 +8277,7 @@
           <a:bodyPr wrap="square" rtlCol="0" anchor="ctr"/>
           <a:lstStyle/>
           <a:p>
-            <a:pPr marL="0" indent="0">
+            <a:pPr indent="0" marL="0">
               <a:buNone/>
             </a:pPr>
             <a:r>
@@ -8111,7 +8307,9 @@
             <a:ext cx="5120640" cy="347472"/>
           </a:xfrm>
           <a:prstGeom prst="rect">
-            <a:avLst/>
+            <a:avLst>
+              <a:gd name="adj" fmla="val 15789"/>
+            </a:avLst>
           </a:prstGeom>
           <a:solidFill>
             <a:srgbClr val="EFEAE1"/>
@@ -8145,7 +8343,7 @@
           <a:bodyPr wrap="square" rtlCol="0" anchor="ctr"/>
           <a:lstStyle/>
           <a:p>
-            <a:pPr marL="0" indent="0">
+            <a:pPr indent="0" marL="0">
               <a:buNone/>
             </a:pPr>
             <a:r>
@@ -8175,7 +8373,9 @@
             <a:ext cx="5120640" cy="347472"/>
           </a:xfrm>
           <a:prstGeom prst="rect">
-            <a:avLst/>
+            <a:avLst>
+              <a:gd name="adj" fmla="val 15789"/>
+            </a:avLst>
           </a:prstGeom>
           <a:solidFill>
             <a:srgbClr val="FFFFFF"/>
@@ -8209,7 +8409,7 @@
           <a:bodyPr wrap="square" rtlCol="0" anchor="ctr"/>
           <a:lstStyle/>
           <a:p>
-            <a:pPr marL="0" indent="0">
+            <a:pPr indent="0" marL="0">
               <a:buNone/>
             </a:pPr>
             <a:r>
@@ -8239,7 +8439,9 @@
             <a:ext cx="5120640" cy="347472"/>
           </a:xfrm>
           <a:prstGeom prst="rect">
-            <a:avLst/>
+            <a:avLst>
+              <a:gd name="adj" fmla="val 15789"/>
+            </a:avLst>
           </a:prstGeom>
           <a:solidFill>
             <a:srgbClr val="EFEAE1"/>
@@ -8273,7 +8475,7 @@
           <a:bodyPr wrap="square" rtlCol="0" anchor="ctr"/>
           <a:lstStyle/>
           <a:p>
-            <a:pPr marL="0" indent="0">
+            <a:pPr indent="0" marL="0">
               <a:buNone/>
             </a:pPr>
             <a:r>
@@ -8303,7 +8505,9 @@
             <a:ext cx="5120640" cy="347472"/>
           </a:xfrm>
           <a:prstGeom prst="rect">
-            <a:avLst/>
+            <a:avLst>
+              <a:gd name="adj" fmla="val 15789"/>
+            </a:avLst>
           </a:prstGeom>
           <a:solidFill>
             <a:srgbClr val="FFFFFF"/>
@@ -8337,7 +8541,7 @@
           <a:bodyPr wrap="square" rtlCol="0" anchor="ctr"/>
           <a:lstStyle/>
           <a:p>
-            <a:pPr marL="0" indent="0">
+            <a:pPr indent="0" marL="0">
               <a:buNone/>
             </a:pPr>
             <a:r>
@@ -8367,7 +8571,9 @@
             <a:ext cx="5120640" cy="347472"/>
           </a:xfrm>
           <a:prstGeom prst="rect">
-            <a:avLst/>
+            <a:avLst>
+              <a:gd name="adj" fmla="val 15789"/>
+            </a:avLst>
           </a:prstGeom>
           <a:solidFill>
             <a:srgbClr val="FFFFFF"/>
@@ -8401,7 +8607,7 @@
           <a:bodyPr wrap="square" rtlCol="0" anchor="ctr"/>
           <a:lstStyle/>
           <a:p>
-            <a:pPr marL="0" indent="0">
+            <a:pPr indent="0" marL="0">
               <a:buNone/>
             </a:pPr>
             <a:r>
@@ -8431,7 +8637,9 @@
             <a:ext cx="5010912" cy="3703320"/>
           </a:xfrm>
           <a:prstGeom prst="rect">
-            <a:avLst/>
+            <a:avLst>
+              <a:gd name="adj" fmla="val 2963"/>
+            </a:avLst>
           </a:prstGeom>
           <a:solidFill>
             <a:srgbClr val="FFFFFF"/>
@@ -8465,7 +8673,7 @@
           <a:bodyPr wrap="square" rtlCol="0" anchor="ctr"/>
           <a:lstStyle/>
           <a:p>
-            <a:pPr marL="0" indent="0">
+            <a:pPr indent="0" marL="0">
               <a:buNone/>
             </a:pPr>
             <a:r>
@@ -8495,7 +8703,9 @@
             <a:ext cx="4645152" cy="1280160"/>
           </a:xfrm>
           <a:prstGeom prst="rect">
-            <a:avLst/>
+            <a:avLst>
+              <a:gd name="adj" fmla="val 5714"/>
+            </a:avLst>
           </a:prstGeom>
           <a:solidFill>
             <a:srgbClr val="EFEAE1"/>
@@ -8529,7 +8739,7 @@
           <a:bodyPr wrap="square" rtlCol="0" anchor="ctr"/>
           <a:lstStyle/>
           <a:p>
-            <a:pPr marL="0" indent="0">
+            <a:pPr indent="0" marL="0">
               <a:buNone/>
             </a:pPr>
             <a:r>
@@ -8544,6 +8754,9 @@
               <a:t>McCabe Cyclomatic Complexity Derivation:
 </a:t>
             </a:r>
+            <a:pPr indent="0" marL="0">
+              <a:buNone/>
+            </a:pPr>
             <a:r>
               <a:rPr lang="en-US" sz="1400" dirty="0">
                 <a:solidFill>
@@ -8556,6 +8769,9 @@
               <a:t>• Nodes (N) = 10, Edges (E) = 13, Component (P) = 1
 </a:t>
             </a:r>
+            <a:pPr indent="0" marL="0">
+              <a:buNone/>
+            </a:pPr>
             <a:r>
               <a:rPr lang="en-US" sz="1400" b="1" dirty="0">
                 <a:solidFill>
@@ -8568,6 +8784,9 @@
               <a:t>• Formula: V(G) = E - N + 2P = 13 - 10 + 2 = 5
 </a:t>
             </a:r>
+            <a:pPr indent="0" marL="0">
+              <a:buNone/>
+            </a:pPr>
             <a:r>
               <a:rPr lang="en-US" sz="1400" dirty="0">
                 <a:solidFill>
@@ -8595,7 +8814,9 @@
             <a:ext cx="4645152" cy="1417320"/>
           </a:xfrm>
           <a:prstGeom prst="rect">
-            <a:avLst/>
+            <a:avLst>
+              <a:gd name="adj" fmla="val 5161"/>
+            </a:avLst>
           </a:prstGeom>
           <a:solidFill>
             <a:srgbClr val="FFFFFF"/>
@@ -8629,7 +8850,7 @@
           <a:bodyPr wrap="square" rtlCol="0" anchor="ctr"/>
           <a:lstStyle/>
           <a:p>
-            <a:pPr marL="0" indent="0">
+            <a:pPr indent="0" marL="0">
               <a:buNone/>
             </a:pPr>
             <a:r>
@@ -8644,6 +8865,9 @@
               <a:t>Real Coverage.py on Application Code Only:
 </a:t>
             </a:r>
+            <a:pPr indent="0" marL="0">
+              <a:buNone/>
+            </a:pPr>
             <a:r>
               <a:rPr lang="en-US" sz="1300" b="1" dirty="0">
                 <a:solidFill>
@@ -8654,9 +8878,26 @@
                 <a:cs typeface="Inter" pitchFamily="34" charset="-120"/>
               </a:rPr>
               <a:t>• get_client_ip(): 100% statement (8/8) &amp; branch (4/4)
-• evaluate_waste_alert_tier(): 100% statement &amp; branch
 </a:t>
             </a:r>
+            <a:pPr indent="0" marL="0">
+              <a:buNone/>
+            </a:pPr>
+            <a:r>
+              <a:rPr lang="en-US" sz="1300" b="1" dirty="0">
+                <a:solidFill>
+                  <a:srgbClr val="2D6A4F"/>
+                </a:solidFill>
+                <a:latin typeface="Inter" pitchFamily="34" charset="0"/>
+                <a:ea typeface="Inter" pitchFamily="34" charset="-122"/>
+                <a:cs typeface="Inter" pitchFamily="34" charset="-120"/>
+              </a:rPr>
+              <a:t>• evaluate_waste_alert_tier(): 100% statement &amp; branch
+</a:t>
+            </a:r>
+            <a:pPr indent="0" marL="0">
+              <a:buNone/>
+            </a:pPr>
             <a:r>
               <a:rPr lang="en-US" sz="1250" dirty="0">
                 <a:solidFill>
@@ -8782,7 +9023,6 @@
         <a:solidFill>
           <a:srgbClr val="FCF9F4"/>
         </a:solidFill>
-        <a:effectLst/>
       </p:bgPr>
     </p:bg>
     <p:spTree>
@@ -8820,7 +9060,7 @@
           <a:bodyPr wrap="square" rtlCol="0" anchor="ctr"/>
           <a:lstStyle/>
           <a:p>
-            <a:pPr marL="0" indent="0" algn="r">
+            <a:pPr algn="r" indent="0" marL="0">
               <a:buNone/>
             </a:pPr>
             <a:r>
@@ -8859,7 +9099,7 @@
           <a:bodyPr wrap="square" rtlCol="0" anchor="ctr"/>
           <a:lstStyle/>
           <a:p>
-            <a:pPr marL="0" indent="0">
+            <a:pPr indent="0" marL="0">
               <a:buNone/>
             </a:pPr>
             <a:r>
@@ -8912,7 +9152,9 @@
             <a:ext cx="5166360" cy="1463040"/>
           </a:xfrm>
           <a:prstGeom prst="rect">
-            <a:avLst/>
+            <a:avLst>
+              <a:gd name="adj" fmla="val 6250"/>
+            </a:avLst>
           </a:prstGeom>
           <a:solidFill>
             <a:srgbClr val="FFFFFF"/>
@@ -8946,7 +9188,7 @@
           <a:bodyPr wrap="square" rtlCol="0" anchor="ctr"/>
           <a:lstStyle/>
           <a:p>
-            <a:pPr marL="0" indent="0">
+            <a:pPr indent="0" marL="0">
               <a:buNone/>
             </a:pPr>
             <a:r>
@@ -8985,7 +9227,7 @@
           <a:bodyPr wrap="square" rtlCol="0" anchor="ctr"/>
           <a:lstStyle/>
           <a:p>
-            <a:pPr marL="0" indent="0">
+            <a:pPr indent="0" marL="0">
               <a:buNone/>
             </a:pPr>
             <a:r>
@@ -9002,7 +9244,7 @@
             <a:endParaRPr lang="en-US" sz="1400" dirty="0"/>
           </a:p>
           <a:p>
-            <a:pPr marL="0" indent="0">
+            <a:pPr indent="0" marL="0">
               <a:buNone/>
             </a:pPr>
             <a:r>
@@ -9032,7 +9274,9 @@
             <a:ext cx="5193792" cy="1463040"/>
           </a:xfrm>
           <a:prstGeom prst="rect">
-            <a:avLst/>
+            <a:avLst>
+              <a:gd name="adj" fmla="val 6250"/>
+            </a:avLst>
           </a:prstGeom>
           <a:solidFill>
             <a:srgbClr val="FFFFFF"/>
@@ -9066,7 +9310,7 @@
           <a:bodyPr wrap="square" rtlCol="0" anchor="ctr"/>
           <a:lstStyle/>
           <a:p>
-            <a:pPr marL="0" indent="0">
+            <a:pPr indent="0" marL="0">
               <a:buNone/>
             </a:pPr>
             <a:r>
@@ -9105,7 +9349,7 @@
           <a:bodyPr wrap="square" rtlCol="0" anchor="ctr"/>
           <a:lstStyle/>
           <a:p>
-            <a:pPr marL="0" indent="0">
+            <a:pPr indent="0" marL="0">
               <a:buNone/>
             </a:pPr>
             <a:r>
@@ -9122,7 +9366,7 @@
             <a:endParaRPr lang="en-US" sz="1400" dirty="0"/>
           </a:p>
           <a:p>
-            <a:pPr marL="0" indent="0">
+            <a:pPr indent="0" marL="0">
               <a:buNone/>
             </a:pPr>
             <a:r>
@@ -9152,7 +9396,9 @@
             <a:ext cx="2496312" cy="1005840"/>
           </a:xfrm>
           <a:prstGeom prst="rect">
-            <a:avLst/>
+            <a:avLst>
+              <a:gd name="adj" fmla="val 7273"/>
+            </a:avLst>
           </a:prstGeom>
           <a:solidFill>
             <a:srgbClr val="FFFFFF"/>
@@ -9186,7 +9432,7 @@
           <a:bodyPr wrap="square" rtlCol="0" anchor="ctr"/>
           <a:lstStyle/>
           <a:p>
-            <a:pPr marL="0" indent="0" algn="ctr">
+            <a:pPr algn="ctr" indent="0" marL="0">
               <a:buNone/>
             </a:pPr>
             <a:r>
@@ -9225,7 +9471,7 @@
           <a:bodyPr wrap="square" rtlCol="0" anchor="ctr"/>
           <a:lstStyle/>
           <a:p>
-            <a:pPr marL="0" indent="0" algn="ctr">
+            <a:pPr algn="ctr" indent="0" marL="0">
               <a:buNone/>
             </a:pPr>
             <a:r>
@@ -9255,7 +9501,9 @@
             <a:ext cx="2496312" cy="1005840"/>
           </a:xfrm>
           <a:prstGeom prst="rect">
-            <a:avLst/>
+            <a:avLst>
+              <a:gd name="adj" fmla="val 7273"/>
+            </a:avLst>
           </a:prstGeom>
           <a:solidFill>
             <a:srgbClr val="FFFFFF"/>
@@ -9289,7 +9537,7 @@
           <a:bodyPr wrap="square" rtlCol="0" anchor="ctr"/>
           <a:lstStyle/>
           <a:p>
-            <a:pPr marL="0" indent="0" algn="ctr">
+            <a:pPr algn="ctr" indent="0" marL="0">
               <a:buNone/>
             </a:pPr>
             <a:r>
@@ -9328,7 +9576,7 @@
           <a:bodyPr wrap="square" rtlCol="0" anchor="ctr"/>
           <a:lstStyle/>
           <a:p>
-            <a:pPr marL="0" indent="0" algn="ctr">
+            <a:pPr algn="ctr" indent="0" marL="0">
               <a:buNone/>
             </a:pPr>
             <a:r>
@@ -9358,7 +9606,9 @@
             <a:ext cx="2496312" cy="1005840"/>
           </a:xfrm>
           <a:prstGeom prst="rect">
-            <a:avLst/>
+            <a:avLst>
+              <a:gd name="adj" fmla="val 7273"/>
+            </a:avLst>
           </a:prstGeom>
           <a:solidFill>
             <a:srgbClr val="FFFFFF"/>
@@ -9392,7 +9642,7 @@
           <a:bodyPr wrap="square" rtlCol="0" anchor="ctr"/>
           <a:lstStyle/>
           <a:p>
-            <a:pPr marL="0" indent="0" algn="ctr">
+            <a:pPr algn="ctr" indent="0" marL="0">
               <a:buNone/>
             </a:pPr>
             <a:r>
@@ -9431,7 +9681,7 @@
           <a:bodyPr wrap="square" rtlCol="0" anchor="ctr"/>
           <a:lstStyle/>
           <a:p>
-            <a:pPr marL="0" indent="0" algn="ctr">
+            <a:pPr algn="ctr" indent="0" marL="0">
               <a:buNone/>
             </a:pPr>
             <a:r>
@@ -9461,7 +9711,9 @@
             <a:ext cx="2496312" cy="1005840"/>
           </a:xfrm>
           <a:prstGeom prst="rect">
-            <a:avLst/>
+            <a:avLst>
+              <a:gd name="adj" fmla="val 7273"/>
+            </a:avLst>
           </a:prstGeom>
           <a:solidFill>
             <a:srgbClr val="FFFFFF"/>
@@ -9495,7 +9747,7 @@
           <a:bodyPr wrap="square" rtlCol="0" anchor="ctr"/>
           <a:lstStyle/>
           <a:p>
-            <a:pPr marL="0" indent="0" algn="ctr">
+            <a:pPr algn="ctr" indent="0" marL="0">
               <a:buNone/>
             </a:pPr>
             <a:r>
@@ -9534,7 +9786,7 @@
           <a:bodyPr wrap="square" rtlCol="0" anchor="ctr"/>
           <a:lstStyle/>
           <a:p>
-            <a:pPr marL="0" indent="0" algn="ctr">
+            <a:pPr algn="ctr" indent="0" marL="0">
               <a:buNone/>
             </a:pPr>
             <a:r>
@@ -9564,7 +9816,9 @@
             <a:ext cx="10728655" cy="868680"/>
           </a:xfrm>
           <a:prstGeom prst="rect">
-            <a:avLst/>
+            <a:avLst>
+              <a:gd name="adj" fmla="val 8421"/>
+            </a:avLst>
           </a:prstGeom>
           <a:solidFill>
             <a:srgbClr val="EFEAE1"/>
@@ -9598,7 +9852,7 @@
           <a:bodyPr wrap="square" rtlCol="0" anchor="ctr"/>
           <a:lstStyle/>
           <a:p>
-            <a:pPr marL="0" indent="0">
+            <a:pPr indent="0" marL="0">
               <a:buNone/>
             </a:pPr>
             <a:r>
@@ -9637,7 +9891,7 @@
           <a:bodyPr wrap="square" rtlCol="0" anchor="ctr"/>
           <a:lstStyle/>
           <a:p>
-            <a:pPr marL="0" indent="0">
+            <a:pPr indent="0" marL="0">
               <a:buNone/>
             </a:pPr>
             <a:r>
@@ -9651,6 +9905,9 @@
               </a:rPr>
               <a:t>• Backend CI: </a:t>
             </a:r>
+            <a:pPr indent="0" marL="0">
+              <a:buNone/>
+            </a:pPr>
             <a:r>
               <a:rPr lang="en-US" sz="1400" b="1" dirty="0">
                 <a:solidFill>
@@ -9663,6 +9920,9 @@
               <a:t>PASSING (23s runtime)
 </a:t>
             </a:r>
+            <a:pPr indent="0" marL="0">
+              <a:buNone/>
+            </a:pPr>
             <a:r>
               <a:rPr lang="en-US" sz="1400" b="1" dirty="0">
                 <a:solidFill>
@@ -9674,6 +9934,9 @@
               </a:rPr>
               <a:t>• Flutter CI: </a:t>
             </a:r>
+            <a:pPr indent="0" marL="0">
+              <a:buNone/>
+            </a:pPr>
             <a:r>
               <a:rPr lang="en-US" sz="1400" dirty="0">
                 <a:solidFill>
@@ -9686,6 +9949,9 @@
               <a:t>FAILING on remote (6 unused imports fixed locally in commit 15b98b22, unpushed)
 </a:t>
             </a:r>
+            <a:pPr indent="0" marL="0">
+              <a:buNone/>
+            </a:pPr>
             <a:r>
               <a:rPr lang="en-US" sz="1400" b="1" dirty="0">
                 <a:solidFill>
@@ -9697,6 +9963,9 @@
               </a:rPr>
               <a:t>• Keepalive: </a:t>
             </a:r>
+            <a:pPr indent="0" marL="0">
+              <a:buNone/>
+            </a:pPr>
             <a:r>
               <a:rPr lang="en-US" sz="1400" b="1" dirty="0">
                 <a:solidFill>
@@ -9822,7 +10091,6 @@
         <a:solidFill>
           <a:srgbClr val="FCF9F4"/>
         </a:solidFill>
-        <a:effectLst/>
       </p:bgPr>
     </p:bg>
     <p:spTree>
@@ -9860,7 +10128,7 @@
           <a:bodyPr wrap="square" rtlCol="0" anchor="ctr"/>
           <a:lstStyle/>
           <a:p>
-            <a:pPr marL="0" indent="0" algn="r">
+            <a:pPr algn="r" indent="0" marL="0">
               <a:buNone/>
             </a:pPr>
             <a:r>
@@ -9899,7 +10167,7 @@
           <a:bodyPr wrap="square" rtlCol="0" anchor="ctr"/>
           <a:lstStyle/>
           <a:p>
-            <a:pPr marL="0" indent="0">
+            <a:pPr indent="0" marL="0">
               <a:buNone/>
             </a:pPr>
             <a:r>
@@ -9952,7 +10220,9 @@
             <a:ext cx="10728655" cy="1051560"/>
           </a:xfrm>
           <a:prstGeom prst="rect">
-            <a:avLst/>
+            <a:avLst>
+              <a:gd name="adj" fmla="val 8696"/>
+            </a:avLst>
           </a:prstGeom>
           <a:solidFill>
             <a:srgbClr val="FFFFFF"/>
@@ -9986,7 +10256,7 @@
           <a:bodyPr wrap="square" rtlCol="0" anchor="ctr"/>
           <a:lstStyle/>
           <a:p>
-            <a:pPr marL="0" indent="0">
+            <a:pPr indent="0" marL="0">
               <a:buNone/>
             </a:pPr>
             <a:r>
@@ -10016,7 +10286,9 @@
             <a:ext cx="3291840" cy="621792"/>
           </a:xfrm>
           <a:prstGeom prst="rect">
-            <a:avLst/>
+            <a:avLst>
+              <a:gd name="adj" fmla="val 8824"/>
+            </a:avLst>
           </a:prstGeom>
           <a:solidFill>
             <a:srgbClr val="EFEAE1"/>
@@ -10050,7 +10322,7 @@
           <a:bodyPr wrap="square" rtlCol="0" anchor="ctr"/>
           <a:lstStyle/>
           <a:p>
-            <a:pPr marL="0" indent="0">
+            <a:pPr indent="0" marL="0">
               <a:buNone/>
             </a:pPr>
             <a:r>
@@ -10089,7 +10361,7 @@
           <a:bodyPr wrap="square" rtlCol="0" anchor="ctr"/>
           <a:lstStyle/>
           <a:p>
-            <a:pPr marL="0" indent="0">
+            <a:pPr indent="0" marL="0">
               <a:buNone/>
             </a:pPr>
             <a:r>
@@ -10119,7 +10391,9 @@
             <a:ext cx="3291840" cy="621792"/>
           </a:xfrm>
           <a:prstGeom prst="rect">
-            <a:avLst/>
+            <a:avLst>
+              <a:gd name="adj" fmla="val 8824"/>
+            </a:avLst>
           </a:prstGeom>
           <a:solidFill>
             <a:srgbClr val="EFEAE1"/>
@@ -10153,7 +10427,7 @@
           <a:bodyPr wrap="square" rtlCol="0" anchor="ctr"/>
           <a:lstStyle/>
           <a:p>
-            <a:pPr marL="0" indent="0">
+            <a:pPr indent="0" marL="0">
               <a:buNone/>
             </a:pPr>
             <a:r>
@@ -10192,7 +10466,7 @@
           <a:bodyPr wrap="square" rtlCol="0" anchor="ctr"/>
           <a:lstStyle/>
           <a:p>
-            <a:pPr marL="0" indent="0">
+            <a:pPr indent="0" marL="0">
               <a:buNone/>
             </a:pPr>
             <a:r>
@@ -10222,7 +10496,9 @@
             <a:ext cx="3291840" cy="621792"/>
           </a:xfrm>
           <a:prstGeom prst="rect">
-            <a:avLst/>
+            <a:avLst>
+              <a:gd name="adj" fmla="val 8824"/>
+            </a:avLst>
           </a:prstGeom>
           <a:solidFill>
             <a:srgbClr val="EFEAE1"/>
@@ -10256,7 +10532,7 @@
           <a:bodyPr wrap="square" rtlCol="0" anchor="ctr"/>
           <a:lstStyle/>
           <a:p>
-            <a:pPr marL="0" indent="0">
+            <a:pPr indent="0" marL="0">
               <a:buNone/>
             </a:pPr>
             <a:r>
@@ -10295,7 +10571,7 @@
           <a:bodyPr wrap="square" rtlCol="0" anchor="ctr"/>
           <a:lstStyle/>
           <a:p>
-            <a:pPr marL="0" indent="0">
+            <a:pPr indent="0" marL="0">
               <a:buNone/>
             </a:pPr>
             <a:r>
@@ -10315,7 +10591,7 @@
       </p:sp>
       <p:graphicFrame>
         <p:nvGraphicFramePr>
-          <p:cNvPr id="16" name="Table 0"/>
+          <p:cNvPr id="8" name="Table 0"/>
           <p:cNvGraphicFramePr>
             <a:graphicFrameLocks noGrp="1"/>
           </p:cNvGraphicFramePr>
@@ -10329,41 +10605,17 @@
         </p:nvGraphicFramePr>
         <p:xfrm>
           <a:off x="731520" y="2423160"/>
-          <a:ext cx="10728655" cy="2487168"/>
+          <a:ext cx="10728655" cy="2286000"/>
         </p:xfrm>
         <a:graphic>
           <a:graphicData uri="http://schemas.openxmlformats.org/drawingml/2006/table">
             <a:tbl>
               <a:tblPr/>
               <a:tblGrid>
-                <a:gridCol w="1463040">
-                  <a:extLst>
-                    <a:ext uri="{9D8B030D-6E8A-4147-A177-3AD203B41FA5}">
-                      <a16:colId xmlns:a16="http://schemas.microsoft.com/office/drawing/2014/main" val="20000"/>
-                    </a:ext>
-                  </a:extLst>
-                </a:gridCol>
-                <a:gridCol w="5242255">
-                  <a:extLst>
-                    <a:ext uri="{9D8B030D-6E8A-4147-A177-3AD203B41FA5}">
-                      <a16:colId xmlns:a16="http://schemas.microsoft.com/office/drawing/2014/main" val="20001"/>
-                    </a:ext>
-                  </a:extLst>
-                </a:gridCol>
-                <a:gridCol w="1645920">
-                  <a:extLst>
-                    <a:ext uri="{9D8B030D-6E8A-4147-A177-3AD203B41FA5}">
-                      <a16:colId xmlns:a16="http://schemas.microsoft.com/office/drawing/2014/main" val="20002"/>
-                    </a:ext>
-                  </a:extLst>
-                </a:gridCol>
-                <a:gridCol w="2377440">
-                  <a:extLst>
-                    <a:ext uri="{9D8B030D-6E8A-4147-A177-3AD203B41FA5}">
-                      <a16:colId xmlns:a16="http://schemas.microsoft.com/office/drawing/2014/main" val="20003"/>
-                    </a:ext>
-                  </a:extLst>
-                </a:gridCol>
+                <a:gridCol w="1463040"/>
+                <a:gridCol w="5242255"/>
+                <a:gridCol w="1645920"/>
+                <a:gridCol w="2377440"/>
               </a:tblGrid>
               <a:tr h="384048">
                 <a:tc>
@@ -10371,7 +10623,7 @@
                     <a:bodyPr/>
                     <a:lstStyle/>
                     <a:p>
-                      <a:pPr marL="0" indent="0" algn="ctr">
+                      <a:pPr algn="ctr" indent="0" marL="0">
                         <a:buNone/>
                       </a:pPr>
                       <a:r>
@@ -10392,7 +10644,7 @@
                       </a:endParaRPr>
                     </a:p>
                   </a:txBody>
-                  <a:tcPr>
+                  <a:tcPr marL="91440" marR="91440" marT="45720" marB="45720">
                     <a:lnL w="6350" cap="flat" cmpd="sng" algn="ctr">
                       <a:solidFill>
                         <a:srgbClr val="E5E0D8"/>
@@ -10439,7 +10691,7 @@
                     <a:bodyPr/>
                     <a:lstStyle/>
                     <a:p>
-                      <a:pPr marL="0" indent="0">
+                      <a:pPr indent="0" marL="0">
                         <a:buNone/>
                       </a:pPr>
                       <a:r>
@@ -10460,7 +10712,7 @@
                       </a:endParaRPr>
                     </a:p>
                   </a:txBody>
-                  <a:tcPr>
+                  <a:tcPr marL="91440" marR="91440" marT="45720" marB="45720">
                     <a:lnL w="6350" cap="flat" cmpd="sng" algn="ctr">
                       <a:solidFill>
                         <a:srgbClr val="E5E0D8"/>
@@ -10507,7 +10759,7 @@
                     <a:bodyPr/>
                     <a:lstStyle/>
                     <a:p>
-                      <a:pPr marL="0" indent="0" algn="ctr">
+                      <a:pPr algn="ctr" indent="0" marL="0">
                         <a:buNone/>
                       </a:pPr>
                       <a:r>
@@ -10528,7 +10780,7 @@
                       </a:endParaRPr>
                     </a:p>
                   </a:txBody>
-                  <a:tcPr>
+                  <a:tcPr marL="91440" marR="91440" marT="45720" marB="45720">
                     <a:lnL w="6350" cap="flat" cmpd="sng" algn="ctr">
                       <a:solidFill>
                         <a:srgbClr val="E5E0D8"/>
@@ -10575,7 +10827,7 @@
                     <a:bodyPr/>
                     <a:lstStyle/>
                     <a:p>
-                      <a:pPr marL="0" indent="0" algn="ctr">
+                      <a:pPr algn="ctr" indent="0" marL="0">
                         <a:buNone/>
                       </a:pPr>
                       <a:r>
@@ -10596,7 +10848,7 @@
                       </a:endParaRPr>
                     </a:p>
                   </a:txBody>
-                  <a:tcPr>
+                  <a:tcPr marL="91440" marR="91440" marT="45720" marB="45720">
                     <a:lnL w="6350" cap="flat" cmpd="sng" algn="ctr">
                       <a:solidFill>
                         <a:srgbClr val="E5E0D8"/>
@@ -10638,11 +10890,6 @@
                     </a:solidFill>
                   </a:tcPr>
                 </a:tc>
-                <a:extLst>
-                  <a:ext uri="{0D108BD9-81ED-4DB2-BD59-A6C34878D82A}">
-                    <a16:rowId xmlns:a16="http://schemas.microsoft.com/office/drawing/2014/main" val="10000"/>
-                  </a:ext>
-                </a:extLst>
               </a:tr>
               <a:tr h="365760">
                 <a:tc>
@@ -10650,7 +10897,7 @@
                     <a:bodyPr/>
                     <a:lstStyle/>
                     <a:p>
-                      <a:pPr marL="0" indent="0">
+                      <a:pPr indent="0" marL="0">
                         <a:buNone/>
                       </a:pPr>
                       <a:r>
@@ -10671,7 +10918,7 @@
                       </a:endParaRPr>
                     </a:p>
                   </a:txBody>
-                  <a:tcPr>
+                  <a:tcPr marL="91440" marR="91440" marT="45720" marB="45720">
                     <a:lnL w="6350" cap="flat" cmpd="sng" algn="ctr">
                       <a:solidFill>
                         <a:srgbClr val="E5E0D8"/>
@@ -10718,7 +10965,7 @@
                     <a:bodyPr/>
                     <a:lstStyle/>
                     <a:p>
-                      <a:pPr marL="0" indent="0">
+                      <a:pPr indent="0" marL="0">
                         <a:buNone/>
                       </a:pPr>
                       <a:r>
@@ -10739,7 +10986,7 @@
                       </a:endParaRPr>
                     </a:p>
                   </a:txBody>
-                  <a:tcPr>
+                  <a:tcPr marL="91440" marR="91440" marT="45720" marB="45720">
                     <a:lnL w="6350" cap="flat" cmpd="sng" algn="ctr">
                       <a:solidFill>
                         <a:srgbClr val="E5E0D8"/>
@@ -10786,7 +11033,7 @@
                     <a:bodyPr/>
                     <a:lstStyle/>
                     <a:p>
-                      <a:pPr marL="0" indent="0">
+                      <a:pPr indent="0" marL="0">
                         <a:buNone/>
                       </a:pPr>
                       <a:r>
@@ -10807,7 +11054,7 @@
                       </a:endParaRPr>
                     </a:p>
                   </a:txBody>
-                  <a:tcPr>
+                  <a:tcPr marL="91440" marR="91440" marT="45720" marB="45720">
                     <a:lnL w="6350" cap="flat" cmpd="sng" algn="ctr">
                       <a:solidFill>
                         <a:srgbClr val="E5E0D8"/>
@@ -10854,7 +11101,7 @@
                     <a:bodyPr/>
                     <a:lstStyle/>
                     <a:p>
-                      <a:pPr marL="0" indent="0">
+                      <a:pPr indent="0" marL="0">
                         <a:buNone/>
                       </a:pPr>
                       <a:r>
@@ -10875,7 +11122,7 @@
                       </a:endParaRPr>
                     </a:p>
                   </a:txBody>
-                  <a:tcPr>
+                  <a:tcPr marL="91440" marR="91440" marT="45720" marB="45720">
                     <a:lnL w="6350" cap="flat" cmpd="sng" algn="ctr">
                       <a:solidFill>
                         <a:srgbClr val="E5E0D8"/>
@@ -10917,11 +11164,6 @@
                     </a:solidFill>
                   </a:tcPr>
                 </a:tc>
-                <a:extLst>
-                  <a:ext uri="{0D108BD9-81ED-4DB2-BD59-A6C34878D82A}">
-                    <a16:rowId xmlns:a16="http://schemas.microsoft.com/office/drawing/2014/main" val="10001"/>
-                  </a:ext>
-                </a:extLst>
               </a:tr>
               <a:tr h="365760">
                 <a:tc>
@@ -10929,7 +11171,7 @@
                     <a:bodyPr/>
                     <a:lstStyle/>
                     <a:p>
-                      <a:pPr marL="0" indent="0">
+                      <a:pPr indent="0" marL="0">
                         <a:buNone/>
                       </a:pPr>
                       <a:r>
@@ -10950,7 +11192,7 @@
                       </a:endParaRPr>
                     </a:p>
                   </a:txBody>
-                  <a:tcPr>
+                  <a:tcPr marL="91440" marR="91440" marT="45720" marB="45720">
                     <a:lnL w="6350" cap="flat" cmpd="sng" algn="ctr">
                       <a:solidFill>
                         <a:srgbClr val="E5E0D8"/>
@@ -10997,7 +11239,7 @@
                     <a:bodyPr/>
                     <a:lstStyle/>
                     <a:p>
-                      <a:pPr marL="0" indent="0">
+                      <a:pPr indent="0" marL="0">
                         <a:buNone/>
                       </a:pPr>
                       <a:r>
@@ -11018,7 +11260,7 @@
                       </a:endParaRPr>
                     </a:p>
                   </a:txBody>
-                  <a:tcPr>
+                  <a:tcPr marL="91440" marR="91440" marT="45720" marB="45720">
                     <a:lnL w="6350" cap="flat" cmpd="sng" algn="ctr">
                       <a:solidFill>
                         <a:srgbClr val="E5E0D8"/>
@@ -11065,7 +11307,7 @@
                     <a:bodyPr/>
                     <a:lstStyle/>
                     <a:p>
-                      <a:pPr marL="0" indent="0">
+                      <a:pPr indent="0" marL="0">
                         <a:buNone/>
                       </a:pPr>
                       <a:r>
@@ -11086,7 +11328,7 @@
                       </a:endParaRPr>
                     </a:p>
                   </a:txBody>
-                  <a:tcPr>
+                  <a:tcPr marL="91440" marR="91440" marT="45720" marB="45720">
                     <a:lnL w="6350" cap="flat" cmpd="sng" algn="ctr">
                       <a:solidFill>
                         <a:srgbClr val="E5E0D8"/>
@@ -11133,7 +11375,7 @@
                     <a:bodyPr/>
                     <a:lstStyle/>
                     <a:p>
-                      <a:pPr marL="0" indent="0">
+                      <a:pPr indent="0" marL="0">
                         <a:buNone/>
                       </a:pPr>
                       <a:r>
@@ -11154,7 +11396,7 @@
                       </a:endParaRPr>
                     </a:p>
                   </a:txBody>
-                  <a:tcPr>
+                  <a:tcPr marL="91440" marR="91440" marT="45720" marB="45720">
                     <a:lnL w="6350" cap="flat" cmpd="sng" algn="ctr">
                       <a:solidFill>
                         <a:srgbClr val="E5E0D8"/>
@@ -11196,11 +11438,6 @@
                     </a:solidFill>
                   </a:tcPr>
                 </a:tc>
-                <a:extLst>
-                  <a:ext uri="{0D108BD9-81ED-4DB2-BD59-A6C34878D82A}">
-                    <a16:rowId xmlns:a16="http://schemas.microsoft.com/office/drawing/2014/main" val="10002"/>
-                  </a:ext>
-                </a:extLst>
               </a:tr>
               <a:tr h="365760">
                 <a:tc>
@@ -11208,7 +11445,7 @@
                     <a:bodyPr/>
                     <a:lstStyle/>
                     <a:p>
-                      <a:pPr marL="0" indent="0">
+                      <a:pPr indent="0" marL="0">
                         <a:buNone/>
                       </a:pPr>
                       <a:r>
@@ -11229,7 +11466,7 @@
                       </a:endParaRPr>
                     </a:p>
                   </a:txBody>
-                  <a:tcPr>
+                  <a:tcPr marL="91440" marR="91440" marT="45720" marB="45720">
                     <a:lnL w="6350" cap="flat" cmpd="sng" algn="ctr">
                       <a:solidFill>
                         <a:srgbClr val="E5E0D8"/>
@@ -11276,7 +11513,7 @@
                     <a:bodyPr/>
                     <a:lstStyle/>
                     <a:p>
-                      <a:pPr marL="0" indent="0">
+                      <a:pPr indent="0" marL="0">
                         <a:buNone/>
                       </a:pPr>
                       <a:r>
@@ -11297,7 +11534,7 @@
                       </a:endParaRPr>
                     </a:p>
                   </a:txBody>
-                  <a:tcPr>
+                  <a:tcPr marL="91440" marR="91440" marT="45720" marB="45720">
                     <a:lnL w="6350" cap="flat" cmpd="sng" algn="ctr">
                       <a:solidFill>
                         <a:srgbClr val="E5E0D8"/>
@@ -11344,7 +11581,7 @@
                     <a:bodyPr/>
                     <a:lstStyle/>
                     <a:p>
-                      <a:pPr marL="0" indent="0">
+                      <a:pPr indent="0" marL="0">
                         <a:buNone/>
                       </a:pPr>
                       <a:r>
@@ -11365,7 +11602,7 @@
                       </a:endParaRPr>
                     </a:p>
                   </a:txBody>
-                  <a:tcPr>
+                  <a:tcPr marL="91440" marR="91440" marT="45720" marB="45720">
                     <a:lnL w="6350" cap="flat" cmpd="sng" algn="ctr">
                       <a:solidFill>
                         <a:srgbClr val="E5E0D8"/>
@@ -11412,7 +11649,7 @@
                     <a:bodyPr/>
                     <a:lstStyle/>
                     <a:p>
-                      <a:pPr marL="0" indent="0">
+                      <a:pPr indent="0" marL="0">
                         <a:buNone/>
                       </a:pPr>
                       <a:r>
@@ -11433,7 +11670,7 @@
                       </a:endParaRPr>
                     </a:p>
                   </a:txBody>
-                  <a:tcPr>
+                  <a:tcPr marL="91440" marR="91440" marT="45720" marB="45720">
                     <a:lnL w="6350" cap="flat" cmpd="sng" algn="ctr">
                       <a:solidFill>
                         <a:srgbClr val="E5E0D8"/>
@@ -11475,11 +11712,6 @@
                     </a:solidFill>
                   </a:tcPr>
                 </a:tc>
-                <a:extLst>
-                  <a:ext uri="{0D108BD9-81ED-4DB2-BD59-A6C34878D82A}">
-                    <a16:rowId xmlns:a16="http://schemas.microsoft.com/office/drawing/2014/main" val="10003"/>
-                  </a:ext>
-                </a:extLst>
               </a:tr>
               <a:tr h="365760">
                 <a:tc>
@@ -11487,7 +11719,7 @@
                     <a:bodyPr/>
                     <a:lstStyle/>
                     <a:p>
-                      <a:pPr marL="0" indent="0">
+                      <a:pPr indent="0" marL="0">
                         <a:buNone/>
                       </a:pPr>
                       <a:r>
@@ -11508,7 +11740,7 @@
                       </a:endParaRPr>
                     </a:p>
                   </a:txBody>
-                  <a:tcPr>
+                  <a:tcPr marL="91440" marR="91440" marT="45720" marB="45720">
                     <a:lnL w="6350" cap="flat" cmpd="sng" algn="ctr">
                       <a:solidFill>
                         <a:srgbClr val="E5E0D8"/>
@@ -11555,7 +11787,7 @@
                     <a:bodyPr/>
                     <a:lstStyle/>
                     <a:p>
-                      <a:pPr marL="0" indent="0">
+                      <a:pPr indent="0" marL="0">
                         <a:buNone/>
                       </a:pPr>
                       <a:r>
@@ -11576,7 +11808,7 @@
                       </a:endParaRPr>
                     </a:p>
                   </a:txBody>
-                  <a:tcPr>
+                  <a:tcPr marL="91440" marR="91440" marT="45720" marB="45720">
                     <a:lnL w="6350" cap="flat" cmpd="sng" algn="ctr">
                       <a:solidFill>
                         <a:srgbClr val="E5E0D8"/>
@@ -11623,7 +11855,7 @@
                     <a:bodyPr/>
                     <a:lstStyle/>
                     <a:p>
-                      <a:pPr marL="0" indent="0">
+                      <a:pPr indent="0" marL="0">
                         <a:buNone/>
                       </a:pPr>
                       <a:r>
@@ -11644,7 +11876,7 @@
                       </a:endParaRPr>
                     </a:p>
                   </a:txBody>
-                  <a:tcPr>
+                  <a:tcPr marL="91440" marR="91440" marT="45720" marB="45720">
                     <a:lnL w="6350" cap="flat" cmpd="sng" algn="ctr">
                       <a:solidFill>
                         <a:srgbClr val="E5E0D8"/>
@@ -11691,7 +11923,7 @@
                     <a:bodyPr/>
                     <a:lstStyle/>
                     <a:p>
-                      <a:pPr marL="0" indent="0">
+                      <a:pPr indent="0" marL="0">
                         <a:buNone/>
                       </a:pPr>
                       <a:r>
@@ -11712,7 +11944,7 @@
                       </a:endParaRPr>
                     </a:p>
                   </a:txBody>
-                  <a:tcPr>
+                  <a:tcPr marL="91440" marR="91440" marT="45720" marB="45720">
                     <a:lnL w="6350" cap="flat" cmpd="sng" algn="ctr">
                       <a:solidFill>
                         <a:srgbClr val="E5E0D8"/>
@@ -11754,11 +11986,6 @@
                     </a:solidFill>
                   </a:tcPr>
                 </a:tc>
-                <a:extLst>
-                  <a:ext uri="{0D108BD9-81ED-4DB2-BD59-A6C34878D82A}">
-                    <a16:rowId xmlns:a16="http://schemas.microsoft.com/office/drawing/2014/main" val="10004"/>
-                  </a:ext>
-                </a:extLst>
               </a:tr>
               <a:tr h="365760">
                 <a:tc>
@@ -11766,7 +11993,7 @@
                     <a:bodyPr/>
                     <a:lstStyle/>
                     <a:p>
-                      <a:pPr marL="0" indent="0">
+                      <a:pPr indent="0" marL="0">
                         <a:buNone/>
                       </a:pPr>
                       <a:r>
@@ -11787,7 +12014,7 @@
                       </a:endParaRPr>
                     </a:p>
                   </a:txBody>
-                  <a:tcPr>
+                  <a:tcPr marL="91440" marR="91440" marT="45720" marB="45720">
                     <a:lnL w="6350" cap="flat" cmpd="sng" algn="ctr">
                       <a:solidFill>
                         <a:srgbClr val="E5E0D8"/>
@@ -11834,7 +12061,7 @@
                     <a:bodyPr/>
                     <a:lstStyle/>
                     <a:p>
-                      <a:pPr marL="0" indent="0">
+                      <a:pPr indent="0" marL="0">
                         <a:buNone/>
                       </a:pPr>
                       <a:r>
@@ -11855,7 +12082,7 @@
                       </a:endParaRPr>
                     </a:p>
                   </a:txBody>
-                  <a:tcPr>
+                  <a:tcPr marL="91440" marR="91440" marT="45720" marB="45720">
                     <a:lnL w="6350" cap="flat" cmpd="sng" algn="ctr">
                       <a:solidFill>
                         <a:srgbClr val="E5E0D8"/>
@@ -11902,7 +12129,7 @@
                     <a:bodyPr/>
                     <a:lstStyle/>
                     <a:p>
-                      <a:pPr marL="0" indent="0">
+                      <a:pPr indent="0" marL="0">
                         <a:buNone/>
                       </a:pPr>
                       <a:r>
@@ -11923,7 +12150,7 @@
                       </a:endParaRPr>
                     </a:p>
                   </a:txBody>
-                  <a:tcPr>
+                  <a:tcPr marL="91440" marR="91440" marT="45720" marB="45720">
                     <a:lnL w="6350" cap="flat" cmpd="sng" algn="ctr">
                       <a:solidFill>
                         <a:srgbClr val="E5E0D8"/>
@@ -11970,7 +12197,7 @@
                     <a:bodyPr/>
                     <a:lstStyle/>
                     <a:p>
-                      <a:pPr marL="0" indent="0">
+                      <a:pPr indent="0" marL="0">
                         <a:buNone/>
                       </a:pPr>
                       <a:r>
@@ -11991,7 +12218,7 @@
                       </a:endParaRPr>
                     </a:p>
                   </a:txBody>
-                  <a:tcPr>
+                  <a:tcPr marL="91440" marR="91440" marT="45720" marB="45720">
                     <a:lnL w="6350" cap="flat" cmpd="sng" algn="ctr">
                       <a:solidFill>
                         <a:srgbClr val="E5E0D8"/>
@@ -12033,11 +12260,6 @@
                     </a:solidFill>
                   </a:tcPr>
                 </a:tc>
-                <a:extLst>
-                  <a:ext uri="{0D108BD9-81ED-4DB2-BD59-A6C34878D82A}">
-                    <a16:rowId xmlns:a16="http://schemas.microsoft.com/office/drawing/2014/main" val="10005"/>
-                  </a:ext>
-                </a:extLst>
               </a:tr>
             </a:tbl>
           </a:graphicData>
@@ -12153,7 +12375,6 @@
         <a:solidFill>
           <a:srgbClr val="FCF9F4"/>
         </a:solidFill>
-        <a:effectLst/>
       </p:bgPr>
     </p:bg>
     <p:spTree>
@@ -12191,7 +12412,7 @@
           <a:bodyPr wrap="square" rtlCol="0" anchor="ctr"/>
           <a:lstStyle/>
           <a:p>
-            <a:pPr marL="0" indent="0" algn="r">
+            <a:pPr algn="r" indent="0" marL="0">
               <a:buNone/>
             </a:pPr>
             <a:r>
@@ -12230,7 +12451,7 @@
           <a:bodyPr wrap="square" rtlCol="0" anchor="ctr"/>
           <a:lstStyle/>
           <a:p>
-            <a:pPr marL="0" indent="0">
+            <a:pPr indent="0" marL="0">
               <a:buNone/>
             </a:pPr>
             <a:r>
@@ -12283,7 +12504,9 @@
             <a:ext cx="5166360" cy="3703320"/>
           </a:xfrm>
           <a:prstGeom prst="rect">
-            <a:avLst/>
+            <a:avLst>
+              <a:gd name="adj" fmla="val 2963"/>
+            </a:avLst>
           </a:prstGeom>
           <a:solidFill>
             <a:srgbClr val="FFFFFF"/>
@@ -12317,7 +12540,7 @@
           <a:bodyPr wrap="square" rtlCol="0" anchor="ctr"/>
           <a:lstStyle/>
           <a:p>
-            <a:pPr marL="0" indent="0">
+            <a:pPr indent="0" marL="0">
               <a:buNone/>
             </a:pPr>
             <a:r>
@@ -12356,7 +12579,7 @@
           <a:bodyPr wrap="square" rtlCol="0" anchor="t"/>
           <a:lstStyle/>
           <a:p>
-            <a:pPr marL="0" indent="0">
+            <a:pPr indent="0" marL="0">
               <a:spcAft>
                 <a:spcPts val="400"/>
               </a:spcAft>
@@ -12372,14 +12595,150 @@
                 <a:cs typeface="Inter" pitchFamily="34" charset="-120"/>
               </a:rPr>
               <a:t>1. GET /health: Ping MongoDB Atlas connection
-2. POST /auth/login: JWT token authentication &amp; issue
-3. GET /items: Verify seeded inventory catalog
-4. batch_forecast.py: Run ML forecast pipeline
-5. GET /forecasts/today: Check dashboard estimates
-6. GET /forecasts/{id}: Validate 7-day forecast curve
-7. POST /items/{id}/restock: One-tap stock increment (+15)
-8. POST /sales/intraday: Log POS sales event to Atlas
-9. GET /waste-alerts: Trigger waste action engine rule</a:t>
+</a:t>
+            </a:r>
+            <a:pPr indent="0" marL="0">
+              <a:spcAft>
+                <a:spcPts val="400"/>
+              </a:spcAft>
+              <a:buNone/>
+            </a:pPr>
+            <a:r>
+              <a:rPr lang="en-US" sz="1250" dirty="0">
+                <a:solidFill>
+                  <a:srgbClr val="1C1C19"/>
+                </a:solidFill>
+                <a:latin typeface="Inter" pitchFamily="34" charset="0"/>
+                <a:ea typeface="Inter" pitchFamily="34" charset="-122"/>
+                <a:cs typeface="Inter" pitchFamily="34" charset="-120"/>
+              </a:rPr>
+              <a:t>2. POST /auth/login: JWT token authentication &amp; issue
+</a:t>
+            </a:r>
+            <a:pPr indent="0" marL="0">
+              <a:spcAft>
+                <a:spcPts val="400"/>
+              </a:spcAft>
+              <a:buNone/>
+            </a:pPr>
+            <a:r>
+              <a:rPr lang="en-US" sz="1250" dirty="0">
+                <a:solidFill>
+                  <a:srgbClr val="1C1C19"/>
+                </a:solidFill>
+                <a:latin typeface="Inter" pitchFamily="34" charset="0"/>
+                <a:ea typeface="Inter" pitchFamily="34" charset="-122"/>
+                <a:cs typeface="Inter" pitchFamily="34" charset="-120"/>
+              </a:rPr>
+              <a:t>3. GET /items: Verify seeded inventory catalog
+</a:t>
+            </a:r>
+            <a:pPr indent="0" marL="0">
+              <a:spcAft>
+                <a:spcPts val="400"/>
+              </a:spcAft>
+              <a:buNone/>
+            </a:pPr>
+            <a:r>
+              <a:rPr lang="en-US" sz="1250" dirty="0">
+                <a:solidFill>
+                  <a:srgbClr val="1C1C19"/>
+                </a:solidFill>
+                <a:latin typeface="Inter" pitchFamily="34" charset="0"/>
+                <a:ea typeface="Inter" pitchFamily="34" charset="-122"/>
+                <a:cs typeface="Inter" pitchFamily="34" charset="-120"/>
+              </a:rPr>
+              <a:t>4. batch_forecast.py: Run ML forecast pipeline
+</a:t>
+            </a:r>
+            <a:pPr indent="0" marL="0">
+              <a:spcAft>
+                <a:spcPts val="400"/>
+              </a:spcAft>
+              <a:buNone/>
+            </a:pPr>
+            <a:r>
+              <a:rPr lang="en-US" sz="1250" dirty="0">
+                <a:solidFill>
+                  <a:srgbClr val="1C1C19"/>
+                </a:solidFill>
+                <a:latin typeface="Inter" pitchFamily="34" charset="0"/>
+                <a:ea typeface="Inter" pitchFamily="34" charset="-122"/>
+                <a:cs typeface="Inter" pitchFamily="34" charset="-120"/>
+              </a:rPr>
+              <a:t>5. GET /forecasts/today: Check dashboard estimates
+</a:t>
+            </a:r>
+            <a:pPr indent="0" marL="0">
+              <a:spcAft>
+                <a:spcPts val="400"/>
+              </a:spcAft>
+              <a:buNone/>
+            </a:pPr>
+            <a:r>
+              <a:rPr lang="en-US" sz="1250" dirty="0">
+                <a:solidFill>
+                  <a:srgbClr val="1C1C19"/>
+                </a:solidFill>
+                <a:latin typeface="Inter" pitchFamily="34" charset="0"/>
+                <a:ea typeface="Inter" pitchFamily="34" charset="-122"/>
+                <a:cs typeface="Inter" pitchFamily="34" charset="-120"/>
+              </a:rPr>
+              <a:t>6. GET /forecasts/{id}: Validate 7-day forecast curve
+</a:t>
+            </a:r>
+            <a:pPr indent="0" marL="0">
+              <a:spcAft>
+                <a:spcPts val="400"/>
+              </a:spcAft>
+              <a:buNone/>
+            </a:pPr>
+            <a:r>
+              <a:rPr lang="en-US" sz="1250" dirty="0">
+                <a:solidFill>
+                  <a:srgbClr val="1C1C19"/>
+                </a:solidFill>
+                <a:latin typeface="Inter" pitchFamily="34" charset="0"/>
+                <a:ea typeface="Inter" pitchFamily="34" charset="-122"/>
+                <a:cs typeface="Inter" pitchFamily="34" charset="-120"/>
+              </a:rPr>
+              <a:t>7. POST /items/{id}/restock: One-tap stock increment (+15)
+</a:t>
+            </a:r>
+            <a:pPr indent="0" marL="0">
+              <a:spcAft>
+                <a:spcPts val="400"/>
+              </a:spcAft>
+              <a:buNone/>
+            </a:pPr>
+            <a:r>
+              <a:rPr lang="en-US" sz="1250" dirty="0">
+                <a:solidFill>
+                  <a:srgbClr val="1C1C19"/>
+                </a:solidFill>
+                <a:latin typeface="Inter" pitchFamily="34" charset="0"/>
+                <a:ea typeface="Inter" pitchFamily="34" charset="-122"/>
+                <a:cs typeface="Inter" pitchFamily="34" charset="-120"/>
+              </a:rPr>
+              <a:t>8. POST /sales/intraday: Log POS sales event to Atlas
+</a:t>
+            </a:r>
+            <a:pPr indent="0" marL="0">
+              <a:spcAft>
+                <a:spcPts val="400"/>
+              </a:spcAft>
+              <a:buNone/>
+            </a:pPr>
+            <a:r>
+              <a:rPr lang="en-US" sz="1250" dirty="0">
+                <a:solidFill>
+                  <a:srgbClr val="1C1C19"/>
+                </a:solidFill>
+                <a:latin typeface="Inter" pitchFamily="34" charset="0"/>
+                <a:ea typeface="Inter" pitchFamily="34" charset="-122"/>
+                <a:cs typeface="Inter" pitchFamily="34" charset="-120"/>
+              </a:rPr>
+              <a:t>9. GET /waste-alerts: Trigger waste action engine rule</a:t>
             </a:r>
             <a:endParaRPr lang="en-US" sz="1250" dirty="0"/>
           </a:p>
@@ -12406,7 +12765,7 @@
           <a:bodyPr wrap="square" rtlCol="0" anchor="ctr"/>
           <a:lstStyle/>
           <a:p>
-            <a:pPr marL="0" indent="0">
+            <a:pPr indent="0" marL="0">
               <a:buNone/>
             </a:pPr>
             <a:r>
@@ -12436,7 +12795,9 @@
             <a:ext cx="5193792" cy="3703320"/>
           </a:xfrm>
           <a:prstGeom prst="rect">
-            <a:avLst/>
+            <a:avLst>
+              <a:gd name="adj" fmla="val 2963"/>
+            </a:avLst>
           </a:prstGeom>
           <a:solidFill>
             <a:srgbClr val="FFFFFF"/>
@@ -12470,7 +12831,7 @@
           <a:bodyPr wrap="square" rtlCol="0" anchor="ctr"/>
           <a:lstStyle/>
           <a:p>
-            <a:pPr marL="0" indent="0">
+            <a:pPr indent="0" marL="0">
               <a:buNone/>
             </a:pPr>
             <a:r>
@@ -12500,7 +12861,9 @@
             <a:ext cx="4828032" cy="1371600"/>
           </a:xfrm>
           <a:prstGeom prst="rect">
-            <a:avLst/>
+            <a:avLst>
+              <a:gd name="adj" fmla="val 5333"/>
+            </a:avLst>
           </a:prstGeom>
           <a:solidFill>
             <a:srgbClr val="EFEAE1"/>
@@ -12534,7 +12897,7 @@
           <a:bodyPr wrap="square" rtlCol="0" anchor="ctr"/>
           <a:lstStyle/>
           <a:p>
-            <a:pPr marL="0" indent="0">
+            <a:pPr indent="0" marL="0">
               <a:buNone/>
             </a:pPr>
             <a:r>
@@ -12549,6 +12912,9 @@
               <a:t>Owner-ID Filtering (test_tenant_isolation.py):
 </a:t>
             </a:r>
+            <a:pPr indent="0" marL="0">
+              <a:buNone/>
+            </a:pPr>
             <a:r>
               <a:rPr lang="en-US" sz="1300" b="1" dirty="0">
                 <a:solidFill>
@@ -12561,6 +12927,9 @@
               <a:t>• Tested 10 endpoints with cross-tenant tokens: ZERO LEAKS.
 </a:t>
             </a:r>
+            <a:pPr indent="0" marL="0">
+              <a:buNone/>
+            </a:pPr>
             <a:r>
               <a:rPr lang="en-US" sz="1250" dirty="0">
                 <a:solidFill>
@@ -12573,6 +12942,9 @@
               <a:t>• All unauthorized requests return HTTP 404 or empty collection.
 </a:t>
             </a:r>
+            <a:pPr indent="0" marL="0">
+              <a:buNone/>
+            </a:pPr>
             <a:r>
               <a:rPr lang="en-US" sz="1200" i="1" dirty="0">
                 <a:solidFill>
@@ -12600,7 +12972,9 @@
             <a:ext cx="4828032" cy="1417320"/>
           </a:xfrm>
           <a:prstGeom prst="rect">
-            <a:avLst/>
+            <a:avLst>
+              <a:gd name="adj" fmla="val 5161"/>
+            </a:avLst>
           </a:prstGeom>
           <a:solidFill>
             <a:srgbClr val="FFFFFF"/>
@@ -12634,7 +13008,7 @@
           <a:bodyPr wrap="square" rtlCol="0" anchor="ctr"/>
           <a:lstStyle/>
           <a:p>
-            <a:pPr marL="0" indent="0">
+            <a:pPr indent="0" marL="0">
               <a:buNone/>
             </a:pPr>
             <a:r>
@@ -12649,6 +13023,9 @@
               <a:t>Custom Rate Limiter &amp; Spoof Defense (main.py):
 </a:t>
             </a:r>
+            <a:pPr indent="0" marL="0">
+              <a:buNone/>
+            </a:pPr>
             <a:r>
               <a:rPr lang="en-US" sz="1250" dirty="0">
                 <a:solidFill>
@@ -12659,9 +13036,26 @@
                 <a:cs typeface="Inter" pitchFamily="34" charset="-120"/>
               </a:rPr>
               <a:t>• In-memory sliding window purges timestamps older than window.
-• Spoof test: Simulated headers verified code selects rightmost IP.
 </a:t>
             </a:r>
+            <a:pPr indent="0" marL="0">
+              <a:buNone/>
+            </a:pPr>
+            <a:r>
+              <a:rPr lang="en-US" sz="1250" dirty="0">
+                <a:solidFill>
+                  <a:srgbClr val="1C1C19"/>
+                </a:solidFill>
+                <a:latin typeface="Inter" pitchFamily="34" charset="0"/>
+                <a:ea typeface="Inter" pitchFamily="34" charset="-122"/>
+                <a:cs typeface="Inter" pitchFamily="34" charset="-120"/>
+              </a:rPr>
+              <a:t>• Spoof test: Simulated headers verified code selects rightmost IP.
+</a:t>
+            </a:r>
+            <a:pPr indent="0" marL="0">
+              <a:buNone/>
+            </a:pPr>
             <a:r>
               <a:rPr lang="en-US" sz="1200" i="1" dirty="0">
                 <a:solidFill>
@@ -12787,7 +13181,6 @@
         <a:solidFill>
           <a:srgbClr val="FCF9F4"/>
         </a:solidFill>
-        <a:effectLst/>
       </p:bgPr>
     </p:bg>
     <p:spTree>
@@ -12825,7 +13218,7 @@
           <a:bodyPr wrap="square" rtlCol="0" anchor="ctr"/>
           <a:lstStyle/>
           <a:p>
-            <a:pPr marL="0" indent="0" algn="r">
+            <a:pPr algn="r" indent="0" marL="0">
               <a:buNone/>
             </a:pPr>
             <a:r>
@@ -12864,7 +13257,7 @@
           <a:bodyPr wrap="square" rtlCol="0" anchor="ctr"/>
           <a:lstStyle/>
           <a:p>
-            <a:pPr marL="0" indent="0">
+            <a:pPr indent="0" marL="0">
               <a:buNone/>
             </a:pPr>
             <a:r>
@@ -12917,7 +13310,9 @@
             <a:ext cx="5166360" cy="3703320"/>
           </a:xfrm>
           <a:prstGeom prst="rect">
-            <a:avLst/>
+            <a:avLst>
+              <a:gd name="adj" fmla="val 2963"/>
+            </a:avLst>
           </a:prstGeom>
           <a:solidFill>
             <a:srgbClr val="FFFFFF"/>
@@ -12951,7 +13346,7 @@
           <a:bodyPr wrap="square" rtlCol="0" anchor="ctr"/>
           <a:lstStyle/>
           <a:p>
-            <a:pPr marL="0" indent="0">
+            <a:pPr indent="0" marL="0">
               <a:buNone/>
             </a:pPr>
             <a:r>
@@ -12971,7 +13366,7 @@
       </p:sp>
       <p:graphicFrame>
         <p:nvGraphicFramePr>
-          <p:cNvPr id="7" name="Chart 0"/>
+          <p:cNvPr id="7" name="Chart 0" descr=""/>
           <p:cNvGraphicFramePr/>
           <p:nvPr/>
         </p:nvGraphicFramePr>
@@ -12979,9 +13374,9 @@
           <a:off x="914400" y="1783080"/>
           <a:ext cx="4800600" cy="2514600"/>
         </p:xfrm>
-        <a:graphic>
+        <a:graphic xmlns:a="http://schemas.openxmlformats.org/drawingml/2006/main">
           <a:graphicData uri="http://schemas.openxmlformats.org/drawingml/2006/chart">
-            <c:chart xmlns:c="http://schemas.openxmlformats.org/drawingml/2006/chart" xmlns:r="http://schemas.openxmlformats.org/officeDocument/2006/relationships" r:id="rId3"/>
+            <c:chart xmlns:c="http://schemas.openxmlformats.org/drawingml/2006/chart" r:id="rId1"/>
           </a:graphicData>
         </a:graphic>
       </p:graphicFrame>
@@ -12997,7 +13392,9 @@
             <a:ext cx="4800600" cy="594360"/>
           </a:xfrm>
           <a:prstGeom prst="rect">
-            <a:avLst/>
+            <a:avLst>
+              <a:gd name="adj" fmla="val 9231"/>
+            </a:avLst>
           </a:prstGeom>
           <a:solidFill>
             <a:srgbClr val="EFEAE1"/>
@@ -13031,7 +13428,7 @@
           <a:bodyPr wrap="square" rtlCol="0" anchor="ctr"/>
           <a:lstStyle/>
           <a:p>
-            <a:pPr marL="0" indent="0" algn="ctr">
+            <a:pPr algn="ctr" indent="0" marL="0">
               <a:buNone/>
             </a:pPr>
             <a:r>
@@ -13061,7 +13458,9 @@
             <a:ext cx="5193792" cy="3703320"/>
           </a:xfrm>
           <a:prstGeom prst="rect">
-            <a:avLst/>
+            <a:avLst>
+              <a:gd name="adj" fmla="val 2963"/>
+            </a:avLst>
           </a:prstGeom>
           <a:solidFill>
             <a:srgbClr val="FFFFFF"/>
@@ -13095,7 +13494,7 @@
           <a:bodyPr wrap="square" rtlCol="0" anchor="ctr"/>
           <a:lstStyle/>
           <a:p>
-            <a:pPr marL="0" indent="0">
+            <a:pPr indent="0" marL="0">
               <a:buNone/>
             </a:pPr>
             <a:r>
@@ -13125,7 +13524,9 @@
             <a:ext cx="4828032" cy="1463040"/>
           </a:xfrm>
           <a:prstGeom prst="rect">
-            <a:avLst/>
+            <a:avLst>
+              <a:gd name="adj" fmla="val 5000"/>
+            </a:avLst>
           </a:prstGeom>
           <a:solidFill>
             <a:srgbClr val="EFEAE1"/>
@@ -13159,7 +13560,7 @@
           <a:bodyPr wrap="square" rtlCol="0" anchor="ctr"/>
           <a:lstStyle/>
           <a:p>
-            <a:pPr marL="0" indent="0">
+            <a:pPr indent="0" marL="0">
               <a:buNone/>
             </a:pPr>
             <a:r>
@@ -13174,6 +13575,9 @@
               <a:t>Temporal Leakage &amp; Zero-Math Truth Audits:
 </a:t>
             </a:r>
+            <a:pPr indent="0" marL="0">
+              <a:buNone/>
+            </a:pPr>
             <a:r>
               <a:rPr lang="en-US" sz="1250" dirty="0">
                 <a:solidFill>
@@ -13184,18 +13588,35 @@
                 <a:cs typeface="Inter" pitchFamily="34" charset="-120"/>
               </a:rPr>
               <a:t>• Temporal Leakage: Training ends before forecast starts in all 6 folds.
-• Zero lookahead contamination: training spans 527 to 593 sales days.
 </a:t>
             </a:r>
-            <a:r>
-              <a:rPr lang="en-US" sz="1250" b="1" dirty="0">
-                <a:solidFill>
-                  <a:srgbClr val="2D6A4F"/>
+            <a:pPr indent="0" marL="0">
+              <a:buNone/>
+            </a:pPr>
+            <a:r>
+              <a:rPr lang="en-US" sz="1250" dirty="0">
+                <a:solidFill>
+                  <a:srgbClr val="1C1C19"/>
                 </a:solidFill>
                 <a:latin typeface="Inter" pitchFamily="34" charset="0"/>
                 <a:ea typeface="Inter" pitchFamily="34" charset="-122"/>
                 <a:cs typeface="Inter" pitchFamily="34" charset="-120"/>
               </a:rPr>
+              <a:t>• Zero lookahead contamination: training spans 527 to 593 sales days.
+</a:t>
+            </a:r>
+            <a:pPr indent="0" marL="0">
+              <a:buNone/>
+            </a:pPr>
+            <a:r>
+              <a:rPr lang="en-US" sz="1250" b="1" dirty="0">
+                <a:solidFill>
+                  <a:srgbClr val="2D6A4F"/>
+                </a:solidFill>
+                <a:latin typeface="Inter" pitchFamily="34" charset="0"/>
+                <a:ea typeface="Inter" pitchFamily="34" charset="-122"/>
+                <a:cs typeface="Inter" pitchFamily="34" charset="-120"/>
+              </a:rPr>
               <a:t>• Zero-Math Audit: Every number in the AI answer appears in our data (check passed). Gemini 3 Flash acts as pure summarizer.</a:t>
             </a:r>
             <a:endParaRPr lang="en-US" sz="1400" dirty="0"/>
@@ -13214,7 +13635,9 @@
             <a:ext cx="4828032" cy="1417320"/>
           </a:xfrm>
           <a:prstGeom prst="rect">
-            <a:avLst/>
+            <a:avLst>
+              <a:gd name="adj" fmla="val 5161"/>
+            </a:avLst>
           </a:prstGeom>
           <a:solidFill>
             <a:srgbClr val="FFFFFF"/>
@@ -13248,7 +13671,7 @@
           <a:bodyPr wrap="square" rtlCol="0" anchor="ctr"/>
           <a:lstStyle/>
           <a:p>
-            <a:pPr marL="0" indent="0">
+            <a:pPr indent="0" marL="0">
               <a:buNone/>
             </a:pPr>
             <a:r>
@@ -13263,6 +13686,9 @@
               <a:t>90-Day Inventory Simulation (Hybrid Model, 68,908 Demand):
 </a:t>
             </a:r>
+            <a:pPr indent="0" marL="0">
+              <a:buNone/>
+            </a:pPr>
             <a:r>
               <a:rPr lang="en-US" sz="1250" dirty="0">
                 <a:solidFill>
@@ -13273,9 +13699,26 @@
                 <a:cs typeface="Inter" pitchFamily="34" charset="-120"/>
               </a:rPr>
               <a:t>• Waste depends on safety buffer: 9.0% at z=0.0 to 37.6% at z=1.65.
-• Profit trade-off: €40,717 at z=0.0 vs. €29,043 at z=1.65.
 </a:t>
             </a:r>
+            <a:pPr indent="0" marL="0">
+              <a:buNone/>
+            </a:pPr>
+            <a:r>
+              <a:rPr lang="en-US" sz="1250" dirty="0">
+                <a:solidFill>
+                  <a:srgbClr val="1C1C19"/>
+                </a:solidFill>
+                <a:latin typeface="Inter" pitchFamily="34" charset="0"/>
+                <a:ea typeface="Inter" pitchFamily="34" charset="-122"/>
+                <a:cs typeface="Inter" pitchFamily="34" charset="-120"/>
+              </a:rPr>
+              <a:t>• Profit trade-off: €40,717 at z=0.0 vs. €29,043 at z=1.65.
+</a:t>
+            </a:r>
+            <a:pPr indent="0" marL="0">
+              <a:buNone/>
+            </a:pPr>
             <a:r>
               <a:rPr lang="en-US" sz="1250" b="1" dirty="0">
                 <a:solidFill>
@@ -13686,299 +14129,4 @@
     </a:ext>
   </a:extLst>
 </a:theme>
-</file>
-
-<file path=ppt/theme/theme2.xml><?xml version="1.0" encoding="utf-8"?>
-<a:theme xmlns:a="http://schemas.openxmlformats.org/drawingml/2006/main" name="Office Theme">
-  <a:themeElements>
-    <a:clrScheme name="Office">
-      <a:dk1>
-        <a:sysClr val="windowText" lastClr="000000"/>
-      </a:dk1>
-      <a:lt1>
-        <a:sysClr val="window" lastClr="FFFFFF"/>
-      </a:lt1>
-      <a:dk2>
-        <a:srgbClr val="44546A"/>
-      </a:dk2>
-      <a:lt2>
-        <a:srgbClr val="E7E6E6"/>
-      </a:lt2>
-      <a:accent1>
-        <a:srgbClr val="4472C4"/>
-      </a:accent1>
-      <a:accent2>
-        <a:srgbClr val="ED7D31"/>
-      </a:accent2>
-      <a:accent3>
-        <a:srgbClr val="A5A5A5"/>
-      </a:accent3>
-      <a:accent4>
-        <a:srgbClr val="FFC000"/>
-      </a:accent4>
-      <a:accent5>
-        <a:srgbClr val="5B9BD5"/>
-      </a:accent5>
-      <a:accent6>
-        <a:srgbClr val="70AD47"/>
-      </a:accent6>
-      <a:hlink>
-        <a:srgbClr val="0563C1"/>
-      </a:hlink>
-      <a:folHlink>
-        <a:srgbClr val="954F72"/>
-      </a:folHlink>
-    </a:clrScheme>
-    <a:fontScheme name="Office">
-      <a:majorFont>
-        <a:latin typeface="Calibri Light" panose="020F0302020204030204"/>
-        <a:ea typeface=""/>
-        <a:cs typeface=""/>
-        <a:font script="Jpan" typeface="游ゴシック Light"/>
-        <a:font script="Hang" typeface="맑은 고딕"/>
-        <a:font script="Hans" typeface="等线 Light"/>
-        <a:font script="Hant" typeface="新細明體"/>
-        <a:font script="Arab" typeface="Times New Roman"/>
-        <a:font script="Hebr" typeface="Times New Roman"/>
-        <a:font script="Thai" typeface="Angsana New"/>
-        <a:font script="Ethi" typeface="Nyala"/>
-        <a:font script="Beng" typeface="Vrinda"/>
-        <a:font script="Gujr" typeface="Shruti"/>
-        <a:font script="Khmr" typeface="MoolBoran"/>
-        <a:font script="Knda" typeface="Tunga"/>
-        <a:font script="Guru" typeface="Raavi"/>
-        <a:font script="Cans" typeface="Euphemia"/>
-        <a:font script="Cher" typeface="Plantagenet Cherokee"/>
-        <a:font script="Yiii" typeface="Microsoft Yi Baiti"/>
-        <a:font script="Tibt" typeface="Microsoft Himalaya"/>
-        <a:font script="Thaa" typeface="MV Boli"/>
-        <a:font script="Deva" typeface="Mangal"/>
-        <a:font script="Telu" typeface="Gautami"/>
-        <a:font script="Taml" typeface="Latha"/>
-        <a:font script="Syrc" typeface="Estrangelo Edessa"/>
-        <a:font script="Orya" typeface="Kalinga"/>
-        <a:font script="Mlym" typeface="Kartika"/>
-        <a:font script="Laoo" typeface="DokChampa"/>
-        <a:font script="Sinh" typeface="Iskoola Pota"/>
-        <a:font script="Mong" typeface="Mongolian Baiti"/>
-        <a:font script="Viet" typeface="Times New Roman"/>
-        <a:font script="Uigh" typeface="Microsoft Uighur"/>
-        <a:font script="Geor" typeface="Sylfaen"/>
-        <a:font script="Armn" typeface="Arial"/>
-        <a:font script="Bugi" typeface="Leelawadee UI"/>
-        <a:font script="Bopo" typeface="Microsoft JhengHei"/>
-        <a:font script="Java" typeface="Javanese Text"/>
-        <a:font script="Lisu" typeface="Segoe UI"/>
-        <a:font script="Mymr" typeface="Myanmar Text"/>
-        <a:font script="Nkoo" typeface="Ebrima"/>
-        <a:font script="Olck" typeface="Nirmala UI"/>
-        <a:font script="Osma" typeface="Ebrima"/>
-        <a:font script="Phag" typeface="Phagspa"/>
-        <a:font script="Syrn" typeface="Estrangelo Edessa"/>
-        <a:font script="Syrj" typeface="Estrangelo Edessa"/>
-        <a:font script="Syre" typeface="Estrangelo Edessa"/>
-        <a:font script="Sora" typeface="Nirmala UI"/>
-        <a:font script="Tale" typeface="Microsoft Tai Le"/>
-        <a:font script="Talu" typeface="Microsoft New Tai Lue"/>
-        <a:font script="Tfng" typeface="Ebrima"/>
-      </a:majorFont>
-      <a:minorFont>
-        <a:latin typeface="Calibri" panose="020F0502020204030204"/>
-        <a:ea typeface=""/>
-        <a:cs typeface=""/>
-        <a:font script="Jpan" typeface="游ゴシック"/>
-        <a:font script="Hang" typeface="맑은 고딕"/>
-        <a:font script="Hans" typeface="等线"/>
-        <a:font script="Hant" typeface="新細明體"/>
-        <a:font script="Arab" typeface="Arial"/>
-        <a:font script="Hebr" typeface="Arial"/>
-        <a:font script="Thai" typeface="Cordia New"/>
-        <a:font script="Ethi" typeface="Nyala"/>
-        <a:font script="Beng" typeface="Vrinda"/>
-        <a:font script="Gujr" typeface="Shruti"/>
-        <a:font script="Khmr" typeface="DaunPenh"/>
-        <a:font script="Knda" typeface="Tunga"/>
-        <a:font script="Guru" typeface="Raavi"/>
-        <a:font script="Cans" typeface="Euphemia"/>
-        <a:font script="Cher" typeface="Plantagenet Cherokee"/>
-        <a:font script="Yiii" typeface="Microsoft Yi Baiti"/>
-        <a:font script="Tibt" typeface="Microsoft Himalaya"/>
-        <a:font script="Thaa" typeface="MV Boli"/>
-        <a:font script="Deva" typeface="Mangal"/>
-        <a:font script="Telu" typeface="Gautami"/>
-        <a:font script="Taml" typeface="Latha"/>
-        <a:font script="Syrc" typeface="Estrangelo Edessa"/>
-        <a:font script="Orya" typeface="Kalinga"/>
-        <a:font script="Mlym" typeface="Kartika"/>
-        <a:font script="Laoo" typeface="DokChampa"/>
-        <a:font script="Sinh" typeface="Iskoola Pota"/>
-        <a:font script="Mong" typeface="Mongolian Baiti"/>
-        <a:font script="Viet" typeface="Arial"/>
-        <a:font script="Uigh" typeface="Microsoft Uighur"/>
-        <a:font script="Geor" typeface="Sylfaen"/>
-        <a:font script="Armn" typeface="Arial"/>
-        <a:font script="Bugi" typeface="Leelawadee UI"/>
-        <a:font script="Bopo" typeface="Microsoft JhengHei"/>
-        <a:font script="Java" typeface="Javanese Text"/>
-        <a:font script="Lisu" typeface="Segoe UI"/>
-        <a:font script="Mymr" typeface="Myanmar Text"/>
-        <a:font script="Nkoo" typeface="Ebrima"/>
-        <a:font script="Olck" typeface="Nirmala UI"/>
-        <a:font script="Osma" typeface="Ebrima"/>
-        <a:font script="Phag" typeface="Phagspa"/>
-        <a:font script="Syrn" typeface="Estrangelo Edessa"/>
-        <a:font script="Syrj" typeface="Estrangelo Edessa"/>
-        <a:font script="Syre" typeface="Estrangelo Edessa"/>
-        <a:font script="Sora" typeface="Nirmala UI"/>
-        <a:font script="Tale" typeface="Microsoft Tai Le"/>
-        <a:font script="Talu" typeface="Microsoft New Tai Lue"/>
-        <a:font script="Tfng" typeface="Ebrima"/>
-      </a:minorFont>
-    </a:fontScheme>
-    <a:fmtScheme name="Office">
-      <a:fillStyleLst>
-        <a:solidFill>
-          <a:schemeClr val="phClr"/>
-        </a:solidFill>
-        <a:gradFill rotWithShape="1">
-          <a:gsLst>
-            <a:gs pos="0">
-              <a:schemeClr val="phClr">
-                <a:lumMod val="110000"/>
-                <a:satMod val="105000"/>
-                <a:tint val="67000"/>
-              </a:schemeClr>
-            </a:gs>
-            <a:gs pos="50000">
-              <a:schemeClr val="phClr">
-                <a:lumMod val="105000"/>
-                <a:satMod val="103000"/>
-                <a:tint val="73000"/>
-              </a:schemeClr>
-            </a:gs>
-            <a:gs pos="100000">
-              <a:schemeClr val="phClr">
-                <a:lumMod val="105000"/>
-                <a:satMod val="109000"/>
-                <a:tint val="81000"/>
-              </a:schemeClr>
-            </a:gs>
-          </a:gsLst>
-          <a:lin ang="5400000" scaled="0"/>
-        </a:gradFill>
-        <a:gradFill rotWithShape="1">
-          <a:gsLst>
-            <a:gs pos="0">
-              <a:schemeClr val="phClr">
-                <a:satMod val="103000"/>
-                <a:lumMod val="102000"/>
-                <a:tint val="94000"/>
-              </a:schemeClr>
-            </a:gs>
-            <a:gs pos="50000">
-              <a:schemeClr val="phClr">
-                <a:satMod val="110000"/>
-                <a:lumMod val="100000"/>
-                <a:shade val="100000"/>
-              </a:schemeClr>
-            </a:gs>
-            <a:gs pos="100000">
-              <a:schemeClr val="phClr">
-                <a:lumMod val="99000"/>
-                <a:satMod val="120000"/>
-                <a:shade val="78000"/>
-              </a:schemeClr>
-            </a:gs>
-          </a:gsLst>
-          <a:lin ang="5400000" scaled="0"/>
-        </a:gradFill>
-      </a:fillStyleLst>
-      <a:lnStyleLst>
-        <a:ln w="6350" cap="flat" cmpd="sng" algn="ctr">
-          <a:solidFill>
-            <a:schemeClr val="phClr"/>
-          </a:solidFill>
-          <a:prstDash val="solid"/>
-          <a:miter lim="800000"/>
-        </a:ln>
-        <a:ln w="12700" cap="flat" cmpd="sng" algn="ctr">
-          <a:solidFill>
-            <a:schemeClr val="phClr"/>
-          </a:solidFill>
-          <a:prstDash val="solid"/>
-          <a:miter lim="800000"/>
-        </a:ln>
-        <a:ln w="19050" cap="flat" cmpd="sng" algn="ctr">
-          <a:solidFill>
-            <a:schemeClr val="phClr"/>
-          </a:solidFill>
-          <a:prstDash val="solid"/>
-          <a:miter lim="800000"/>
-        </a:ln>
-      </a:lnStyleLst>
-      <a:effectStyleLst>
-        <a:effectStyle>
-          <a:effectLst/>
-        </a:effectStyle>
-        <a:effectStyle>
-          <a:effectLst/>
-        </a:effectStyle>
-        <a:effectStyle>
-          <a:effectLst>
-            <a:outerShdw blurRad="57150" dist="19050" dir="5400000" algn="ctr" rotWithShape="0">
-              <a:srgbClr val="000000">
-                <a:alpha val="63000"/>
-              </a:srgbClr>
-            </a:outerShdw>
-          </a:effectLst>
-        </a:effectStyle>
-      </a:effectStyleLst>
-      <a:bgFillStyleLst>
-        <a:solidFill>
-          <a:schemeClr val="phClr"/>
-        </a:solidFill>
-        <a:solidFill>
-          <a:schemeClr val="phClr">
-            <a:tint val="95000"/>
-            <a:satMod val="170000"/>
-          </a:schemeClr>
-        </a:solidFill>
-        <a:gradFill rotWithShape="1">
-          <a:gsLst>
-            <a:gs pos="0">
-              <a:schemeClr val="phClr">
-                <a:tint val="93000"/>
-                <a:satMod val="150000"/>
-                <a:shade val="98000"/>
-                <a:lumMod val="102000"/>
-              </a:schemeClr>
-            </a:gs>
-            <a:gs pos="50000">
-              <a:schemeClr val="phClr">
-                <a:tint val="98000"/>
-                <a:satMod val="130000"/>
-                <a:shade val="90000"/>
-                <a:lumMod val="103000"/>
-              </a:schemeClr>
-            </a:gs>
-            <a:gs pos="100000">
-              <a:schemeClr val="phClr">
-                <a:shade val="63000"/>
-                <a:satMod val="120000"/>
-              </a:schemeClr>
-            </a:gs>
-          </a:gsLst>
-          <a:lin ang="5400000" scaled="0"/>
-        </a:gradFill>
-      </a:bgFillStyleLst>
-    </a:fmtScheme>
-  </a:themeElements>
-  <a:objectDefaults/>
-  <a:extraClrSchemeLst/>
-  <a:extLst>
-    <a:ext uri="{05A4C25C-085E-4340-85A3-A5531E510DB2}">
-      <thm15:themeFamily xmlns:thm15="http://schemas.microsoft.com/office/thememl/2012/main" name="Office Theme" id="{62F939B6-93AF-4DB8-9C6B-D6C7DFDC589F}" vid="{4A3C46E8-61CC-4603-A589-7422A47A8E4A}"/>
-    </a:ext>
-  </a:extLst>
-</a:theme>
 </file>
</xml_diff>

<commit_message>
docs(paper): finalize IEEE conference paper v2, update Overleaf package and Black Book assets
</commit_message>
<xml_diff>
--- a/docs/software_testing_10slides.pptx
+++ b/docs/software_testing_10slides.pptx
@@ -10977,7 +10977,7 @@
                           <a:ea typeface="Inter" pitchFamily="34" charset="-122"/>
                           <a:cs typeface="Inter" pitchFamily="34" charset="-120"/>
                         </a:rPr>
-                        <a:t>Item setup bottom overflow on small viewports</a:t>
+                        <a:t>Hardcoded loopback IP (10.0.2.2) caused 76s physical phone hang</a:t>
                       </a:r>
                       <a:endParaRPr lang="en-US" sz="1350" dirty="0">
                         <a:latin typeface="Inter" charset="0"/>
@@ -11045,7 +11045,7 @@
                           <a:ea typeface="Inter" pitchFamily="34" charset="-122"/>
                           <a:cs typeface="Inter" pitchFamily="34" charset="-120"/>
                         </a:rPr>
-                        <a:t>UI/Layout</a:t>
+                        <a:t>Config/Net</a:t>
                       </a:r>
                       <a:endParaRPr lang="en-US" sz="1350" dirty="0">
                         <a:latin typeface="Inter" charset="0"/>
@@ -11113,7 +11113,7 @@
                           <a:ea typeface="Inter" pitchFamily="34" charset="-122"/>
                           <a:cs typeface="Inter" pitchFamily="34" charset="-120"/>
                         </a:rPr>
-                        <a:t>Fixed (SingleChildScrollView)</a:t>
+                        <a:t>Fixed (Cloud URL + Probe)</a:t>
                       </a:r>
                       <a:endParaRPr lang="en-US" sz="1350" dirty="0">
                         <a:latin typeface="Inter" charset="0"/>
@@ -11183,7 +11183,7 @@
                           <a:ea typeface="Inter" pitchFamily="34" charset="-122"/>
                           <a:cs typeface="Inter" pitchFamily="34" charset="-120"/>
                         </a:rPr>
-                        <a:t>DEF-004</a:t>
+                        <a:t>DEF-003</a:t>
                       </a:r>
                       <a:endParaRPr lang="en-US" sz="1350" dirty="0">
                         <a:latin typeface="Inter" charset="0"/>
@@ -11251,7 +11251,7 @@
                           <a:ea typeface="Inter" pitchFamily="34" charset="-122"/>
                           <a:cs typeface="Inter" pitchFamily="34" charset="-120"/>
                         </a:rPr>
-                        <a:t>Waste alert calculation lag on initial catalog load</a:t>
+                        <a:t>Hardcoded JWT fallback secret in backend configuration</a:t>
                       </a:r>
                       <a:endParaRPr lang="en-US" sz="1350" dirty="0">
                         <a:latin typeface="Inter" charset="0"/>
@@ -11319,7 +11319,7 @@
                           <a:ea typeface="Inter" pitchFamily="34" charset="-122"/>
                           <a:cs typeface="Inter" pitchFamily="34" charset="-120"/>
                         </a:rPr>
-                        <a:t>Functional</a:t>
+                        <a:t>Security</a:t>
                       </a:r>
                       <a:endParaRPr lang="en-US" sz="1350" dirty="0">
                         <a:latin typeface="Inter" charset="0"/>
@@ -11387,7 +11387,7 @@
                           <a:ea typeface="Inter" pitchFamily="34" charset="-122"/>
                           <a:cs typeface="Inter" pitchFamily="34" charset="-120"/>
                         </a:rPr>
-                        <a:t>Fixed (Pre-warmed cache)</a:t>
+                        <a:t>Fixed (Fail-fast Startup)</a:t>
                       </a:r>
                       <a:endParaRPr lang="en-US" sz="1350" dirty="0">
                         <a:latin typeface="Inter" charset="0"/>
@@ -11525,7 +11525,7 @@
                           <a:ea typeface="Inter" pitchFamily="34" charset="-122"/>
                           <a:cs typeface="Inter" pitchFamily="34" charset="-120"/>
                         </a:rPr>
-                        <a:t>37 missing calendar days causing weekday shift mismatch</a:t>
+                        <a:t>37 store closure dates skewing 4-week lag calculation</a:t>
                       </a:r>
                       <a:endParaRPr lang="en-US" sz="1350" dirty="0">
                         <a:latin typeface="Inter" charset="0"/>
@@ -11661,281 +11661,7 @@
                           <a:ea typeface="Inter" pitchFamily="34" charset="-122"/>
                           <a:cs typeface="Inter" pitchFamily="34" charset="-120"/>
                         </a:rPr>
-                        <a:t>Open (DEF-008 Shift)</a:t>
-                      </a:r>
-                      <a:endParaRPr lang="en-US" sz="1350" dirty="0">
-                        <a:latin typeface="Inter" charset="0"/>
-                        <a:ea typeface="Inter" charset="0"/>
-                        <a:cs typeface="Inter" charset="0"/>
-                      </a:endParaRPr>
-                    </a:p>
-                  </a:txBody>
-                  <a:tcPr marL="91440" marR="91440" marT="45720" marB="45720">
-                    <a:lnL w="6350" cap="flat" cmpd="sng" algn="ctr">
-                      <a:solidFill>
-                        <a:srgbClr val="E5E0D8"/>
-                      </a:solidFill>
-                      <a:prstDash val="solid"/>
-                      <a:round/>
-                      <a:headEnd type="none" w="med" len="med"/>
-                      <a:tailEnd type="none" w="med" len="med"/>
-                    </a:lnL>
-                    <a:lnR w="6350" cap="flat" cmpd="sng" algn="ctr">
-                      <a:solidFill>
-                        <a:srgbClr val="E5E0D8"/>
-                      </a:solidFill>
-                      <a:prstDash val="solid"/>
-                      <a:round/>
-                      <a:headEnd type="none" w="med" len="med"/>
-                      <a:tailEnd type="none" w="med" len="med"/>
-                    </a:lnR>
-                    <a:lnT w="6350" cap="flat" cmpd="sng" algn="ctr">
-                      <a:solidFill>
-                        <a:srgbClr val="E5E0D8"/>
-                      </a:solidFill>
-                      <a:prstDash val="solid"/>
-                      <a:round/>
-                      <a:headEnd type="none" w="med" len="med"/>
-                      <a:tailEnd type="none" w="med" len="med"/>
-                    </a:lnT>
-                    <a:lnB w="6350" cap="flat" cmpd="sng" algn="ctr">
-                      <a:solidFill>
-                        <a:srgbClr val="E5E0D8"/>
-                      </a:solidFill>
-                      <a:prstDash val="solid"/>
-                      <a:round/>
-                      <a:headEnd type="none" w="med" len="med"/>
-                      <a:tailEnd type="none" w="med" len="med"/>
-                    </a:lnB>
-                    <a:solidFill>
-                      <a:srgbClr val="FFFFFF"/>
-                    </a:solidFill>
-                  </a:tcPr>
-                </a:tc>
-              </a:tr>
-              <a:tr h="365760">
-                <a:tc>
-                  <a:txBody>
-                    <a:bodyPr/>
-                    <a:lstStyle/>
-                    <a:p>
-                      <a:pPr indent="0" marL="0">
-                        <a:buNone/>
-                      </a:pPr>
-                      <a:r>
-                        <a:rPr lang="en-US" sz="1350" dirty="0">
-                          <a:solidFill>
-                            <a:srgbClr val="1C1C19"/>
-                          </a:solidFill>
-                          <a:latin typeface="Inter" pitchFamily="34" charset="0"/>
-                          <a:ea typeface="Inter" pitchFamily="34" charset="-122"/>
-                          <a:cs typeface="Inter" pitchFamily="34" charset="-120"/>
-                        </a:rPr>
-                        <a:t>DEF-009</a:t>
-                      </a:r>
-                      <a:endParaRPr lang="en-US" sz="1350" dirty="0">
-                        <a:latin typeface="Inter" charset="0"/>
-                        <a:ea typeface="Inter" charset="0"/>
-                        <a:cs typeface="Inter" charset="0"/>
-                      </a:endParaRPr>
-                    </a:p>
-                  </a:txBody>
-                  <a:tcPr marL="91440" marR="91440" marT="45720" marB="45720">
-                    <a:lnL w="6350" cap="flat" cmpd="sng" algn="ctr">
-                      <a:solidFill>
-                        <a:srgbClr val="E5E0D8"/>
-                      </a:solidFill>
-                      <a:prstDash val="solid"/>
-                      <a:round/>
-                      <a:headEnd type="none" w="med" len="med"/>
-                      <a:tailEnd type="none" w="med" len="med"/>
-                    </a:lnL>
-                    <a:lnR w="6350" cap="flat" cmpd="sng" algn="ctr">
-                      <a:solidFill>
-                        <a:srgbClr val="E5E0D8"/>
-                      </a:solidFill>
-                      <a:prstDash val="solid"/>
-                      <a:round/>
-                      <a:headEnd type="none" w="med" len="med"/>
-                      <a:tailEnd type="none" w="med" len="med"/>
-                    </a:lnR>
-                    <a:lnT w="6350" cap="flat" cmpd="sng" algn="ctr">
-                      <a:solidFill>
-                        <a:srgbClr val="E5E0D8"/>
-                      </a:solidFill>
-                      <a:prstDash val="solid"/>
-                      <a:round/>
-                      <a:headEnd type="none" w="med" len="med"/>
-                      <a:tailEnd type="none" w="med" len="med"/>
-                    </a:lnT>
-                    <a:lnB w="6350" cap="flat" cmpd="sng" algn="ctr">
-                      <a:solidFill>
-                        <a:srgbClr val="E5E0D8"/>
-                      </a:solidFill>
-                      <a:prstDash val="solid"/>
-                      <a:round/>
-                      <a:headEnd type="none" w="med" len="med"/>
-                      <a:tailEnd type="none" w="med" len="med"/>
-                    </a:lnB>
-                    <a:solidFill>
-                      <a:srgbClr val="FFFFFF"/>
-                    </a:solidFill>
-                  </a:tcPr>
-                </a:tc>
-                <a:tc>
-                  <a:txBody>
-                    <a:bodyPr/>
-                    <a:lstStyle/>
-                    <a:p>
-                      <a:pPr indent="0" marL="0">
-                        <a:buNone/>
-                      </a:pPr>
-                      <a:r>
-                        <a:rPr lang="en-US" sz="1350" dirty="0">
-                          <a:solidFill>
-                            <a:srgbClr val="1C1C19"/>
-                          </a:solidFill>
-                          <a:latin typeface="Inter" pitchFamily="34" charset="0"/>
-                          <a:ea typeface="Inter" pitchFamily="34" charset="-122"/>
-                          <a:cs typeface="Inter" pitchFamily="34" charset="-120"/>
-                        </a:rPr>
-                        <a:t>Hardcoded loopback IP caused 76s physical phone hang</a:t>
-                      </a:r>
-                      <a:endParaRPr lang="en-US" sz="1350" dirty="0">
-                        <a:latin typeface="Inter" charset="0"/>
-                        <a:ea typeface="Inter" charset="0"/>
-                        <a:cs typeface="Inter" charset="0"/>
-                      </a:endParaRPr>
-                    </a:p>
-                  </a:txBody>
-                  <a:tcPr marL="91440" marR="91440" marT="45720" marB="45720">
-                    <a:lnL w="6350" cap="flat" cmpd="sng" algn="ctr">
-                      <a:solidFill>
-                        <a:srgbClr val="E5E0D8"/>
-                      </a:solidFill>
-                      <a:prstDash val="solid"/>
-                      <a:round/>
-                      <a:headEnd type="none" w="med" len="med"/>
-                      <a:tailEnd type="none" w="med" len="med"/>
-                    </a:lnL>
-                    <a:lnR w="6350" cap="flat" cmpd="sng" algn="ctr">
-                      <a:solidFill>
-                        <a:srgbClr val="E5E0D8"/>
-                      </a:solidFill>
-                      <a:prstDash val="solid"/>
-                      <a:round/>
-                      <a:headEnd type="none" w="med" len="med"/>
-                      <a:tailEnd type="none" w="med" len="med"/>
-                    </a:lnR>
-                    <a:lnT w="6350" cap="flat" cmpd="sng" algn="ctr">
-                      <a:solidFill>
-                        <a:srgbClr val="E5E0D8"/>
-                      </a:solidFill>
-                      <a:prstDash val="solid"/>
-                      <a:round/>
-                      <a:headEnd type="none" w="med" len="med"/>
-                      <a:tailEnd type="none" w="med" len="med"/>
-                    </a:lnT>
-                    <a:lnB w="6350" cap="flat" cmpd="sng" algn="ctr">
-                      <a:solidFill>
-                        <a:srgbClr val="E5E0D8"/>
-                      </a:solidFill>
-                      <a:prstDash val="solid"/>
-                      <a:round/>
-                      <a:headEnd type="none" w="med" len="med"/>
-                      <a:tailEnd type="none" w="med" len="med"/>
-                    </a:lnB>
-                    <a:solidFill>
-                      <a:srgbClr val="FFFFFF"/>
-                    </a:solidFill>
-                  </a:tcPr>
-                </a:tc>
-                <a:tc>
-                  <a:txBody>
-                    <a:bodyPr/>
-                    <a:lstStyle/>
-                    <a:p>
-                      <a:pPr indent="0" marL="0">
-                        <a:buNone/>
-                      </a:pPr>
-                      <a:r>
-                        <a:rPr lang="en-US" sz="1350" dirty="0">
-                          <a:solidFill>
-                            <a:srgbClr val="1C1C19"/>
-                          </a:solidFill>
-                          <a:latin typeface="Inter" pitchFamily="34" charset="0"/>
-                          <a:ea typeface="Inter" pitchFamily="34" charset="-122"/>
-                          <a:cs typeface="Inter" pitchFamily="34" charset="-120"/>
-                        </a:rPr>
-                        <a:t>Config/Net</a:t>
-                      </a:r>
-                      <a:endParaRPr lang="en-US" sz="1350" dirty="0">
-                        <a:latin typeface="Inter" charset="0"/>
-                        <a:ea typeface="Inter" charset="0"/>
-                        <a:cs typeface="Inter" charset="0"/>
-                      </a:endParaRPr>
-                    </a:p>
-                  </a:txBody>
-                  <a:tcPr marL="91440" marR="91440" marT="45720" marB="45720">
-                    <a:lnL w="6350" cap="flat" cmpd="sng" algn="ctr">
-                      <a:solidFill>
-                        <a:srgbClr val="E5E0D8"/>
-                      </a:solidFill>
-                      <a:prstDash val="solid"/>
-                      <a:round/>
-                      <a:headEnd type="none" w="med" len="med"/>
-                      <a:tailEnd type="none" w="med" len="med"/>
-                    </a:lnL>
-                    <a:lnR w="6350" cap="flat" cmpd="sng" algn="ctr">
-                      <a:solidFill>
-                        <a:srgbClr val="E5E0D8"/>
-                      </a:solidFill>
-                      <a:prstDash val="solid"/>
-                      <a:round/>
-                      <a:headEnd type="none" w="med" len="med"/>
-                      <a:tailEnd type="none" w="med" len="med"/>
-                    </a:lnR>
-                    <a:lnT w="6350" cap="flat" cmpd="sng" algn="ctr">
-                      <a:solidFill>
-                        <a:srgbClr val="E5E0D8"/>
-                      </a:solidFill>
-                      <a:prstDash val="solid"/>
-                      <a:round/>
-                      <a:headEnd type="none" w="med" len="med"/>
-                      <a:tailEnd type="none" w="med" len="med"/>
-                    </a:lnT>
-                    <a:lnB w="6350" cap="flat" cmpd="sng" algn="ctr">
-                      <a:solidFill>
-                        <a:srgbClr val="E5E0D8"/>
-                      </a:solidFill>
-                      <a:prstDash val="solid"/>
-                      <a:round/>
-                      <a:headEnd type="none" w="med" len="med"/>
-                      <a:tailEnd type="none" w="med" len="med"/>
-                    </a:lnB>
-                    <a:solidFill>
-                      <a:srgbClr val="FFFFFF"/>
-                    </a:solidFill>
-                  </a:tcPr>
-                </a:tc>
-                <a:tc>
-                  <a:txBody>
-                    <a:bodyPr/>
-                    <a:lstStyle/>
-                    <a:p>
-                      <a:pPr indent="0" marL="0">
-                        <a:buNone/>
-                      </a:pPr>
-                      <a:r>
-                        <a:rPr lang="en-US" sz="1350" dirty="0">
-                          <a:solidFill>
-                            <a:srgbClr val="1C1C19"/>
-                          </a:solidFill>
-                          <a:latin typeface="Inter" pitchFamily="34" charset="0"/>
-                          <a:ea typeface="Inter" pitchFamily="34" charset="-122"/>
-                          <a:cs typeface="Inter" pitchFamily="34" charset="-120"/>
-                        </a:rPr>
-                        <a:t>Fixed (Dynamic IP + Gating)</a:t>
+                        <a:t>Resolved &amp; Verified (Calendar Lookup)</a:t>
                       </a:r>
                       <a:endParaRPr lang="en-US" sz="1350" dirty="0">
                         <a:latin typeface="Inter" charset="0"/>
@@ -12073,7 +11799,281 @@
                           <a:ea typeface="Inter" pitchFamily="34" charset="-122"/>
                           <a:cs typeface="Inter" pitchFamily="34" charset="-120"/>
                         </a:rPr>
-                        <a:t>Legacy donation endpoint retained vs commercial rule</a:t>
+                        <a:t>Item setup form bottom overflow on small viewports</a:t>
+                      </a:r>
+                      <a:endParaRPr lang="en-US" sz="1350" dirty="0">
+                        <a:latin typeface="Inter" charset="0"/>
+                        <a:ea typeface="Inter" charset="0"/>
+                        <a:cs typeface="Inter" charset="0"/>
+                      </a:endParaRPr>
+                    </a:p>
+                  </a:txBody>
+                  <a:tcPr marL="91440" marR="91440" marT="45720" marB="45720">
+                    <a:lnL w="6350" cap="flat" cmpd="sng" algn="ctr">
+                      <a:solidFill>
+                        <a:srgbClr val="E5E0D8"/>
+                      </a:solidFill>
+                      <a:prstDash val="solid"/>
+                      <a:round/>
+                      <a:headEnd type="none" w="med" len="med"/>
+                      <a:tailEnd type="none" w="med" len="med"/>
+                    </a:lnL>
+                    <a:lnR w="6350" cap="flat" cmpd="sng" algn="ctr">
+                      <a:solidFill>
+                        <a:srgbClr val="E5E0D8"/>
+                      </a:solidFill>
+                      <a:prstDash val="solid"/>
+                      <a:round/>
+                      <a:headEnd type="none" w="med" len="med"/>
+                      <a:tailEnd type="none" w="med" len="med"/>
+                    </a:lnR>
+                    <a:lnT w="6350" cap="flat" cmpd="sng" algn="ctr">
+                      <a:solidFill>
+                        <a:srgbClr val="E5E0D8"/>
+                      </a:solidFill>
+                      <a:prstDash val="solid"/>
+                      <a:round/>
+                      <a:headEnd type="none" w="med" len="med"/>
+                      <a:tailEnd type="none" w="med" len="med"/>
+                    </a:lnT>
+                    <a:lnB w="6350" cap="flat" cmpd="sng" algn="ctr">
+                      <a:solidFill>
+                        <a:srgbClr val="E5E0D8"/>
+                      </a:solidFill>
+                      <a:prstDash val="solid"/>
+                      <a:round/>
+                      <a:headEnd type="none" w="med" len="med"/>
+                      <a:tailEnd type="none" w="med" len="med"/>
+                    </a:lnB>
+                    <a:solidFill>
+                      <a:srgbClr val="FFFFFF"/>
+                    </a:solidFill>
+                  </a:tcPr>
+                </a:tc>
+                <a:tc>
+                  <a:txBody>
+                    <a:bodyPr/>
+                    <a:lstStyle/>
+                    <a:p>
+                      <a:pPr indent="0" marL="0">
+                        <a:buNone/>
+                      </a:pPr>
+                      <a:r>
+                        <a:rPr lang="en-US" sz="1350" dirty="0">
+                          <a:solidFill>
+                            <a:srgbClr val="1C1C19"/>
+                          </a:solidFill>
+                          <a:latin typeface="Inter" pitchFamily="34" charset="0"/>
+                          <a:ea typeface="Inter" pitchFamily="34" charset="-122"/>
+                          <a:cs typeface="Inter" pitchFamily="34" charset="-120"/>
+                        </a:rPr>
+                        <a:t>UI/Layout</a:t>
+                      </a:r>
+                      <a:endParaRPr lang="en-US" sz="1350" dirty="0">
+                        <a:latin typeface="Inter" charset="0"/>
+                        <a:ea typeface="Inter" charset="0"/>
+                        <a:cs typeface="Inter" charset="0"/>
+                      </a:endParaRPr>
+                    </a:p>
+                  </a:txBody>
+                  <a:tcPr marL="91440" marR="91440" marT="45720" marB="45720">
+                    <a:lnL w="6350" cap="flat" cmpd="sng" algn="ctr">
+                      <a:solidFill>
+                        <a:srgbClr val="E5E0D8"/>
+                      </a:solidFill>
+                      <a:prstDash val="solid"/>
+                      <a:round/>
+                      <a:headEnd type="none" w="med" len="med"/>
+                      <a:tailEnd type="none" w="med" len="med"/>
+                    </a:lnL>
+                    <a:lnR w="6350" cap="flat" cmpd="sng" algn="ctr">
+                      <a:solidFill>
+                        <a:srgbClr val="E5E0D8"/>
+                      </a:solidFill>
+                      <a:prstDash val="solid"/>
+                      <a:round/>
+                      <a:headEnd type="none" w="med" len="med"/>
+                      <a:tailEnd type="none" w="med" len="med"/>
+                    </a:lnR>
+                    <a:lnT w="6350" cap="flat" cmpd="sng" algn="ctr">
+                      <a:solidFill>
+                        <a:srgbClr val="E5E0D8"/>
+                      </a:solidFill>
+                      <a:prstDash val="solid"/>
+                      <a:round/>
+                      <a:headEnd type="none" w="med" len="med"/>
+                      <a:tailEnd type="none" w="med" len="med"/>
+                    </a:lnT>
+                    <a:lnB w="6350" cap="flat" cmpd="sng" algn="ctr">
+                      <a:solidFill>
+                        <a:srgbClr val="E5E0D8"/>
+                      </a:solidFill>
+                      <a:prstDash val="solid"/>
+                      <a:round/>
+                      <a:headEnd type="none" w="med" len="med"/>
+                      <a:tailEnd type="none" w="med" len="med"/>
+                    </a:lnB>
+                    <a:solidFill>
+                      <a:srgbClr val="FFFFFF"/>
+                    </a:solidFill>
+                  </a:tcPr>
+                </a:tc>
+                <a:tc>
+                  <a:txBody>
+                    <a:bodyPr/>
+                    <a:lstStyle/>
+                    <a:p>
+                      <a:pPr indent="0" marL="0">
+                        <a:buNone/>
+                      </a:pPr>
+                      <a:r>
+                        <a:rPr lang="en-US" sz="1350" dirty="0">
+                          <a:solidFill>
+                            <a:srgbClr val="1C1C19"/>
+                          </a:solidFill>
+                          <a:latin typeface="Inter" pitchFamily="34" charset="0"/>
+                          <a:ea typeface="Inter" pitchFamily="34" charset="-122"/>
+                          <a:cs typeface="Inter" pitchFamily="34" charset="-120"/>
+                        </a:rPr>
+                        <a:t>Fixed (SingleChildScrollView)</a:t>
+                      </a:r>
+                      <a:endParaRPr lang="en-US" sz="1350" dirty="0">
+                        <a:latin typeface="Inter" charset="0"/>
+                        <a:ea typeface="Inter" charset="0"/>
+                        <a:cs typeface="Inter" charset="0"/>
+                      </a:endParaRPr>
+                    </a:p>
+                  </a:txBody>
+                  <a:tcPr marL="91440" marR="91440" marT="45720" marB="45720">
+                    <a:lnL w="6350" cap="flat" cmpd="sng" algn="ctr">
+                      <a:solidFill>
+                        <a:srgbClr val="E5E0D8"/>
+                      </a:solidFill>
+                      <a:prstDash val="solid"/>
+                      <a:round/>
+                      <a:headEnd type="none" w="med" len="med"/>
+                      <a:tailEnd type="none" w="med" len="med"/>
+                    </a:lnL>
+                    <a:lnR w="6350" cap="flat" cmpd="sng" algn="ctr">
+                      <a:solidFill>
+                        <a:srgbClr val="E5E0D8"/>
+                      </a:solidFill>
+                      <a:prstDash val="solid"/>
+                      <a:round/>
+                      <a:headEnd type="none" w="med" len="med"/>
+                      <a:tailEnd type="none" w="med" len="med"/>
+                    </a:lnR>
+                    <a:lnT w="6350" cap="flat" cmpd="sng" algn="ctr">
+                      <a:solidFill>
+                        <a:srgbClr val="E5E0D8"/>
+                      </a:solidFill>
+                      <a:prstDash val="solid"/>
+                      <a:round/>
+                      <a:headEnd type="none" w="med" len="med"/>
+                      <a:tailEnd type="none" w="med" len="med"/>
+                    </a:lnT>
+                    <a:lnB w="6350" cap="flat" cmpd="sng" algn="ctr">
+                      <a:solidFill>
+                        <a:srgbClr val="E5E0D8"/>
+                      </a:solidFill>
+                      <a:prstDash val="solid"/>
+                      <a:round/>
+                      <a:headEnd type="none" w="med" len="med"/>
+                      <a:tailEnd type="none" w="med" len="med"/>
+                    </a:lnB>
+                    <a:solidFill>
+                      <a:srgbClr val="FFFFFF"/>
+                    </a:solidFill>
+                  </a:tcPr>
+                </a:tc>
+              </a:tr>
+              <a:tr h="365760">
+                <a:tc>
+                  <a:txBody>
+                    <a:bodyPr/>
+                    <a:lstStyle/>
+                    <a:p>
+                      <a:pPr indent="0" marL="0">
+                        <a:buNone/>
+                      </a:pPr>
+                      <a:r>
+                        <a:rPr lang="en-US" sz="1350" dirty="0">
+                          <a:solidFill>
+                            <a:srgbClr val="1C1C19"/>
+                          </a:solidFill>
+                          <a:latin typeface="Inter" pitchFamily="34" charset="0"/>
+                          <a:ea typeface="Inter" pitchFamily="34" charset="-122"/>
+                          <a:cs typeface="Inter" pitchFamily="34" charset="-120"/>
+                        </a:rPr>
+                        <a:t>DEF-013</a:t>
+                      </a:r>
+                      <a:endParaRPr lang="en-US" sz="1350" dirty="0">
+                        <a:latin typeface="Inter" charset="0"/>
+                        <a:ea typeface="Inter" charset="0"/>
+                        <a:cs typeface="Inter" charset="0"/>
+                      </a:endParaRPr>
+                    </a:p>
+                  </a:txBody>
+                  <a:tcPr marL="91440" marR="91440" marT="45720" marB="45720">
+                    <a:lnL w="6350" cap="flat" cmpd="sng" algn="ctr">
+                      <a:solidFill>
+                        <a:srgbClr val="E5E0D8"/>
+                      </a:solidFill>
+                      <a:prstDash val="solid"/>
+                      <a:round/>
+                      <a:headEnd type="none" w="med" len="med"/>
+                      <a:tailEnd type="none" w="med" len="med"/>
+                    </a:lnL>
+                    <a:lnR w="6350" cap="flat" cmpd="sng" algn="ctr">
+                      <a:solidFill>
+                        <a:srgbClr val="E5E0D8"/>
+                      </a:solidFill>
+                      <a:prstDash val="solid"/>
+                      <a:round/>
+                      <a:headEnd type="none" w="med" len="med"/>
+                      <a:tailEnd type="none" w="med" len="med"/>
+                    </a:lnR>
+                    <a:lnT w="6350" cap="flat" cmpd="sng" algn="ctr">
+                      <a:solidFill>
+                        <a:srgbClr val="E5E0D8"/>
+                      </a:solidFill>
+                      <a:prstDash val="solid"/>
+                      <a:round/>
+                      <a:headEnd type="none" w="med" len="med"/>
+                      <a:tailEnd type="none" w="med" len="med"/>
+                    </a:lnT>
+                    <a:lnB w="6350" cap="flat" cmpd="sng" algn="ctr">
+                      <a:solidFill>
+                        <a:srgbClr val="E5E0D8"/>
+                      </a:solidFill>
+                      <a:prstDash val="solid"/>
+                      <a:round/>
+                      <a:headEnd type="none" w="med" len="med"/>
+                      <a:tailEnd type="none" w="med" len="med"/>
+                    </a:lnB>
+                    <a:solidFill>
+                      <a:srgbClr val="FFFFFF"/>
+                    </a:solidFill>
+                  </a:tcPr>
+                </a:tc>
+                <a:tc>
+                  <a:txBody>
+                    <a:bodyPr/>
+                    <a:lstStyle/>
+                    <a:p>
+                      <a:pPr indent="0" marL="0">
+                        <a:buNone/>
+                      </a:pPr>
+                      <a:r>
+                        <a:rPr lang="en-US" sz="1350" dirty="0">
+                          <a:solidFill>
+                            <a:srgbClr val="1C1C19"/>
+                          </a:solidFill>
+                          <a:latin typeface="Inter" pitchFamily="34" charset="0"/>
+                          <a:ea typeface="Inter" pitchFamily="34" charset="-122"/>
+                          <a:cs typeface="Inter" pitchFamily="34" charset="-120"/>
+                        </a:rPr>
+                        <a:t>Legacy donation endpoint retained vs commercial markdown</a:t>
                       </a:r>
                       <a:endParaRPr lang="en-US" sz="1350" dirty="0">
                         <a:latin typeface="Inter" charset="0"/>
@@ -12209,7 +12209,7 @@
                           <a:ea typeface="Inter" pitchFamily="34" charset="-122"/>
                           <a:cs typeface="Inter" pitchFamily="34" charset="-120"/>
                         </a:rPr>
-                        <a:t>Open (DEF-011 State)</a:t>
+                        <a:t>Open (Documented V2 Backlog)</a:t>
                       </a:r>
                       <a:endParaRPr lang="en-US" sz="1350" dirty="0">
                         <a:latin typeface="Inter" charset="0"/>
@@ -12329,7 +12329,7 @@
                 <a:ea typeface="Inter" pitchFamily="34" charset="-122"/>
                 <a:cs typeface="Inter" pitchFamily="34" charset="-120"/>
               </a:rPr>
-              <a:t>Eleven defects logged across git history: nine resolved, two open.</a:t>
+              <a:t>Thirteen defects logged across git history: twelve resolved, one open.</a:t>
             </a:r>
             <a:endParaRPr lang="en-US" sz="2000" dirty="0"/>
           </a:p>
@@ -12353,7 +12353,7 @@
                 <a:ea typeface="Inter" pitchFamily="34" charset="-122"/>
                 <a:cs typeface="Inter" pitchFamily="34" charset="-120"/>
               </a:rPr>
-              <a:t>Two non-critical architectural findings remain openly tracked.</a:t>
+              <a:t>One non-critical architectural finding remains openly tracked (DEF-013).</a:t>
             </a:r>
             <a:endParaRPr lang="en-US" sz="2000" dirty="0"/>
           </a:p>

</xml_diff>